<commit_message>
Update presentation and document files with latest revisions
</commit_message>
<xml_diff>
--- a/bench inspection poster/Presentation2.pptx
+++ b/bench inspection poster/Presentation2.pptx
@@ -2,7 +2,7 @@
 <file path=ppt/presentation.xml><?xml version="1.0" encoding="utf-8"?>
 <p:presentation xmlns:a="http://schemas.openxmlformats.org/drawingml/2006/main" xmlns:r="http://schemas.openxmlformats.org/officeDocument/2006/relationships" xmlns:p="http://schemas.openxmlformats.org/presentationml/2006/main" saveSubsetFonts="1" autoCompressPictures="0">
   <p:sldMasterIdLst>
-    <p:sldMasterId id="2147483672" r:id="rId1"/>
+    <p:sldMasterId id="2147483684" r:id="rId1"/>
   </p:sldMasterIdLst>
   <p:notesMasterIdLst>
     <p:notesMasterId r:id="rId3"/>
@@ -10,7 +10,7 @@
   <p:sldIdLst>
     <p:sldId id="256" r:id="rId2"/>
   </p:sldIdLst>
-  <p:sldSz cx="30275213" cy="21420138"/>
+  <p:sldSz cx="21420138" cy="30275213"/>
   <p:notesSz cx="6858000" cy="9144000"/>
   <p:defaultTextStyle>
     <a:defPPr>
@@ -210,8 +210,8 @@
         </p:nvSpPr>
         <p:spPr>
           <a:xfrm>
-            <a:off x="1247775" y="1143000"/>
-            <a:ext cx="4362450" cy="3086100"/>
+            <a:off x="2336800" y="1143000"/>
+            <a:ext cx="2184400" cy="3086100"/>
           </a:xfrm>
           <a:prstGeom prst="rect">
             <a:avLst/>
@@ -487,7 +487,12 @@
             <p:ph type="sldImg"/>
           </p:nvPr>
         </p:nvSpPr>
-        <p:spPr/>
+        <p:spPr>
+          <a:xfrm>
+            <a:off x="2336800" y="1143000"/>
+            <a:ext cx="2184400" cy="3086100"/>
+          </a:xfrm>
+        </p:spPr>
       </p:sp>
       <p:sp>
         <p:nvSpPr>
@@ -573,15 +578,15 @@
         </p:nvSpPr>
         <p:spPr>
           <a:xfrm>
-            <a:off x="2270641" y="3505566"/>
-            <a:ext cx="25733931" cy="7457381"/>
+            <a:off x="1606511" y="4954765"/>
+            <a:ext cx="18207117" cy="10540259"/>
           </a:xfrm>
         </p:spPr>
         <p:txBody>
           <a:bodyPr anchor="b"/>
           <a:lstStyle>
             <a:lvl1pPr algn="ctr">
-              <a:defRPr sz="18740"/>
+              <a:defRPr sz="14055"/>
             </a:lvl1pPr>
           </a:lstStyle>
           <a:p>
@@ -605,8 +610,8 @@
         </p:nvSpPr>
         <p:spPr>
           <a:xfrm>
-            <a:off x="3784402" y="11250533"/>
-            <a:ext cx="22706410" cy="5171573"/>
+            <a:off x="2677517" y="15901497"/>
+            <a:ext cx="16065104" cy="7309499"/>
           </a:xfrm>
         </p:spPr>
         <p:txBody>
@@ -614,39 +619,39 @@
           <a:lstStyle>
             <a:lvl1pPr marL="0" indent="0" algn="ctr">
               <a:buNone/>
-              <a:defRPr sz="7496"/>
+              <a:defRPr sz="5622"/>
             </a:lvl1pPr>
-            <a:lvl2pPr marL="1428018" indent="0" algn="ctr">
+            <a:lvl2pPr marL="1070991" indent="0" algn="ctr">
               <a:buNone/>
-              <a:defRPr sz="6247"/>
+              <a:defRPr sz="4685"/>
             </a:lvl2pPr>
-            <a:lvl3pPr marL="2856037" indent="0" algn="ctr">
+            <a:lvl3pPr marL="2141982" indent="0" algn="ctr">
               <a:buNone/>
-              <a:defRPr sz="5622"/>
+              <a:defRPr sz="4217"/>
             </a:lvl3pPr>
-            <a:lvl4pPr marL="4284055" indent="0" algn="ctr">
+            <a:lvl4pPr marL="3212973" indent="0" algn="ctr">
               <a:buNone/>
-              <a:defRPr sz="4997"/>
+              <a:defRPr sz="3748"/>
             </a:lvl4pPr>
-            <a:lvl5pPr marL="5712074" indent="0" algn="ctr">
+            <a:lvl5pPr marL="4283964" indent="0" algn="ctr">
               <a:buNone/>
-              <a:defRPr sz="4997"/>
+              <a:defRPr sz="3748"/>
             </a:lvl5pPr>
-            <a:lvl6pPr marL="7140092" indent="0" algn="ctr">
+            <a:lvl6pPr marL="5354955" indent="0" algn="ctr">
               <a:buNone/>
-              <a:defRPr sz="4997"/>
+              <a:defRPr sz="3748"/>
             </a:lvl6pPr>
-            <a:lvl7pPr marL="8568111" indent="0" algn="ctr">
+            <a:lvl7pPr marL="6425946" indent="0" algn="ctr">
               <a:buNone/>
-              <a:defRPr sz="4997"/>
+              <a:defRPr sz="3748"/>
             </a:lvl7pPr>
-            <a:lvl8pPr marL="9996129" indent="0" algn="ctr">
+            <a:lvl8pPr marL="7496937" indent="0" algn="ctr">
               <a:buNone/>
-              <a:defRPr sz="4997"/>
+              <a:defRPr sz="3748"/>
             </a:lvl8pPr>
-            <a:lvl9pPr marL="11424148" indent="0" algn="ctr">
+            <a:lvl9pPr marL="8567928" indent="0" algn="ctr">
               <a:buNone/>
-              <a:defRPr sz="4997"/>
+              <a:defRPr sz="3748"/>
             </a:lvl9pPr>
           </a:lstStyle>
           <a:p>
@@ -726,7 +731,7 @@
     </p:spTree>
     <p:extLst>
       <p:ext uri="{BB962C8B-B14F-4D97-AF65-F5344CB8AC3E}">
-        <p14:creationId xmlns:p14="http://schemas.microsoft.com/office/powerpoint/2010/main" val="1028715814"/>
+        <p14:creationId xmlns:p14="http://schemas.microsoft.com/office/powerpoint/2010/main" val="1574146446"/>
       </p:ext>
     </p:extLst>
   </p:cSld>
@@ -896,7 +901,7 @@
     </p:spTree>
     <p:extLst>
       <p:ext uri="{BB962C8B-B14F-4D97-AF65-F5344CB8AC3E}">
-        <p14:creationId xmlns:p14="http://schemas.microsoft.com/office/powerpoint/2010/main" val="1676564498"/>
+        <p14:creationId xmlns:p14="http://schemas.microsoft.com/office/powerpoint/2010/main" val="3543684818"/>
       </p:ext>
     </p:extLst>
   </p:cSld>
@@ -935,8 +940,8 @@
         </p:nvSpPr>
         <p:spPr>
           <a:xfrm>
-            <a:off x="21665701" y="1140424"/>
-            <a:ext cx="6528093" cy="18152577"/>
+            <a:off x="15328788" y="1611875"/>
+            <a:ext cx="4618717" cy="25656844"/>
           </a:xfrm>
         </p:spPr>
         <p:txBody>
@@ -963,8 +968,8 @@
         </p:nvSpPr>
         <p:spPr>
           <a:xfrm>
-            <a:off x="2081423" y="1140424"/>
-            <a:ext cx="19205838" cy="18152577"/>
+            <a:off x="1472636" y="1611875"/>
+            <a:ext cx="13588400" cy="25656844"/>
           </a:xfrm>
         </p:spPr>
         <p:txBody>
@@ -1076,7 +1081,7 @@
     </p:spTree>
     <p:extLst>
       <p:ext uri="{BB962C8B-B14F-4D97-AF65-F5344CB8AC3E}">
-        <p14:creationId xmlns:p14="http://schemas.microsoft.com/office/powerpoint/2010/main" val="1394427734"/>
+        <p14:creationId xmlns:p14="http://schemas.microsoft.com/office/powerpoint/2010/main" val="2881905890"/>
       </p:ext>
     </p:extLst>
   </p:cSld>
@@ -1246,7 +1251,7 @@
     </p:spTree>
     <p:extLst>
       <p:ext uri="{BB962C8B-B14F-4D97-AF65-F5344CB8AC3E}">
-        <p14:creationId xmlns:p14="http://schemas.microsoft.com/office/powerpoint/2010/main" val="3658139099"/>
+        <p14:creationId xmlns:p14="http://schemas.microsoft.com/office/powerpoint/2010/main" val="641583493"/>
       </p:ext>
     </p:extLst>
   </p:cSld>
@@ -1285,15 +1290,15 @@
         </p:nvSpPr>
         <p:spPr>
           <a:xfrm>
-            <a:off x="2065654" y="5340166"/>
-            <a:ext cx="26112371" cy="8910181"/>
+            <a:off x="1461479" y="7547788"/>
+            <a:ext cx="18474869" cy="12593645"/>
           </a:xfrm>
         </p:spPr>
         <p:txBody>
           <a:bodyPr anchor="b"/>
           <a:lstStyle>
             <a:lvl1pPr>
-              <a:defRPr sz="18740"/>
+              <a:defRPr sz="14055"/>
             </a:lvl1pPr>
           </a:lstStyle>
           <a:p>
@@ -1317,34 +1322,14 @@
         </p:nvSpPr>
         <p:spPr>
           <a:xfrm>
-            <a:off x="2065654" y="14334640"/>
-            <a:ext cx="26112371" cy="4685654"/>
+            <a:off x="1461479" y="20260574"/>
+            <a:ext cx="18474869" cy="6622701"/>
           </a:xfrm>
         </p:spPr>
         <p:txBody>
           <a:bodyPr/>
           <a:lstStyle>
             <a:lvl1pPr marL="0" indent="0">
-              <a:buNone/>
-              <a:defRPr sz="7496">
-                <a:solidFill>
-                  <a:schemeClr val="tx1">
-                    <a:tint val="82000"/>
-                  </a:schemeClr>
-                </a:solidFill>
-              </a:defRPr>
-            </a:lvl1pPr>
-            <a:lvl2pPr marL="1428018" indent="0">
-              <a:buNone/>
-              <a:defRPr sz="6247">
-                <a:solidFill>
-                  <a:schemeClr val="tx1">
-                    <a:tint val="82000"/>
-                  </a:schemeClr>
-                </a:solidFill>
-              </a:defRPr>
-            </a:lvl2pPr>
-            <a:lvl3pPr marL="2856037" indent="0">
               <a:buNone/>
               <a:defRPr sz="5622">
                 <a:solidFill>
@@ -1353,10 +1338,30 @@
                   </a:schemeClr>
                 </a:solidFill>
               </a:defRPr>
+            </a:lvl1pPr>
+            <a:lvl2pPr marL="1070991" indent="0">
+              <a:buNone/>
+              <a:defRPr sz="4685">
+                <a:solidFill>
+                  <a:schemeClr val="tx1">
+                    <a:tint val="82000"/>
+                  </a:schemeClr>
+                </a:solidFill>
+              </a:defRPr>
+            </a:lvl2pPr>
+            <a:lvl3pPr marL="2141982" indent="0">
+              <a:buNone/>
+              <a:defRPr sz="4217">
+                <a:solidFill>
+                  <a:schemeClr val="tx1">
+                    <a:tint val="82000"/>
+                  </a:schemeClr>
+                </a:solidFill>
+              </a:defRPr>
             </a:lvl3pPr>
-            <a:lvl4pPr marL="4284055" indent="0">
+            <a:lvl4pPr marL="3212973" indent="0">
               <a:buNone/>
-              <a:defRPr sz="4997">
+              <a:defRPr sz="3748">
                 <a:solidFill>
                   <a:schemeClr val="tx1">
                     <a:tint val="82000"/>
@@ -1364,9 +1369,9 @@
                 </a:solidFill>
               </a:defRPr>
             </a:lvl4pPr>
-            <a:lvl5pPr marL="5712074" indent="0">
+            <a:lvl5pPr marL="4283964" indent="0">
               <a:buNone/>
-              <a:defRPr sz="4997">
+              <a:defRPr sz="3748">
                 <a:solidFill>
                   <a:schemeClr val="tx1">
                     <a:tint val="82000"/>
@@ -1374,9 +1379,9 @@
                 </a:solidFill>
               </a:defRPr>
             </a:lvl5pPr>
-            <a:lvl6pPr marL="7140092" indent="0">
+            <a:lvl6pPr marL="5354955" indent="0">
               <a:buNone/>
-              <a:defRPr sz="4997">
+              <a:defRPr sz="3748">
                 <a:solidFill>
                   <a:schemeClr val="tx1">
                     <a:tint val="82000"/>
@@ -1384,9 +1389,9 @@
                 </a:solidFill>
               </a:defRPr>
             </a:lvl6pPr>
-            <a:lvl7pPr marL="8568111" indent="0">
+            <a:lvl7pPr marL="6425946" indent="0">
               <a:buNone/>
-              <a:defRPr sz="4997">
+              <a:defRPr sz="3748">
                 <a:solidFill>
                   <a:schemeClr val="tx1">
                     <a:tint val="82000"/>
@@ -1394,9 +1399,9 @@
                 </a:solidFill>
               </a:defRPr>
             </a:lvl7pPr>
-            <a:lvl8pPr marL="9996129" indent="0">
+            <a:lvl8pPr marL="7496937" indent="0">
               <a:buNone/>
-              <a:defRPr sz="4997">
+              <a:defRPr sz="3748">
                 <a:solidFill>
                   <a:schemeClr val="tx1">
                     <a:tint val="82000"/>
@@ -1404,9 +1409,9 @@
                 </a:solidFill>
               </a:defRPr>
             </a:lvl8pPr>
-            <a:lvl9pPr marL="11424148" indent="0">
+            <a:lvl9pPr marL="8567928" indent="0">
               <a:buNone/>
-              <a:defRPr sz="4997">
+              <a:defRPr sz="3748">
                 <a:solidFill>
                   <a:schemeClr val="tx1">
                     <a:tint val="82000"/>
@@ -1492,7 +1497,7 @@
     </p:spTree>
     <p:extLst>
       <p:ext uri="{BB962C8B-B14F-4D97-AF65-F5344CB8AC3E}">
-        <p14:creationId xmlns:p14="http://schemas.microsoft.com/office/powerpoint/2010/main" val="1259963103"/>
+        <p14:creationId xmlns:p14="http://schemas.microsoft.com/office/powerpoint/2010/main" val="1289695686"/>
       </p:ext>
     </p:extLst>
   </p:cSld>
@@ -1554,8 +1559,8 @@
         </p:nvSpPr>
         <p:spPr>
           <a:xfrm>
-            <a:off x="2081421" y="5702120"/>
-            <a:ext cx="12866966" cy="13590881"/>
+            <a:off x="1472634" y="8059374"/>
+            <a:ext cx="9103559" cy="19209345"/>
           </a:xfrm>
         </p:spPr>
         <p:txBody>
@@ -1611,8 +1616,8 @@
         </p:nvSpPr>
         <p:spPr>
           <a:xfrm>
-            <a:off x="15326826" y="5702120"/>
-            <a:ext cx="12866966" cy="13590881"/>
+            <a:off x="10843945" y="8059374"/>
+            <a:ext cx="9103559" cy="19209345"/>
           </a:xfrm>
         </p:spPr>
         <p:txBody>
@@ -1724,7 +1729,7 @@
     </p:spTree>
     <p:extLst>
       <p:ext uri="{BB962C8B-B14F-4D97-AF65-F5344CB8AC3E}">
-        <p14:creationId xmlns:p14="http://schemas.microsoft.com/office/powerpoint/2010/main" val="1498554878"/>
+        <p14:creationId xmlns:p14="http://schemas.microsoft.com/office/powerpoint/2010/main" val="958861554"/>
       </p:ext>
     </p:extLst>
   </p:cSld>
@@ -1763,8 +1768,8 @@
         </p:nvSpPr>
         <p:spPr>
           <a:xfrm>
-            <a:off x="2085364" y="1140428"/>
-            <a:ext cx="26112371" cy="4140237"/>
+            <a:off x="1475424" y="1611882"/>
+            <a:ext cx="18474869" cy="5851808"/>
           </a:xfrm>
         </p:spPr>
         <p:txBody>
@@ -1791,8 +1796,8 @@
         </p:nvSpPr>
         <p:spPr>
           <a:xfrm>
-            <a:off x="2085368" y="5250910"/>
-            <a:ext cx="12807832" cy="2573390"/>
+            <a:off x="1475427" y="7421634"/>
+            <a:ext cx="9061721" cy="3637228"/>
           </a:xfrm>
         </p:spPr>
         <p:txBody>
@@ -1800,39 +1805,39 @@
           <a:lstStyle>
             <a:lvl1pPr marL="0" indent="0">
               <a:buNone/>
-              <a:defRPr sz="7496" b="1"/>
+              <a:defRPr sz="5622" b="1"/>
             </a:lvl1pPr>
-            <a:lvl2pPr marL="1428018" indent="0">
+            <a:lvl2pPr marL="1070991" indent="0">
               <a:buNone/>
-              <a:defRPr sz="6247" b="1"/>
+              <a:defRPr sz="4685" b="1"/>
             </a:lvl2pPr>
-            <a:lvl3pPr marL="2856037" indent="0">
+            <a:lvl3pPr marL="2141982" indent="0">
               <a:buNone/>
-              <a:defRPr sz="5622" b="1"/>
+              <a:defRPr sz="4217" b="1"/>
             </a:lvl3pPr>
-            <a:lvl4pPr marL="4284055" indent="0">
+            <a:lvl4pPr marL="3212973" indent="0">
               <a:buNone/>
-              <a:defRPr sz="4997" b="1"/>
+              <a:defRPr sz="3748" b="1"/>
             </a:lvl4pPr>
-            <a:lvl5pPr marL="5712074" indent="0">
+            <a:lvl5pPr marL="4283964" indent="0">
               <a:buNone/>
-              <a:defRPr sz="4997" b="1"/>
+              <a:defRPr sz="3748" b="1"/>
             </a:lvl5pPr>
-            <a:lvl6pPr marL="7140092" indent="0">
+            <a:lvl6pPr marL="5354955" indent="0">
               <a:buNone/>
-              <a:defRPr sz="4997" b="1"/>
+              <a:defRPr sz="3748" b="1"/>
             </a:lvl6pPr>
-            <a:lvl7pPr marL="8568111" indent="0">
+            <a:lvl7pPr marL="6425946" indent="0">
               <a:buNone/>
-              <a:defRPr sz="4997" b="1"/>
+              <a:defRPr sz="3748" b="1"/>
             </a:lvl7pPr>
-            <a:lvl8pPr marL="9996129" indent="0">
+            <a:lvl8pPr marL="7496937" indent="0">
               <a:buNone/>
-              <a:defRPr sz="4997" b="1"/>
+              <a:defRPr sz="3748" b="1"/>
             </a:lvl8pPr>
-            <a:lvl9pPr marL="11424148" indent="0">
+            <a:lvl9pPr marL="8567928" indent="0">
               <a:buNone/>
-              <a:defRPr sz="4997" b="1"/>
+              <a:defRPr sz="3748" b="1"/>
             </a:lvl9pPr>
           </a:lstStyle>
           <a:p>
@@ -1856,8 +1861,8 @@
         </p:nvSpPr>
         <p:spPr>
           <a:xfrm>
-            <a:off x="2085368" y="7824301"/>
-            <a:ext cx="12807832" cy="11508367"/>
+            <a:off x="1475427" y="11058863"/>
+            <a:ext cx="9061721" cy="16265921"/>
           </a:xfrm>
         </p:spPr>
         <p:txBody>
@@ -1913,8 +1918,8 @@
         </p:nvSpPr>
         <p:spPr>
           <a:xfrm>
-            <a:off x="15326828" y="5250910"/>
-            <a:ext cx="12870909" cy="2573390"/>
+            <a:off x="10843946" y="7421634"/>
+            <a:ext cx="9106349" cy="3637228"/>
           </a:xfrm>
         </p:spPr>
         <p:txBody>
@@ -1922,39 +1927,39 @@
           <a:lstStyle>
             <a:lvl1pPr marL="0" indent="0">
               <a:buNone/>
-              <a:defRPr sz="7496" b="1"/>
+              <a:defRPr sz="5622" b="1"/>
             </a:lvl1pPr>
-            <a:lvl2pPr marL="1428018" indent="0">
+            <a:lvl2pPr marL="1070991" indent="0">
               <a:buNone/>
-              <a:defRPr sz="6247" b="1"/>
+              <a:defRPr sz="4685" b="1"/>
             </a:lvl2pPr>
-            <a:lvl3pPr marL="2856037" indent="0">
+            <a:lvl3pPr marL="2141982" indent="0">
               <a:buNone/>
-              <a:defRPr sz="5622" b="1"/>
+              <a:defRPr sz="4217" b="1"/>
             </a:lvl3pPr>
-            <a:lvl4pPr marL="4284055" indent="0">
+            <a:lvl4pPr marL="3212973" indent="0">
               <a:buNone/>
-              <a:defRPr sz="4997" b="1"/>
+              <a:defRPr sz="3748" b="1"/>
             </a:lvl4pPr>
-            <a:lvl5pPr marL="5712074" indent="0">
+            <a:lvl5pPr marL="4283964" indent="0">
               <a:buNone/>
-              <a:defRPr sz="4997" b="1"/>
+              <a:defRPr sz="3748" b="1"/>
             </a:lvl5pPr>
-            <a:lvl6pPr marL="7140092" indent="0">
+            <a:lvl6pPr marL="5354955" indent="0">
               <a:buNone/>
-              <a:defRPr sz="4997" b="1"/>
+              <a:defRPr sz="3748" b="1"/>
             </a:lvl6pPr>
-            <a:lvl7pPr marL="8568111" indent="0">
+            <a:lvl7pPr marL="6425946" indent="0">
               <a:buNone/>
-              <a:defRPr sz="4997" b="1"/>
+              <a:defRPr sz="3748" b="1"/>
             </a:lvl7pPr>
-            <a:lvl8pPr marL="9996129" indent="0">
+            <a:lvl8pPr marL="7496937" indent="0">
               <a:buNone/>
-              <a:defRPr sz="4997" b="1"/>
+              <a:defRPr sz="3748" b="1"/>
             </a:lvl8pPr>
-            <a:lvl9pPr marL="11424148" indent="0">
+            <a:lvl9pPr marL="8567928" indent="0">
               <a:buNone/>
-              <a:defRPr sz="4997" b="1"/>
+              <a:defRPr sz="3748" b="1"/>
             </a:lvl9pPr>
           </a:lstStyle>
           <a:p>
@@ -1978,8 +1983,8 @@
         </p:nvSpPr>
         <p:spPr>
           <a:xfrm>
-            <a:off x="15326828" y="7824301"/>
-            <a:ext cx="12870909" cy="11508367"/>
+            <a:off x="10843946" y="11058863"/>
+            <a:ext cx="9106349" cy="16265921"/>
           </a:xfrm>
         </p:spPr>
         <p:txBody>
@@ -2091,7 +2096,7 @@
     </p:spTree>
     <p:extLst>
       <p:ext uri="{BB962C8B-B14F-4D97-AF65-F5344CB8AC3E}">
-        <p14:creationId xmlns:p14="http://schemas.microsoft.com/office/powerpoint/2010/main" val="3186938250"/>
+        <p14:creationId xmlns:p14="http://schemas.microsoft.com/office/powerpoint/2010/main" val="3901044009"/>
       </p:ext>
     </p:extLst>
   </p:cSld>
@@ -2209,7 +2214,7 @@
     </p:spTree>
     <p:extLst>
       <p:ext uri="{BB962C8B-B14F-4D97-AF65-F5344CB8AC3E}">
-        <p14:creationId xmlns:p14="http://schemas.microsoft.com/office/powerpoint/2010/main" val="3014833675"/>
+        <p14:creationId xmlns:p14="http://schemas.microsoft.com/office/powerpoint/2010/main" val="3063416633"/>
       </p:ext>
     </p:extLst>
   </p:cSld>
@@ -2304,7 +2309,7 @@
     </p:spTree>
     <p:extLst>
       <p:ext uri="{BB962C8B-B14F-4D97-AF65-F5344CB8AC3E}">
-        <p14:creationId xmlns:p14="http://schemas.microsoft.com/office/powerpoint/2010/main" val="1822192122"/>
+        <p14:creationId xmlns:p14="http://schemas.microsoft.com/office/powerpoint/2010/main" val="1079583130"/>
       </p:ext>
     </p:extLst>
   </p:cSld>
@@ -2343,15 +2348,15 @@
         </p:nvSpPr>
         <p:spPr>
           <a:xfrm>
-            <a:off x="2085364" y="1428009"/>
-            <a:ext cx="9764544" cy="4998032"/>
+            <a:off x="1475424" y="2018348"/>
+            <a:ext cx="6908552" cy="7064216"/>
           </a:xfrm>
         </p:spPr>
         <p:txBody>
           <a:bodyPr anchor="b"/>
           <a:lstStyle>
             <a:lvl1pPr>
-              <a:defRPr sz="9995"/>
+              <a:defRPr sz="7496"/>
             </a:lvl1pPr>
           </a:lstStyle>
           <a:p>
@@ -2375,39 +2380,39 @@
         </p:nvSpPr>
         <p:spPr>
           <a:xfrm>
-            <a:off x="12870909" y="3084108"/>
-            <a:ext cx="15326827" cy="15222181"/>
+            <a:off x="9106349" y="4359077"/>
+            <a:ext cx="10843945" cy="21515024"/>
           </a:xfrm>
         </p:spPr>
         <p:txBody>
           <a:bodyPr/>
           <a:lstStyle>
             <a:lvl1pPr>
-              <a:defRPr sz="9995"/>
+              <a:defRPr sz="7496"/>
             </a:lvl1pPr>
             <a:lvl2pPr>
-              <a:defRPr sz="8746"/>
+              <a:defRPr sz="6559"/>
             </a:lvl2pPr>
             <a:lvl3pPr>
-              <a:defRPr sz="7496"/>
+              <a:defRPr sz="5622"/>
             </a:lvl3pPr>
             <a:lvl4pPr>
-              <a:defRPr sz="6247"/>
+              <a:defRPr sz="4685"/>
             </a:lvl4pPr>
             <a:lvl5pPr>
-              <a:defRPr sz="6247"/>
+              <a:defRPr sz="4685"/>
             </a:lvl5pPr>
             <a:lvl6pPr>
-              <a:defRPr sz="6247"/>
+              <a:defRPr sz="4685"/>
             </a:lvl6pPr>
             <a:lvl7pPr>
-              <a:defRPr sz="6247"/>
+              <a:defRPr sz="4685"/>
             </a:lvl7pPr>
             <a:lvl8pPr>
-              <a:defRPr sz="6247"/>
+              <a:defRPr sz="4685"/>
             </a:lvl8pPr>
             <a:lvl9pPr>
-              <a:defRPr sz="6247"/>
+              <a:defRPr sz="4685"/>
             </a:lvl9pPr>
           </a:lstStyle>
           <a:p>
@@ -2460,8 +2465,8 @@
         </p:nvSpPr>
         <p:spPr>
           <a:xfrm>
-            <a:off x="2085364" y="6426041"/>
-            <a:ext cx="9764544" cy="11905037"/>
+            <a:off x="1475424" y="9082564"/>
+            <a:ext cx="6908552" cy="16826573"/>
           </a:xfrm>
         </p:spPr>
         <p:txBody>
@@ -2469,39 +2474,39 @@
           <a:lstStyle>
             <a:lvl1pPr marL="0" indent="0">
               <a:buNone/>
-              <a:defRPr sz="4997"/>
+              <a:defRPr sz="3748"/>
             </a:lvl1pPr>
-            <a:lvl2pPr marL="1428018" indent="0">
+            <a:lvl2pPr marL="1070991" indent="0">
               <a:buNone/>
-              <a:defRPr sz="4373"/>
+              <a:defRPr sz="3280"/>
             </a:lvl2pPr>
-            <a:lvl3pPr marL="2856037" indent="0">
+            <a:lvl3pPr marL="2141982" indent="0">
               <a:buNone/>
-              <a:defRPr sz="3748"/>
+              <a:defRPr sz="2811"/>
             </a:lvl3pPr>
-            <a:lvl4pPr marL="4284055" indent="0">
+            <a:lvl4pPr marL="3212973" indent="0">
               <a:buNone/>
-              <a:defRPr sz="3123"/>
+              <a:defRPr sz="2343"/>
             </a:lvl4pPr>
-            <a:lvl5pPr marL="5712074" indent="0">
+            <a:lvl5pPr marL="4283964" indent="0">
               <a:buNone/>
-              <a:defRPr sz="3123"/>
+              <a:defRPr sz="2343"/>
             </a:lvl5pPr>
-            <a:lvl6pPr marL="7140092" indent="0">
+            <a:lvl6pPr marL="5354955" indent="0">
               <a:buNone/>
-              <a:defRPr sz="3123"/>
+              <a:defRPr sz="2343"/>
             </a:lvl6pPr>
-            <a:lvl7pPr marL="8568111" indent="0">
+            <a:lvl7pPr marL="6425946" indent="0">
               <a:buNone/>
-              <a:defRPr sz="3123"/>
+              <a:defRPr sz="2343"/>
             </a:lvl7pPr>
-            <a:lvl8pPr marL="9996129" indent="0">
+            <a:lvl8pPr marL="7496937" indent="0">
               <a:buNone/>
-              <a:defRPr sz="3123"/>
+              <a:defRPr sz="2343"/>
             </a:lvl8pPr>
-            <a:lvl9pPr marL="11424148" indent="0">
+            <a:lvl9pPr marL="8567928" indent="0">
               <a:buNone/>
-              <a:defRPr sz="3123"/>
+              <a:defRPr sz="2343"/>
             </a:lvl9pPr>
           </a:lstStyle>
           <a:p>
@@ -2581,7 +2586,7 @@
     </p:spTree>
     <p:extLst>
       <p:ext uri="{BB962C8B-B14F-4D97-AF65-F5344CB8AC3E}">
-        <p14:creationId xmlns:p14="http://schemas.microsoft.com/office/powerpoint/2010/main" val="4070421855"/>
+        <p14:creationId xmlns:p14="http://schemas.microsoft.com/office/powerpoint/2010/main" val="3043638493"/>
       </p:ext>
     </p:extLst>
   </p:cSld>
@@ -2620,15 +2625,15 @@
         </p:nvSpPr>
         <p:spPr>
           <a:xfrm>
-            <a:off x="2085364" y="1428009"/>
-            <a:ext cx="9764544" cy="4998032"/>
+            <a:off x="1475424" y="2018348"/>
+            <a:ext cx="6908552" cy="7064216"/>
           </a:xfrm>
         </p:spPr>
         <p:txBody>
           <a:bodyPr anchor="b"/>
           <a:lstStyle>
             <a:lvl1pPr>
-              <a:defRPr sz="9995"/>
+              <a:defRPr sz="7496"/>
             </a:lvl1pPr>
           </a:lstStyle>
           <a:p>
@@ -2652,8 +2657,8 @@
         </p:nvSpPr>
         <p:spPr>
           <a:xfrm>
-            <a:off x="12870909" y="3084108"/>
-            <a:ext cx="15326827" cy="15222181"/>
+            <a:off x="9106349" y="4359077"/>
+            <a:ext cx="10843945" cy="21515024"/>
           </a:xfrm>
         </p:spPr>
         <p:txBody>
@@ -2661,39 +2666,39 @@
           <a:lstStyle>
             <a:lvl1pPr marL="0" indent="0">
               <a:buNone/>
-              <a:defRPr sz="9995"/>
+              <a:defRPr sz="7496"/>
             </a:lvl1pPr>
-            <a:lvl2pPr marL="1428018" indent="0">
+            <a:lvl2pPr marL="1070991" indent="0">
               <a:buNone/>
-              <a:defRPr sz="8746"/>
+              <a:defRPr sz="6559"/>
             </a:lvl2pPr>
-            <a:lvl3pPr marL="2856037" indent="0">
+            <a:lvl3pPr marL="2141982" indent="0">
               <a:buNone/>
-              <a:defRPr sz="7496"/>
+              <a:defRPr sz="5622"/>
             </a:lvl3pPr>
-            <a:lvl4pPr marL="4284055" indent="0">
+            <a:lvl4pPr marL="3212973" indent="0">
               <a:buNone/>
-              <a:defRPr sz="6247"/>
+              <a:defRPr sz="4685"/>
             </a:lvl4pPr>
-            <a:lvl5pPr marL="5712074" indent="0">
+            <a:lvl5pPr marL="4283964" indent="0">
               <a:buNone/>
-              <a:defRPr sz="6247"/>
+              <a:defRPr sz="4685"/>
             </a:lvl5pPr>
-            <a:lvl6pPr marL="7140092" indent="0">
+            <a:lvl6pPr marL="5354955" indent="0">
               <a:buNone/>
-              <a:defRPr sz="6247"/>
+              <a:defRPr sz="4685"/>
             </a:lvl6pPr>
-            <a:lvl7pPr marL="8568111" indent="0">
+            <a:lvl7pPr marL="6425946" indent="0">
               <a:buNone/>
-              <a:defRPr sz="6247"/>
+              <a:defRPr sz="4685"/>
             </a:lvl7pPr>
-            <a:lvl8pPr marL="9996129" indent="0">
+            <a:lvl8pPr marL="7496937" indent="0">
               <a:buNone/>
-              <a:defRPr sz="6247"/>
+              <a:defRPr sz="4685"/>
             </a:lvl8pPr>
-            <a:lvl9pPr marL="11424148" indent="0">
+            <a:lvl9pPr marL="8567928" indent="0">
               <a:buNone/>
-              <a:defRPr sz="6247"/>
+              <a:defRPr sz="4685"/>
             </a:lvl9pPr>
           </a:lstStyle>
           <a:p>
@@ -2717,8 +2722,8 @@
         </p:nvSpPr>
         <p:spPr>
           <a:xfrm>
-            <a:off x="2085364" y="6426041"/>
-            <a:ext cx="9764544" cy="11905037"/>
+            <a:off x="1475424" y="9082564"/>
+            <a:ext cx="6908552" cy="16826573"/>
           </a:xfrm>
         </p:spPr>
         <p:txBody>
@@ -2726,39 +2731,39 @@
           <a:lstStyle>
             <a:lvl1pPr marL="0" indent="0">
               <a:buNone/>
-              <a:defRPr sz="4997"/>
+              <a:defRPr sz="3748"/>
             </a:lvl1pPr>
-            <a:lvl2pPr marL="1428018" indent="0">
+            <a:lvl2pPr marL="1070991" indent="0">
               <a:buNone/>
-              <a:defRPr sz="4373"/>
+              <a:defRPr sz="3280"/>
             </a:lvl2pPr>
-            <a:lvl3pPr marL="2856037" indent="0">
+            <a:lvl3pPr marL="2141982" indent="0">
               <a:buNone/>
-              <a:defRPr sz="3748"/>
+              <a:defRPr sz="2811"/>
             </a:lvl3pPr>
-            <a:lvl4pPr marL="4284055" indent="0">
+            <a:lvl4pPr marL="3212973" indent="0">
               <a:buNone/>
-              <a:defRPr sz="3123"/>
+              <a:defRPr sz="2343"/>
             </a:lvl4pPr>
-            <a:lvl5pPr marL="5712074" indent="0">
+            <a:lvl5pPr marL="4283964" indent="0">
               <a:buNone/>
-              <a:defRPr sz="3123"/>
+              <a:defRPr sz="2343"/>
             </a:lvl5pPr>
-            <a:lvl6pPr marL="7140092" indent="0">
+            <a:lvl6pPr marL="5354955" indent="0">
               <a:buNone/>
-              <a:defRPr sz="3123"/>
+              <a:defRPr sz="2343"/>
             </a:lvl6pPr>
-            <a:lvl7pPr marL="8568111" indent="0">
+            <a:lvl7pPr marL="6425946" indent="0">
               <a:buNone/>
-              <a:defRPr sz="3123"/>
+              <a:defRPr sz="2343"/>
             </a:lvl7pPr>
-            <a:lvl8pPr marL="9996129" indent="0">
+            <a:lvl8pPr marL="7496937" indent="0">
               <a:buNone/>
-              <a:defRPr sz="3123"/>
+              <a:defRPr sz="2343"/>
             </a:lvl8pPr>
-            <a:lvl9pPr marL="11424148" indent="0">
+            <a:lvl9pPr marL="8567928" indent="0">
               <a:buNone/>
-              <a:defRPr sz="3123"/>
+              <a:defRPr sz="2343"/>
             </a:lvl9pPr>
           </a:lstStyle>
           <a:p>
@@ -2838,7 +2843,7 @@
     </p:spTree>
     <p:extLst>
       <p:ext uri="{BB962C8B-B14F-4D97-AF65-F5344CB8AC3E}">
-        <p14:creationId xmlns:p14="http://schemas.microsoft.com/office/powerpoint/2010/main" val="316161268"/>
+        <p14:creationId xmlns:p14="http://schemas.microsoft.com/office/powerpoint/2010/main" val="3402424829"/>
       </p:ext>
     </p:extLst>
   </p:cSld>
@@ -2882,8 +2887,8 @@
         </p:nvSpPr>
         <p:spPr>
           <a:xfrm>
-            <a:off x="2081421" y="1140428"/>
-            <a:ext cx="26112371" cy="4140237"/>
+            <a:off x="1472635" y="1611882"/>
+            <a:ext cx="18474869" cy="5851808"/>
           </a:xfrm>
           <a:prstGeom prst="rect">
             <a:avLst/>
@@ -2915,8 +2920,8 @@
         </p:nvSpPr>
         <p:spPr>
           <a:xfrm>
-            <a:off x="2081421" y="5702120"/>
-            <a:ext cx="26112371" cy="13590881"/>
+            <a:off x="1472635" y="8059374"/>
+            <a:ext cx="18474869" cy="19209345"/>
           </a:xfrm>
           <a:prstGeom prst="rect">
             <a:avLst/>
@@ -2977,8 +2982,8 @@
         </p:nvSpPr>
         <p:spPr>
           <a:xfrm>
-            <a:off x="2081421" y="19853299"/>
-            <a:ext cx="6811923" cy="1140424"/>
+            <a:off x="1472635" y="28060644"/>
+            <a:ext cx="4819531" cy="1611875"/>
           </a:xfrm>
           <a:prstGeom prst="rect">
             <a:avLst/>
@@ -2988,7 +2993,7 @@
           <a:bodyPr vert="horz" lIns="91440" tIns="45720" rIns="91440" bIns="45720" rtlCol="0" anchor="ctr"/>
           <a:lstStyle>
             <a:lvl1pPr algn="l">
-              <a:defRPr sz="3748">
+              <a:defRPr sz="2811">
                 <a:solidFill>
                   <a:schemeClr val="tx1">
                     <a:tint val="82000"/>
@@ -3018,8 +3023,8 @@
         </p:nvSpPr>
         <p:spPr>
           <a:xfrm>
-            <a:off x="10028665" y="19853299"/>
-            <a:ext cx="10217884" cy="1140424"/>
+            <a:off x="7095421" y="28060644"/>
+            <a:ext cx="7229297" cy="1611875"/>
           </a:xfrm>
           <a:prstGeom prst="rect">
             <a:avLst/>
@@ -3029,7 +3034,7 @@
           <a:bodyPr vert="horz" lIns="91440" tIns="45720" rIns="91440" bIns="45720" rtlCol="0" anchor="ctr"/>
           <a:lstStyle>
             <a:lvl1pPr algn="ctr">
-              <a:defRPr sz="3748">
+              <a:defRPr sz="2811">
                 <a:solidFill>
                   <a:schemeClr val="tx1">
                     <a:tint val="82000"/>
@@ -3055,8 +3060,8 @@
         </p:nvSpPr>
         <p:spPr>
           <a:xfrm>
-            <a:off x="21381869" y="19853299"/>
-            <a:ext cx="6811923" cy="1140424"/>
+            <a:off x="15127972" y="28060644"/>
+            <a:ext cx="4819531" cy="1611875"/>
           </a:xfrm>
           <a:prstGeom prst="rect">
             <a:avLst/>
@@ -3066,7 +3071,7 @@
           <a:bodyPr vert="horz" lIns="91440" tIns="45720" rIns="91440" bIns="45720" rtlCol="0" anchor="ctr"/>
           <a:lstStyle>
             <a:lvl1pPr algn="r">
-              <a:defRPr sz="3748">
+              <a:defRPr sz="2811">
                 <a:solidFill>
                   <a:schemeClr val="tx1">
                     <a:tint val="82000"/>
@@ -3087,27 +3092,27 @@
     </p:spTree>
     <p:extLst>
       <p:ext uri="{BB962C8B-B14F-4D97-AF65-F5344CB8AC3E}">
-        <p14:creationId xmlns:p14="http://schemas.microsoft.com/office/powerpoint/2010/main" val="751722466"/>
+        <p14:creationId xmlns:p14="http://schemas.microsoft.com/office/powerpoint/2010/main" val="2113318962"/>
       </p:ext>
     </p:extLst>
   </p:cSld>
   <p:clrMap bg1="lt1" tx1="dk1" bg2="lt2" tx2="dk2" accent1="accent1" accent2="accent2" accent3="accent3" accent4="accent4" accent5="accent5" accent6="accent6" hlink="hlink" folHlink="folHlink"/>
   <p:sldLayoutIdLst>
-    <p:sldLayoutId id="2147483673" r:id="rId1"/>
-    <p:sldLayoutId id="2147483674" r:id="rId2"/>
-    <p:sldLayoutId id="2147483675" r:id="rId3"/>
-    <p:sldLayoutId id="2147483676" r:id="rId4"/>
-    <p:sldLayoutId id="2147483677" r:id="rId5"/>
-    <p:sldLayoutId id="2147483678" r:id="rId6"/>
-    <p:sldLayoutId id="2147483679" r:id="rId7"/>
-    <p:sldLayoutId id="2147483680" r:id="rId8"/>
-    <p:sldLayoutId id="2147483681" r:id="rId9"/>
-    <p:sldLayoutId id="2147483682" r:id="rId10"/>
-    <p:sldLayoutId id="2147483683" r:id="rId11"/>
+    <p:sldLayoutId id="2147483685" r:id="rId1"/>
+    <p:sldLayoutId id="2147483686" r:id="rId2"/>
+    <p:sldLayoutId id="2147483687" r:id="rId3"/>
+    <p:sldLayoutId id="2147483688" r:id="rId4"/>
+    <p:sldLayoutId id="2147483689" r:id="rId5"/>
+    <p:sldLayoutId id="2147483690" r:id="rId6"/>
+    <p:sldLayoutId id="2147483691" r:id="rId7"/>
+    <p:sldLayoutId id="2147483692" r:id="rId8"/>
+    <p:sldLayoutId id="2147483693" r:id="rId9"/>
+    <p:sldLayoutId id="2147483694" r:id="rId10"/>
+    <p:sldLayoutId id="2147483695" r:id="rId11"/>
   </p:sldLayoutIdLst>
   <p:txStyles>
     <p:titleStyle>
-      <a:lvl1pPr algn="l" defTabSz="2856037" rtl="0" eaLnBrk="1" latinLnBrk="0" hangingPunct="1">
+      <a:lvl1pPr algn="l" defTabSz="2141982" rtl="0" eaLnBrk="1" latinLnBrk="0" hangingPunct="1">
         <a:lnSpc>
           <a:spcPct val="90000"/>
         </a:lnSpc>
@@ -3115,7 +3120,7 @@
           <a:spcPct val="0"/>
         </a:spcBef>
         <a:buNone/>
-        <a:defRPr sz="13743" kern="1200">
+        <a:defRPr sz="10307" kern="1200">
           <a:solidFill>
             <a:schemeClr val="tx1"/>
           </a:solidFill>
@@ -3126,16 +3131,16 @@
       </a:lvl1pPr>
     </p:titleStyle>
     <p:bodyStyle>
-      <a:lvl1pPr marL="714009" indent="-714009" algn="l" defTabSz="2856037" rtl="0" eaLnBrk="1" latinLnBrk="0" hangingPunct="1">
+      <a:lvl1pPr marL="535496" indent="-535496" algn="l" defTabSz="2141982" rtl="0" eaLnBrk="1" latinLnBrk="0" hangingPunct="1">
         <a:lnSpc>
           <a:spcPct val="90000"/>
         </a:lnSpc>
         <a:spcBef>
-          <a:spcPts val="3123"/>
+          <a:spcPts val="2343"/>
         </a:spcBef>
         <a:buFont typeface="Arial" panose="020B0604020202020204" pitchFamily="34" charset="0"/>
         <a:buChar char="•"/>
-        <a:defRPr sz="8746" kern="1200">
+        <a:defRPr sz="6559" kern="1200">
           <a:solidFill>
             <a:schemeClr val="tx1"/>
           </a:solidFill>
@@ -3144,48 +3149,12 @@
           <a:cs typeface="+mn-cs"/>
         </a:defRPr>
       </a:lvl1pPr>
-      <a:lvl2pPr marL="2142028" indent="-714009" algn="l" defTabSz="2856037" rtl="0" eaLnBrk="1" latinLnBrk="0" hangingPunct="1">
+      <a:lvl2pPr marL="1606487" indent="-535496" algn="l" defTabSz="2141982" rtl="0" eaLnBrk="1" latinLnBrk="0" hangingPunct="1">
         <a:lnSpc>
           <a:spcPct val="90000"/>
         </a:lnSpc>
         <a:spcBef>
-          <a:spcPts val="1562"/>
-        </a:spcBef>
-        <a:buFont typeface="Arial" panose="020B0604020202020204" pitchFamily="34" charset="0"/>
-        <a:buChar char="•"/>
-        <a:defRPr sz="7496" kern="1200">
-          <a:solidFill>
-            <a:schemeClr val="tx1"/>
-          </a:solidFill>
-          <a:latin typeface="+mn-lt"/>
-          <a:ea typeface="+mn-ea"/>
-          <a:cs typeface="+mn-cs"/>
-        </a:defRPr>
-      </a:lvl2pPr>
-      <a:lvl3pPr marL="3570046" indent="-714009" algn="l" defTabSz="2856037" rtl="0" eaLnBrk="1" latinLnBrk="0" hangingPunct="1">
-        <a:lnSpc>
-          <a:spcPct val="90000"/>
-        </a:lnSpc>
-        <a:spcBef>
-          <a:spcPts val="1562"/>
-        </a:spcBef>
-        <a:buFont typeface="Arial" panose="020B0604020202020204" pitchFamily="34" charset="0"/>
-        <a:buChar char="•"/>
-        <a:defRPr sz="6247" kern="1200">
-          <a:solidFill>
-            <a:schemeClr val="tx1"/>
-          </a:solidFill>
-          <a:latin typeface="+mn-lt"/>
-          <a:ea typeface="+mn-ea"/>
-          <a:cs typeface="+mn-cs"/>
-        </a:defRPr>
-      </a:lvl3pPr>
-      <a:lvl4pPr marL="4998065" indent="-714009" algn="l" defTabSz="2856037" rtl="0" eaLnBrk="1" latinLnBrk="0" hangingPunct="1">
-        <a:lnSpc>
-          <a:spcPct val="90000"/>
-        </a:lnSpc>
-        <a:spcBef>
-          <a:spcPts val="1562"/>
+          <a:spcPts val="1171"/>
         </a:spcBef>
         <a:buFont typeface="Arial" panose="020B0604020202020204" pitchFamily="34" charset="0"/>
         <a:buChar char="•"/>
@@ -3197,17 +3166,53 @@
           <a:ea typeface="+mn-ea"/>
           <a:cs typeface="+mn-cs"/>
         </a:defRPr>
-      </a:lvl4pPr>
-      <a:lvl5pPr marL="6426083" indent="-714009" algn="l" defTabSz="2856037" rtl="0" eaLnBrk="1" latinLnBrk="0" hangingPunct="1">
+      </a:lvl2pPr>
+      <a:lvl3pPr marL="2677478" indent="-535496" algn="l" defTabSz="2141982" rtl="0" eaLnBrk="1" latinLnBrk="0" hangingPunct="1">
         <a:lnSpc>
           <a:spcPct val="90000"/>
         </a:lnSpc>
         <a:spcBef>
-          <a:spcPts val="1562"/>
+          <a:spcPts val="1171"/>
         </a:spcBef>
         <a:buFont typeface="Arial" panose="020B0604020202020204" pitchFamily="34" charset="0"/>
         <a:buChar char="•"/>
-        <a:defRPr sz="5622" kern="1200">
+        <a:defRPr sz="4685" kern="1200">
+          <a:solidFill>
+            <a:schemeClr val="tx1"/>
+          </a:solidFill>
+          <a:latin typeface="+mn-lt"/>
+          <a:ea typeface="+mn-ea"/>
+          <a:cs typeface="+mn-cs"/>
+        </a:defRPr>
+      </a:lvl3pPr>
+      <a:lvl4pPr marL="3748469" indent="-535496" algn="l" defTabSz="2141982" rtl="0" eaLnBrk="1" latinLnBrk="0" hangingPunct="1">
+        <a:lnSpc>
+          <a:spcPct val="90000"/>
+        </a:lnSpc>
+        <a:spcBef>
+          <a:spcPts val="1171"/>
+        </a:spcBef>
+        <a:buFont typeface="Arial" panose="020B0604020202020204" pitchFamily="34" charset="0"/>
+        <a:buChar char="•"/>
+        <a:defRPr sz="4217" kern="1200">
+          <a:solidFill>
+            <a:schemeClr val="tx1"/>
+          </a:solidFill>
+          <a:latin typeface="+mn-lt"/>
+          <a:ea typeface="+mn-ea"/>
+          <a:cs typeface="+mn-cs"/>
+        </a:defRPr>
+      </a:lvl4pPr>
+      <a:lvl5pPr marL="4819460" indent="-535496" algn="l" defTabSz="2141982" rtl="0" eaLnBrk="1" latinLnBrk="0" hangingPunct="1">
+        <a:lnSpc>
+          <a:spcPct val="90000"/>
+        </a:lnSpc>
+        <a:spcBef>
+          <a:spcPts val="1171"/>
+        </a:spcBef>
+        <a:buFont typeface="Arial" panose="020B0604020202020204" pitchFamily="34" charset="0"/>
+        <a:buChar char="•"/>
+        <a:defRPr sz="4217" kern="1200">
           <a:solidFill>
             <a:schemeClr val="tx1"/>
           </a:solidFill>
@@ -3216,16 +3221,16 @@
           <a:cs typeface="+mn-cs"/>
         </a:defRPr>
       </a:lvl5pPr>
-      <a:lvl6pPr marL="7854102" indent="-714009" algn="l" defTabSz="2856037" rtl="0" eaLnBrk="1" latinLnBrk="0" hangingPunct="1">
+      <a:lvl6pPr marL="5890451" indent="-535496" algn="l" defTabSz="2141982" rtl="0" eaLnBrk="1" latinLnBrk="0" hangingPunct="1">
         <a:lnSpc>
           <a:spcPct val="90000"/>
         </a:lnSpc>
         <a:spcBef>
-          <a:spcPts val="1562"/>
+          <a:spcPts val="1171"/>
         </a:spcBef>
         <a:buFont typeface="Arial" panose="020B0604020202020204" pitchFamily="34" charset="0"/>
         <a:buChar char="•"/>
-        <a:defRPr sz="5622" kern="1200">
+        <a:defRPr sz="4217" kern="1200">
           <a:solidFill>
             <a:schemeClr val="tx1"/>
           </a:solidFill>
@@ -3234,16 +3239,16 @@
           <a:cs typeface="+mn-cs"/>
         </a:defRPr>
       </a:lvl6pPr>
-      <a:lvl7pPr marL="9282120" indent="-714009" algn="l" defTabSz="2856037" rtl="0" eaLnBrk="1" latinLnBrk="0" hangingPunct="1">
+      <a:lvl7pPr marL="6961442" indent="-535496" algn="l" defTabSz="2141982" rtl="0" eaLnBrk="1" latinLnBrk="0" hangingPunct="1">
         <a:lnSpc>
           <a:spcPct val="90000"/>
         </a:lnSpc>
         <a:spcBef>
-          <a:spcPts val="1562"/>
+          <a:spcPts val="1171"/>
         </a:spcBef>
         <a:buFont typeface="Arial" panose="020B0604020202020204" pitchFamily="34" charset="0"/>
         <a:buChar char="•"/>
-        <a:defRPr sz="5622" kern="1200">
+        <a:defRPr sz="4217" kern="1200">
           <a:solidFill>
             <a:schemeClr val="tx1"/>
           </a:solidFill>
@@ -3252,16 +3257,16 @@
           <a:cs typeface="+mn-cs"/>
         </a:defRPr>
       </a:lvl7pPr>
-      <a:lvl8pPr marL="10710139" indent="-714009" algn="l" defTabSz="2856037" rtl="0" eaLnBrk="1" latinLnBrk="0" hangingPunct="1">
+      <a:lvl8pPr marL="8032433" indent="-535496" algn="l" defTabSz="2141982" rtl="0" eaLnBrk="1" latinLnBrk="0" hangingPunct="1">
         <a:lnSpc>
           <a:spcPct val="90000"/>
         </a:lnSpc>
         <a:spcBef>
-          <a:spcPts val="1562"/>
+          <a:spcPts val="1171"/>
         </a:spcBef>
         <a:buFont typeface="Arial" panose="020B0604020202020204" pitchFamily="34" charset="0"/>
         <a:buChar char="•"/>
-        <a:defRPr sz="5622" kern="1200">
+        <a:defRPr sz="4217" kern="1200">
           <a:solidFill>
             <a:schemeClr val="tx1"/>
           </a:solidFill>
@@ -3270,16 +3275,16 @@
           <a:cs typeface="+mn-cs"/>
         </a:defRPr>
       </a:lvl8pPr>
-      <a:lvl9pPr marL="12138157" indent="-714009" algn="l" defTabSz="2856037" rtl="0" eaLnBrk="1" latinLnBrk="0" hangingPunct="1">
+      <a:lvl9pPr marL="9103424" indent="-535496" algn="l" defTabSz="2141982" rtl="0" eaLnBrk="1" latinLnBrk="0" hangingPunct="1">
         <a:lnSpc>
           <a:spcPct val="90000"/>
         </a:lnSpc>
         <a:spcBef>
-          <a:spcPts val="1562"/>
+          <a:spcPts val="1171"/>
         </a:spcBef>
         <a:buFont typeface="Arial" panose="020B0604020202020204" pitchFamily="34" charset="0"/>
         <a:buChar char="•"/>
-        <a:defRPr sz="5622" kern="1200">
+        <a:defRPr sz="4217" kern="1200">
           <a:solidFill>
             <a:schemeClr val="tx1"/>
           </a:solidFill>
@@ -3293,8 +3298,8 @@
       <a:defPPr>
         <a:defRPr lang="en-US"/>
       </a:defPPr>
-      <a:lvl1pPr marL="0" algn="l" defTabSz="2856037" rtl="0" eaLnBrk="1" latinLnBrk="0" hangingPunct="1">
-        <a:defRPr sz="5622" kern="1200">
+      <a:lvl1pPr marL="0" algn="l" defTabSz="2141982" rtl="0" eaLnBrk="1" latinLnBrk="0" hangingPunct="1">
+        <a:defRPr sz="4217" kern="1200">
           <a:solidFill>
             <a:schemeClr val="tx1"/>
           </a:solidFill>
@@ -3303,8 +3308,8 @@
           <a:cs typeface="+mn-cs"/>
         </a:defRPr>
       </a:lvl1pPr>
-      <a:lvl2pPr marL="1428018" algn="l" defTabSz="2856037" rtl="0" eaLnBrk="1" latinLnBrk="0" hangingPunct="1">
-        <a:defRPr sz="5622" kern="1200">
+      <a:lvl2pPr marL="1070991" algn="l" defTabSz="2141982" rtl="0" eaLnBrk="1" latinLnBrk="0" hangingPunct="1">
+        <a:defRPr sz="4217" kern="1200">
           <a:solidFill>
             <a:schemeClr val="tx1"/>
           </a:solidFill>
@@ -3313,8 +3318,8 @@
           <a:cs typeface="+mn-cs"/>
         </a:defRPr>
       </a:lvl2pPr>
-      <a:lvl3pPr marL="2856037" algn="l" defTabSz="2856037" rtl="0" eaLnBrk="1" latinLnBrk="0" hangingPunct="1">
-        <a:defRPr sz="5622" kern="1200">
+      <a:lvl3pPr marL="2141982" algn="l" defTabSz="2141982" rtl="0" eaLnBrk="1" latinLnBrk="0" hangingPunct="1">
+        <a:defRPr sz="4217" kern="1200">
           <a:solidFill>
             <a:schemeClr val="tx1"/>
           </a:solidFill>
@@ -3323,8 +3328,8 @@
           <a:cs typeface="+mn-cs"/>
         </a:defRPr>
       </a:lvl3pPr>
-      <a:lvl4pPr marL="4284055" algn="l" defTabSz="2856037" rtl="0" eaLnBrk="1" latinLnBrk="0" hangingPunct="1">
-        <a:defRPr sz="5622" kern="1200">
+      <a:lvl4pPr marL="3212973" algn="l" defTabSz="2141982" rtl="0" eaLnBrk="1" latinLnBrk="0" hangingPunct="1">
+        <a:defRPr sz="4217" kern="1200">
           <a:solidFill>
             <a:schemeClr val="tx1"/>
           </a:solidFill>
@@ -3333,8 +3338,8 @@
           <a:cs typeface="+mn-cs"/>
         </a:defRPr>
       </a:lvl4pPr>
-      <a:lvl5pPr marL="5712074" algn="l" defTabSz="2856037" rtl="0" eaLnBrk="1" latinLnBrk="0" hangingPunct="1">
-        <a:defRPr sz="5622" kern="1200">
+      <a:lvl5pPr marL="4283964" algn="l" defTabSz="2141982" rtl="0" eaLnBrk="1" latinLnBrk="0" hangingPunct="1">
+        <a:defRPr sz="4217" kern="1200">
           <a:solidFill>
             <a:schemeClr val="tx1"/>
           </a:solidFill>
@@ -3343,8 +3348,8 @@
           <a:cs typeface="+mn-cs"/>
         </a:defRPr>
       </a:lvl5pPr>
-      <a:lvl6pPr marL="7140092" algn="l" defTabSz="2856037" rtl="0" eaLnBrk="1" latinLnBrk="0" hangingPunct="1">
-        <a:defRPr sz="5622" kern="1200">
+      <a:lvl6pPr marL="5354955" algn="l" defTabSz="2141982" rtl="0" eaLnBrk="1" latinLnBrk="0" hangingPunct="1">
+        <a:defRPr sz="4217" kern="1200">
           <a:solidFill>
             <a:schemeClr val="tx1"/>
           </a:solidFill>
@@ -3353,8 +3358,8 @@
           <a:cs typeface="+mn-cs"/>
         </a:defRPr>
       </a:lvl6pPr>
-      <a:lvl7pPr marL="8568111" algn="l" defTabSz="2856037" rtl="0" eaLnBrk="1" latinLnBrk="0" hangingPunct="1">
-        <a:defRPr sz="5622" kern="1200">
+      <a:lvl7pPr marL="6425946" algn="l" defTabSz="2141982" rtl="0" eaLnBrk="1" latinLnBrk="0" hangingPunct="1">
+        <a:defRPr sz="4217" kern="1200">
           <a:solidFill>
             <a:schemeClr val="tx1"/>
           </a:solidFill>
@@ -3363,8 +3368,8 @@
           <a:cs typeface="+mn-cs"/>
         </a:defRPr>
       </a:lvl7pPr>
-      <a:lvl8pPr marL="9996129" algn="l" defTabSz="2856037" rtl="0" eaLnBrk="1" latinLnBrk="0" hangingPunct="1">
-        <a:defRPr sz="5622" kern="1200">
+      <a:lvl8pPr marL="7496937" algn="l" defTabSz="2141982" rtl="0" eaLnBrk="1" latinLnBrk="0" hangingPunct="1">
+        <a:defRPr sz="4217" kern="1200">
           <a:solidFill>
             <a:schemeClr val="tx1"/>
           </a:solidFill>
@@ -3373,8 +3378,8 @@
           <a:cs typeface="+mn-cs"/>
         </a:defRPr>
       </a:lvl8pPr>
-      <a:lvl9pPr marL="11424148" algn="l" defTabSz="2856037" rtl="0" eaLnBrk="1" latinLnBrk="0" hangingPunct="1">
-        <a:defRPr sz="5622" kern="1200">
+      <a:lvl9pPr marL="8567928" algn="l" defTabSz="2141982" rtl="0" eaLnBrk="1" latinLnBrk="0" hangingPunct="1">
+        <a:defRPr sz="4217" kern="1200">
           <a:solidFill>
             <a:schemeClr val="tx1"/>
           </a:solidFill>
@@ -3419,8 +3424,8 @@
         </p:nvSpPr>
         <p:spPr>
           <a:xfrm>
-            <a:off x="0" y="1"/>
-            <a:ext cx="30275213" cy="2029967"/>
+            <a:off x="0" y="0"/>
+            <a:ext cx="21420140" cy="2908117"/>
           </a:xfrm>
           <a:prstGeom prst="rect">
             <a:avLst/>
@@ -3459,10 +3464,10 @@
       </p:sp>
       <p:sp>
         <p:nvSpPr>
-          <p:cNvPr id="8" name="TextBox 7">
+          <p:cNvPr id="12" name="TextBox 11">
             <a:extLst>
               <a:ext uri="{FF2B5EF4-FFF2-40B4-BE49-F238E27FC236}">
-                <a16:creationId xmlns:a16="http://schemas.microsoft.com/office/drawing/2014/main" id="{97472441-3D57-0161-1737-11D3E68D2916}"/>
+                <a16:creationId xmlns:a16="http://schemas.microsoft.com/office/drawing/2014/main" id="{2B0EDB25-8610-C8B4-5905-0D2DA4759622}"/>
               </a:ext>
             </a:extLst>
           </p:cNvPr>
@@ -3471,8 +3476,8 @@
         </p:nvSpPr>
         <p:spPr>
           <a:xfrm>
-            <a:off x="11830050" y="4667250"/>
-            <a:ext cx="1278876" cy="369332"/>
+            <a:off x="1473855" y="130801"/>
+            <a:ext cx="18438061" cy="1446550"/>
           </a:xfrm>
           <a:prstGeom prst="rect">
             <a:avLst/>
@@ -3485,13 +3490,2140 @@
           </a:bodyPr>
           <a:lstStyle/>
           <a:p>
-            <a:r>
-              <a:rPr lang="en-CN"/>
-              <a:t>Evaluation </a:t>
-            </a:r>
-          </a:p>
-        </p:txBody>
-      </p:sp>
+            <a:pPr algn="ctr"/>
+            <a:r>
+              <a:rPr lang="en-US" sz="4400" b="1" dirty="0">
+                <a:solidFill>
+                  <a:schemeClr val="bg1"/>
+                </a:solidFill>
+                <a:latin typeface="+mj-lt"/>
+                <a:cs typeface="Calibri" panose="020F0502020204030204" pitchFamily="34" charset="0"/>
+              </a:rPr>
+              <a:t>Machine Learning Assisted Real-Time Plasma Diagnosis: </a:t>
+            </a:r>
+          </a:p>
+          <a:p>
+            <a:pPr algn="ctr"/>
+            <a:r>
+              <a:rPr lang="en-US" sz="4400" b="1" dirty="0">
+                <a:solidFill>
+                  <a:schemeClr val="bg1"/>
+                </a:solidFill>
+                <a:latin typeface="+mj-lt"/>
+                <a:cs typeface="Calibri" panose="020F0502020204030204" pitchFamily="34" charset="0"/>
+              </a:rPr>
+              <a:t>Domain-Knowledge-Driven Feature Engineering Enable H</a:t>
+            </a:r>
+            <a:r>
+              <a:rPr lang="en-US" sz="4400" b="1" baseline="-25000" dirty="0">
+                <a:solidFill>
+                  <a:schemeClr val="bg1"/>
+                </a:solidFill>
+                <a:latin typeface="+mj-lt"/>
+                <a:cs typeface="Calibri" panose="020F0502020204030204" pitchFamily="34" charset="0"/>
+              </a:rPr>
+              <a:t>2</a:t>
+            </a:r>
+            <a:r>
+              <a:rPr lang="en-US" sz="4400" b="1" dirty="0">
+                <a:solidFill>
+                  <a:schemeClr val="bg1"/>
+                </a:solidFill>
+                <a:latin typeface="+mj-lt"/>
+                <a:cs typeface="Calibri" panose="020F0502020204030204" pitchFamily="34" charset="0"/>
+              </a:rPr>
+              <a:t>O</a:t>
+            </a:r>
+            <a:r>
+              <a:rPr lang="en-US" sz="4400" b="1" baseline="-25000" dirty="0">
+                <a:solidFill>
+                  <a:schemeClr val="bg1"/>
+                </a:solidFill>
+                <a:latin typeface="+mj-lt"/>
+                <a:cs typeface="Calibri" panose="020F0502020204030204" pitchFamily="34" charset="0"/>
+              </a:rPr>
+              <a:t>2 </a:t>
+            </a:r>
+            <a:r>
+              <a:rPr lang="en-US" sz="4400" b="1" dirty="0">
+                <a:solidFill>
+                  <a:schemeClr val="bg1"/>
+                </a:solidFill>
+                <a:latin typeface="+mj-lt"/>
+                <a:cs typeface="Calibri" panose="020F0502020204030204" pitchFamily="34" charset="0"/>
+              </a:rPr>
+              <a:t>Yield Prediction</a:t>
+            </a:r>
+            <a:endParaRPr lang="en-CN" sz="4000" b="1" dirty="0">
+              <a:solidFill>
+                <a:schemeClr val="bg1"/>
+              </a:solidFill>
+              <a:latin typeface="+mj-lt"/>
+              <a:cs typeface="Calibri" panose="020F0502020204030204" pitchFamily="34" charset="0"/>
+            </a:endParaRPr>
+          </a:p>
+        </p:txBody>
+      </p:sp>
+      <p:sp>
+        <p:nvSpPr>
+          <p:cNvPr id="13" name="TextBox 12">
+            <a:extLst>
+              <a:ext uri="{FF2B5EF4-FFF2-40B4-BE49-F238E27FC236}">
+                <a16:creationId xmlns:a16="http://schemas.microsoft.com/office/drawing/2014/main" id="{17AF1040-1642-AD80-FA87-F4F86A8F15DF}"/>
+              </a:ext>
+            </a:extLst>
+          </p:cNvPr>
+          <p:cNvSpPr txBox="1"/>
+          <p:nvPr/>
+        </p:nvSpPr>
+        <p:spPr>
+          <a:xfrm>
+            <a:off x="7178468" y="1689709"/>
+            <a:ext cx="7028816" cy="954107"/>
+          </a:xfrm>
+          <a:prstGeom prst="rect">
+            <a:avLst/>
+          </a:prstGeom>
+          <a:noFill/>
+        </p:spPr>
+        <p:txBody>
+          <a:bodyPr wrap="square" rtlCol="0">
+            <a:spAutoFit/>
+          </a:bodyPr>
+          <a:lstStyle/>
+          <a:p>
+            <a:pPr algn="ctr"/>
+            <a:r>
+              <a:rPr lang="en-CN" sz="2800" dirty="0">
+                <a:solidFill>
+                  <a:schemeClr val="bg1">
+                    <a:lumMod val="75000"/>
+                  </a:schemeClr>
+                </a:solidFill>
+                <a:latin typeface="Calibri" panose="020F0502020204030204" pitchFamily="34" charset="0"/>
+                <a:cs typeface="Calibri" panose="020F0502020204030204" pitchFamily="34" charset="0"/>
+              </a:rPr>
+              <a:t>Supervisor: Xin Tu	Assessor: Xue Yong</a:t>
+            </a:r>
+          </a:p>
+          <a:p>
+            <a:pPr algn="ctr"/>
+            <a:r>
+              <a:rPr lang="en-CN" sz="2800" dirty="0">
+                <a:solidFill>
+                  <a:schemeClr val="bg1">
+                    <a:lumMod val="75000"/>
+                  </a:schemeClr>
+                </a:solidFill>
+                <a:latin typeface="Calibri" panose="020F0502020204030204" pitchFamily="34" charset="0"/>
+                <a:cs typeface="Calibri" panose="020F0502020204030204" pitchFamily="34" charset="0"/>
+              </a:rPr>
+              <a:t>Mingjie Zhu  (201850714)	</a:t>
+            </a:r>
+          </a:p>
+        </p:txBody>
+      </p:sp>
+      <p:pic>
+        <p:nvPicPr>
+          <p:cNvPr id="33" name="图片 72">
+            <a:extLst>
+              <a:ext uri="{FF2B5EF4-FFF2-40B4-BE49-F238E27FC236}">
+                <a16:creationId xmlns:a16="http://schemas.microsoft.com/office/drawing/2014/main" id="{CE82D9B4-FF87-FD54-BE3E-B9AA1108C868}"/>
+              </a:ext>
+            </a:extLst>
+          </p:cNvPr>
+          <p:cNvPicPr/>
+          <p:nvPr/>
+        </p:nvPicPr>
+        <p:blipFill>
+          <a:blip r:embed="rId3"/>
+          <a:stretch>
+            <a:fillRect/>
+          </a:stretch>
+        </p:blipFill>
+        <p:spPr>
+          <a:xfrm>
+            <a:off x="357901" y="1403948"/>
+            <a:ext cx="4200416" cy="1446550"/>
+          </a:xfrm>
+          <a:prstGeom prst="rect">
+            <a:avLst/>
+          </a:prstGeom>
+        </p:spPr>
+      </p:pic>
+      <p:grpSp>
+        <p:nvGrpSpPr>
+          <p:cNvPr id="48" name="Group 47">
+            <a:extLst>
+              <a:ext uri="{FF2B5EF4-FFF2-40B4-BE49-F238E27FC236}">
+                <a16:creationId xmlns:a16="http://schemas.microsoft.com/office/drawing/2014/main" id="{88C311E7-0C99-82C3-A0DE-4E491B7D2ACA}"/>
+              </a:ext>
+            </a:extLst>
+          </p:cNvPr>
+          <p:cNvGrpSpPr/>
+          <p:nvPr/>
+        </p:nvGrpSpPr>
+        <p:grpSpPr>
+          <a:xfrm>
+            <a:off x="7348061" y="9085406"/>
+            <a:ext cx="6724016" cy="8711716"/>
+            <a:chOff x="440418" y="5694830"/>
+            <a:chExt cx="9183262" cy="8711716"/>
+          </a:xfrm>
+        </p:grpSpPr>
+        <p:sp>
+          <p:nvSpPr>
+            <p:cNvPr id="49" name="Text Box 189">
+              <a:extLst>
+                <a:ext uri="{FF2B5EF4-FFF2-40B4-BE49-F238E27FC236}">
+                  <a16:creationId xmlns:a16="http://schemas.microsoft.com/office/drawing/2014/main" id="{BE3C8062-1114-E101-75D6-0ADD85BA5258}"/>
+                </a:ext>
+              </a:extLst>
+            </p:cNvPr>
+            <p:cNvSpPr txBox="1">
+              <a:spLocks noChangeArrowheads="1"/>
+            </p:cNvSpPr>
+            <p:nvPr/>
+          </p:nvSpPr>
+          <p:spPr bwMode="auto">
+            <a:xfrm>
+              <a:off x="440418" y="6668631"/>
+              <a:ext cx="9183262" cy="7737915"/>
+            </a:xfrm>
+            <a:prstGeom prst="rect">
+              <a:avLst/>
+            </a:prstGeom>
+            <a:solidFill>
+              <a:schemeClr val="bg1"/>
+            </a:solidFill>
+            <a:ln w="12700">
+              <a:solidFill>
+                <a:schemeClr val="accent1">
+                  <a:lumMod val="75000"/>
+                </a:schemeClr>
+              </a:solidFill>
+            </a:ln>
+            <a:effectLst/>
+          </p:spPr>
+          <p:txBody>
+            <a:bodyPr wrap="square" lIns="173940" tIns="173940" rIns="173940" bIns="173940">
+              <a:spAutoFit/>
+            </a:bodyPr>
+            <a:lstStyle>
+              <a:lvl1pPr eaLnBrk="0" hangingPunct="0">
+                <a:defRPr sz="2200">
+                  <a:solidFill>
+                    <a:schemeClr val="tx1"/>
+                  </a:solidFill>
+                  <a:latin typeface="Arial" charset="0"/>
+                </a:defRPr>
+              </a:lvl1pPr>
+              <a:lvl2pPr marL="742950" indent="-285750" eaLnBrk="0" hangingPunct="0">
+                <a:defRPr sz="2200">
+                  <a:solidFill>
+                    <a:schemeClr val="tx1"/>
+                  </a:solidFill>
+                  <a:latin typeface="Arial" charset="0"/>
+                </a:defRPr>
+              </a:lvl2pPr>
+              <a:lvl3pPr marL="1143000" indent="-228600" eaLnBrk="0" hangingPunct="0">
+                <a:defRPr sz="2200">
+                  <a:solidFill>
+                    <a:schemeClr val="tx1"/>
+                  </a:solidFill>
+                  <a:latin typeface="Arial" charset="0"/>
+                </a:defRPr>
+              </a:lvl3pPr>
+              <a:lvl4pPr marL="1600200" indent="-228600" eaLnBrk="0" hangingPunct="0">
+                <a:defRPr sz="2200">
+                  <a:solidFill>
+                    <a:schemeClr val="tx1"/>
+                  </a:solidFill>
+                  <a:latin typeface="Arial" charset="0"/>
+                </a:defRPr>
+              </a:lvl4pPr>
+              <a:lvl5pPr marL="2057400" indent="-228600" eaLnBrk="0" hangingPunct="0">
+                <a:defRPr sz="2200">
+                  <a:solidFill>
+                    <a:schemeClr val="tx1"/>
+                  </a:solidFill>
+                  <a:latin typeface="Arial" charset="0"/>
+                </a:defRPr>
+              </a:lvl5pPr>
+              <a:lvl6pPr marL="2514600" indent="-228600" eaLnBrk="0" fontAlgn="base" hangingPunct="0">
+                <a:spcBef>
+                  <a:spcPct val="0"/>
+                </a:spcBef>
+                <a:spcAft>
+                  <a:spcPct val="0"/>
+                </a:spcAft>
+                <a:defRPr sz="2200">
+                  <a:solidFill>
+                    <a:schemeClr val="tx1"/>
+                  </a:solidFill>
+                  <a:latin typeface="Arial" charset="0"/>
+                </a:defRPr>
+              </a:lvl6pPr>
+              <a:lvl7pPr marL="2971800" indent="-228600" eaLnBrk="0" fontAlgn="base" hangingPunct="0">
+                <a:spcBef>
+                  <a:spcPct val="0"/>
+                </a:spcBef>
+                <a:spcAft>
+                  <a:spcPct val="0"/>
+                </a:spcAft>
+                <a:defRPr sz="2200">
+                  <a:solidFill>
+                    <a:schemeClr val="tx1"/>
+                  </a:solidFill>
+                  <a:latin typeface="Arial" charset="0"/>
+                </a:defRPr>
+              </a:lvl7pPr>
+              <a:lvl8pPr marL="3429000" indent="-228600" eaLnBrk="0" fontAlgn="base" hangingPunct="0">
+                <a:spcBef>
+                  <a:spcPct val="0"/>
+                </a:spcBef>
+                <a:spcAft>
+                  <a:spcPct val="0"/>
+                </a:spcAft>
+                <a:defRPr sz="2200">
+                  <a:solidFill>
+                    <a:schemeClr val="tx1"/>
+                  </a:solidFill>
+                  <a:latin typeface="Arial" charset="0"/>
+                </a:defRPr>
+              </a:lvl8pPr>
+              <a:lvl9pPr marL="3886200" indent="-228600" eaLnBrk="0" fontAlgn="base" hangingPunct="0">
+                <a:spcBef>
+                  <a:spcPct val="0"/>
+                </a:spcBef>
+                <a:spcAft>
+                  <a:spcPct val="0"/>
+                </a:spcAft>
+                <a:defRPr sz="2200">
+                  <a:solidFill>
+                    <a:schemeClr val="tx1"/>
+                  </a:solidFill>
+                  <a:latin typeface="Arial" charset="0"/>
+                </a:defRPr>
+              </a:lvl9pPr>
+            </a:lstStyle>
+            <a:p>
+              <a:pPr eaLnBrk="1" hangingPunct="1"/>
+              <a:r>
+                <a:rPr lang="en-US" sz="3200" dirty="0">
+                  <a:latin typeface="+mn-lt"/>
+                </a:rPr>
+                <a:t>Inspired by CNC machining, this project creates an automated drawing machine using an Etch A Sketch board</a:t>
+              </a:r>
+              <a:r>
+                <a:rPr lang="en-US" sz="3200" baseline="30000" dirty="0">
+                  <a:latin typeface="Calibri" pitchFamily="34" charset="0"/>
+                </a:rPr>
+                <a:t>[1]</a:t>
+              </a:r>
+              <a:r>
+                <a:rPr lang="en-US" sz="3200" dirty="0">
+                  <a:latin typeface="Calibri" pitchFamily="34" charset="0"/>
+                </a:rPr>
+                <a:t>.</a:t>
+              </a:r>
+              <a:r>
+                <a:rPr lang="en-US" sz="3200" dirty="0">
+                  <a:latin typeface="+mn-lt"/>
+                </a:rPr>
+                <a:t> </a:t>
+              </a:r>
+            </a:p>
+            <a:p>
+              <a:pPr eaLnBrk="1" hangingPunct="1"/>
+              <a:endParaRPr lang="en-US" sz="3200" dirty="0">
+                <a:latin typeface="+mn-lt"/>
+              </a:endParaRPr>
+            </a:p>
+            <a:p>
+              <a:pPr eaLnBrk="1" hangingPunct="1"/>
+              <a:r>
+                <a:rPr lang="en-US" sz="3200" dirty="0">
+                  <a:latin typeface="+mn-lt"/>
+                </a:rPr>
+                <a:t>It first introduces a software pipeline that transforms digital images into continuous-line drawings. By employing edge detection techniques and a specialized depth-first search (DFS) algorithm, our system generates optimized G-code instructions tailored for our custom-built drawing machine.</a:t>
+              </a:r>
+            </a:p>
+            <a:p>
+              <a:pPr eaLnBrk="1" hangingPunct="1"/>
+              <a:br>
+                <a:rPr lang="en-US" sz="3200" dirty="0">
+                  <a:latin typeface="+mn-lt"/>
+                </a:rPr>
+              </a:br>
+              <a:r>
+                <a:rPr lang="en-US" sz="3200" dirty="0">
+                  <a:latin typeface="+mn-lt"/>
+                </a:rPr>
+                <a:t>The hardware system interprets these instructions and uses two stepper motors to precisely control the Etch A Sketch knobs, allowing the machine to replicate digital images as physical sketches.</a:t>
+              </a:r>
+            </a:p>
+          </p:txBody>
+        </p:sp>
+        <p:sp>
+          <p:nvSpPr>
+            <p:cNvPr id="50" name="Rectangle 49">
+              <a:extLst>
+                <a:ext uri="{FF2B5EF4-FFF2-40B4-BE49-F238E27FC236}">
+                  <a16:creationId xmlns:a16="http://schemas.microsoft.com/office/drawing/2014/main" id="{FD5B111A-B4E9-6D13-00F1-85495135907E}"/>
+                </a:ext>
+              </a:extLst>
+            </p:cNvPr>
+            <p:cNvSpPr/>
+            <p:nvPr/>
+          </p:nvSpPr>
+          <p:spPr>
+            <a:xfrm>
+              <a:off x="440418" y="5694830"/>
+              <a:ext cx="9183262" cy="973802"/>
+            </a:xfrm>
+            <a:prstGeom prst="rect">
+              <a:avLst/>
+            </a:prstGeom>
+            <a:solidFill>
+              <a:schemeClr val="accent1">
+                <a:lumMod val="75000"/>
+              </a:schemeClr>
+            </a:solidFill>
+          </p:spPr>
+          <p:style>
+            <a:lnRef idx="2">
+              <a:schemeClr val="accent1">
+                <a:shade val="50000"/>
+              </a:schemeClr>
+            </a:lnRef>
+            <a:fillRef idx="1">
+              <a:schemeClr val="accent1"/>
+            </a:fillRef>
+            <a:effectRef idx="0">
+              <a:schemeClr val="accent1"/>
+            </a:effectRef>
+            <a:fontRef idx="minor">
+              <a:schemeClr val="lt1"/>
+            </a:fontRef>
+          </p:style>
+          <p:txBody>
+            <a:bodyPr lIns="86970" tIns="43485" rIns="86970" bIns="43485" rtlCol="0" anchor="ctr"/>
+            <a:lstStyle/>
+            <a:p>
+              <a:pPr algn="ctr"/>
+              <a:r>
+                <a:rPr lang="en-US" sz="5400" b="1" dirty="0">
+                  <a:solidFill>
+                    <a:schemeClr val="accent3">
+                      <a:lumMod val="20000"/>
+                      <a:lumOff val="80000"/>
+                    </a:schemeClr>
+                  </a:solidFill>
+                </a:rPr>
+                <a:t>Results</a:t>
+              </a:r>
+            </a:p>
+          </p:txBody>
+        </p:sp>
+      </p:grpSp>
+      <p:grpSp>
+        <p:nvGrpSpPr>
+          <p:cNvPr id="51" name="Group 50">
+            <a:extLst>
+              <a:ext uri="{FF2B5EF4-FFF2-40B4-BE49-F238E27FC236}">
+                <a16:creationId xmlns:a16="http://schemas.microsoft.com/office/drawing/2014/main" id="{A9355F9A-B3D3-A17F-1418-060C39543E24}"/>
+              </a:ext>
+            </a:extLst>
+          </p:cNvPr>
+          <p:cNvGrpSpPr/>
+          <p:nvPr/>
+        </p:nvGrpSpPr>
+        <p:grpSpPr>
+          <a:xfrm>
+            <a:off x="229885" y="3091330"/>
+            <a:ext cx="6748634" cy="14928802"/>
+            <a:chOff x="440418" y="5694830"/>
+            <a:chExt cx="9183262" cy="14928802"/>
+          </a:xfrm>
+        </p:grpSpPr>
+        <p:sp>
+          <p:nvSpPr>
+            <p:cNvPr id="52" name="Text Box 189">
+              <a:extLst>
+                <a:ext uri="{FF2B5EF4-FFF2-40B4-BE49-F238E27FC236}">
+                  <a16:creationId xmlns:a16="http://schemas.microsoft.com/office/drawing/2014/main" id="{11367713-F6E8-F588-F90C-BE8C07A708EB}"/>
+                </a:ext>
+              </a:extLst>
+            </p:cNvPr>
+            <p:cNvSpPr txBox="1">
+              <a:spLocks noChangeArrowheads="1"/>
+            </p:cNvSpPr>
+            <p:nvPr/>
+          </p:nvSpPr>
+          <p:spPr bwMode="auto">
+            <a:xfrm>
+              <a:off x="440418" y="6668631"/>
+              <a:ext cx="9183262" cy="13955001"/>
+            </a:xfrm>
+            <a:prstGeom prst="rect">
+              <a:avLst/>
+            </a:prstGeom>
+            <a:solidFill>
+              <a:schemeClr val="bg1"/>
+            </a:solidFill>
+            <a:ln w="12700">
+              <a:solidFill>
+                <a:schemeClr val="accent1">
+                  <a:lumMod val="75000"/>
+                </a:schemeClr>
+              </a:solidFill>
+            </a:ln>
+            <a:effectLst/>
+          </p:spPr>
+          <p:txBody>
+            <a:bodyPr wrap="square" lIns="173940" tIns="173940" rIns="173940" bIns="173940">
+              <a:spAutoFit/>
+            </a:bodyPr>
+            <a:lstStyle>
+              <a:lvl1pPr eaLnBrk="0" hangingPunct="0">
+                <a:defRPr sz="2200">
+                  <a:solidFill>
+                    <a:schemeClr val="tx1"/>
+                  </a:solidFill>
+                  <a:latin typeface="Arial" charset="0"/>
+                </a:defRPr>
+              </a:lvl1pPr>
+              <a:lvl2pPr marL="742950" indent="-285750" eaLnBrk="0" hangingPunct="0">
+                <a:defRPr sz="2200">
+                  <a:solidFill>
+                    <a:schemeClr val="tx1"/>
+                  </a:solidFill>
+                  <a:latin typeface="Arial" charset="0"/>
+                </a:defRPr>
+              </a:lvl2pPr>
+              <a:lvl3pPr marL="1143000" indent="-228600" eaLnBrk="0" hangingPunct="0">
+                <a:defRPr sz="2200">
+                  <a:solidFill>
+                    <a:schemeClr val="tx1"/>
+                  </a:solidFill>
+                  <a:latin typeface="Arial" charset="0"/>
+                </a:defRPr>
+              </a:lvl3pPr>
+              <a:lvl4pPr marL="1600200" indent="-228600" eaLnBrk="0" hangingPunct="0">
+                <a:defRPr sz="2200">
+                  <a:solidFill>
+                    <a:schemeClr val="tx1"/>
+                  </a:solidFill>
+                  <a:latin typeface="Arial" charset="0"/>
+                </a:defRPr>
+              </a:lvl4pPr>
+              <a:lvl5pPr marL="2057400" indent="-228600" eaLnBrk="0" hangingPunct="0">
+                <a:defRPr sz="2200">
+                  <a:solidFill>
+                    <a:schemeClr val="tx1"/>
+                  </a:solidFill>
+                  <a:latin typeface="Arial" charset="0"/>
+                </a:defRPr>
+              </a:lvl5pPr>
+              <a:lvl6pPr marL="2514600" indent="-228600" eaLnBrk="0" fontAlgn="base" hangingPunct="0">
+                <a:spcBef>
+                  <a:spcPct val="0"/>
+                </a:spcBef>
+                <a:spcAft>
+                  <a:spcPct val="0"/>
+                </a:spcAft>
+                <a:defRPr sz="2200">
+                  <a:solidFill>
+                    <a:schemeClr val="tx1"/>
+                  </a:solidFill>
+                  <a:latin typeface="Arial" charset="0"/>
+                </a:defRPr>
+              </a:lvl6pPr>
+              <a:lvl7pPr marL="2971800" indent="-228600" eaLnBrk="0" fontAlgn="base" hangingPunct="0">
+                <a:spcBef>
+                  <a:spcPct val="0"/>
+                </a:spcBef>
+                <a:spcAft>
+                  <a:spcPct val="0"/>
+                </a:spcAft>
+                <a:defRPr sz="2200">
+                  <a:solidFill>
+                    <a:schemeClr val="tx1"/>
+                  </a:solidFill>
+                  <a:latin typeface="Arial" charset="0"/>
+                </a:defRPr>
+              </a:lvl7pPr>
+              <a:lvl8pPr marL="3429000" indent="-228600" eaLnBrk="0" fontAlgn="base" hangingPunct="0">
+                <a:spcBef>
+                  <a:spcPct val="0"/>
+                </a:spcBef>
+                <a:spcAft>
+                  <a:spcPct val="0"/>
+                </a:spcAft>
+                <a:defRPr sz="2200">
+                  <a:solidFill>
+                    <a:schemeClr val="tx1"/>
+                  </a:solidFill>
+                  <a:latin typeface="Arial" charset="0"/>
+                </a:defRPr>
+              </a:lvl8pPr>
+              <a:lvl9pPr marL="3886200" indent="-228600" eaLnBrk="0" fontAlgn="base" hangingPunct="0">
+                <a:spcBef>
+                  <a:spcPct val="0"/>
+                </a:spcBef>
+                <a:spcAft>
+                  <a:spcPct val="0"/>
+                </a:spcAft>
+                <a:defRPr sz="2200">
+                  <a:solidFill>
+                    <a:schemeClr val="tx1"/>
+                  </a:solidFill>
+                  <a:latin typeface="Arial" charset="0"/>
+                </a:defRPr>
+              </a:lvl9pPr>
+            </a:lstStyle>
+            <a:p>
+              <a:pPr eaLnBrk="1" hangingPunct="1"/>
+              <a:r>
+                <a:rPr lang="en-US" sz="2400" dirty="0">
+                  <a:latin typeface="+mn-lt"/>
+                </a:rPr>
+                <a:t>Nanosecond pulsed CO2 bubble discharge demonstrates novel pathway that utilizes plasma technology  to convert CO2 into useful chemical products, such as H2 and H2O2[1]. </a:t>
+              </a:r>
+            </a:p>
+            <a:p>
+              <a:pPr eaLnBrk="1" hangingPunct="1"/>
+              <a:endParaRPr lang="en-US" sz="2400" dirty="0">
+                <a:latin typeface="+mn-lt"/>
+              </a:endParaRPr>
+            </a:p>
+            <a:p>
+              <a:pPr eaLnBrk="1" hangingPunct="1"/>
+              <a:endParaRPr lang="en-US" sz="2400" dirty="0">
+                <a:latin typeface="+mn-lt"/>
+              </a:endParaRPr>
+            </a:p>
+            <a:p>
+              <a:pPr eaLnBrk="1" hangingPunct="1"/>
+              <a:endParaRPr lang="en-US" sz="2400" dirty="0">
+                <a:latin typeface="+mn-lt"/>
+              </a:endParaRPr>
+            </a:p>
+            <a:p>
+              <a:pPr eaLnBrk="1" hangingPunct="1"/>
+              <a:endParaRPr lang="en-US" sz="2400" dirty="0">
+                <a:latin typeface="+mn-lt"/>
+              </a:endParaRPr>
+            </a:p>
+            <a:p>
+              <a:pPr eaLnBrk="1" hangingPunct="1"/>
+              <a:endParaRPr lang="en-US" sz="2400" dirty="0">
+                <a:latin typeface="+mn-lt"/>
+              </a:endParaRPr>
+            </a:p>
+            <a:p>
+              <a:pPr eaLnBrk="1" hangingPunct="1"/>
+              <a:endParaRPr lang="en-US" sz="2400" dirty="0">
+                <a:latin typeface="+mn-lt"/>
+              </a:endParaRPr>
+            </a:p>
+            <a:p>
+              <a:pPr eaLnBrk="1" hangingPunct="1"/>
+              <a:endParaRPr lang="en-US" sz="2400" dirty="0">
+                <a:latin typeface="+mn-lt"/>
+              </a:endParaRPr>
+            </a:p>
+            <a:p>
+              <a:pPr eaLnBrk="1" hangingPunct="1"/>
+              <a:endParaRPr lang="en-US" sz="2400" dirty="0">
+                <a:latin typeface="+mn-lt"/>
+              </a:endParaRPr>
+            </a:p>
+            <a:p>
+              <a:pPr eaLnBrk="1" hangingPunct="1"/>
+              <a:endParaRPr lang="en-US" sz="2400" dirty="0">
+                <a:latin typeface="+mn-lt"/>
+              </a:endParaRPr>
+            </a:p>
+            <a:p>
+              <a:pPr eaLnBrk="1" hangingPunct="1"/>
+              <a:endParaRPr lang="en-US" sz="2400" dirty="0">
+                <a:latin typeface="+mn-lt"/>
+              </a:endParaRPr>
+            </a:p>
+            <a:p>
+              <a:pPr eaLnBrk="1" hangingPunct="1"/>
+              <a:endParaRPr lang="en-US" sz="2400" dirty="0">
+                <a:latin typeface="+mn-lt"/>
+              </a:endParaRPr>
+            </a:p>
+            <a:p>
+              <a:pPr eaLnBrk="1" hangingPunct="1">
+                <a:spcAft>
+                  <a:spcPts val="1200"/>
+                </a:spcAft>
+              </a:pPr>
+              <a:r>
+                <a:rPr lang="en-US" sz="2400" dirty="0">
+                  <a:latin typeface="+mn-lt"/>
+                </a:rPr>
+                <a:t>Optical Emission Spectroscopy (OES) is a cost-effective instrument that enables non-intrusive, real-time measurement into the status of plasma. </a:t>
+              </a:r>
+            </a:p>
+            <a:p>
+              <a:pPr eaLnBrk="1" hangingPunct="1">
+                <a:spcAft>
+                  <a:spcPts val="1200"/>
+                </a:spcAft>
+              </a:pPr>
+              <a:r>
+                <a:rPr lang="en-US" sz="2400" dirty="0">
+                  <a:latin typeface="+mn-lt"/>
+                </a:rPr>
+                <a:t>In this research, </a:t>
+              </a:r>
+              <a:r>
+                <a:rPr lang="en-US" sz="2400" b="1" dirty="0">
+                  <a:latin typeface="+mn-lt"/>
+                </a:rPr>
+                <a:t>OES spectrum, combined with reaction discharge parameters</a:t>
+              </a:r>
+              <a:r>
+                <a:rPr lang="en-US" sz="2400" dirty="0">
+                  <a:latin typeface="+mn-lt"/>
+                </a:rPr>
+                <a:t>, are engineered to build informative features that allow Machine Learning models (i.e. linear regression, artificial neural network) to recognize and </a:t>
+              </a:r>
+              <a:r>
+                <a:rPr lang="en-US" sz="2400" b="1" dirty="0">
+                  <a:latin typeface="+mn-lt"/>
+                </a:rPr>
+                <a:t>predict H2O2 yield</a:t>
+              </a:r>
+              <a:r>
+                <a:rPr lang="en-US" sz="2400" dirty="0">
+                  <a:latin typeface="+mn-lt"/>
+                </a:rPr>
+                <a:t>. Data used in this research is collected from Gao et al.[1]</a:t>
+              </a:r>
+            </a:p>
+            <a:p>
+              <a:pPr eaLnBrk="1" hangingPunct="1"/>
+              <a:endParaRPr lang="en-US" sz="2400" dirty="0">
+                <a:latin typeface="+mn-lt"/>
+              </a:endParaRPr>
+            </a:p>
+            <a:p>
+              <a:pPr eaLnBrk="1" hangingPunct="1"/>
+              <a:endParaRPr lang="en-US" sz="2400" dirty="0">
+                <a:latin typeface="+mn-lt"/>
+              </a:endParaRPr>
+            </a:p>
+            <a:p>
+              <a:pPr eaLnBrk="1" hangingPunct="1"/>
+              <a:endParaRPr lang="en-US" sz="2400" dirty="0">
+                <a:latin typeface="+mn-lt"/>
+              </a:endParaRPr>
+            </a:p>
+            <a:p>
+              <a:pPr eaLnBrk="1" hangingPunct="1"/>
+              <a:endParaRPr lang="en-US" sz="2400" dirty="0">
+                <a:latin typeface="+mn-lt"/>
+              </a:endParaRPr>
+            </a:p>
+            <a:p>
+              <a:pPr eaLnBrk="1" hangingPunct="1"/>
+              <a:endParaRPr lang="en-US" sz="2400" dirty="0">
+                <a:latin typeface="+mn-lt"/>
+              </a:endParaRPr>
+            </a:p>
+            <a:p>
+              <a:pPr eaLnBrk="1" hangingPunct="1"/>
+              <a:endParaRPr lang="en-US" sz="2400" dirty="0">
+                <a:latin typeface="+mn-lt"/>
+              </a:endParaRPr>
+            </a:p>
+            <a:p>
+              <a:pPr eaLnBrk="1" hangingPunct="1"/>
+              <a:endParaRPr lang="en-US" sz="2400" dirty="0">
+                <a:latin typeface="+mn-lt"/>
+              </a:endParaRPr>
+            </a:p>
+            <a:p>
+              <a:pPr eaLnBrk="1" hangingPunct="1"/>
+              <a:br>
+                <a:rPr lang="en-US" sz="2400" dirty="0">
+                  <a:latin typeface="+mn-lt"/>
+                </a:rPr>
+              </a:br>
+              <a:br>
+                <a:rPr lang="en-US" sz="2400" dirty="0">
+                  <a:latin typeface="+mn-lt"/>
+                </a:rPr>
+              </a:br>
+              <a:endParaRPr lang="en-US" sz="2400" dirty="0">
+                <a:latin typeface="+mn-lt"/>
+              </a:endParaRPr>
+            </a:p>
+          </p:txBody>
+        </p:sp>
+        <p:sp>
+          <p:nvSpPr>
+            <p:cNvPr id="53" name="Rectangle 52">
+              <a:extLst>
+                <a:ext uri="{FF2B5EF4-FFF2-40B4-BE49-F238E27FC236}">
+                  <a16:creationId xmlns:a16="http://schemas.microsoft.com/office/drawing/2014/main" id="{D9AF8757-41ED-FFFA-5384-C33B63700FE3}"/>
+                </a:ext>
+              </a:extLst>
+            </p:cNvPr>
+            <p:cNvSpPr/>
+            <p:nvPr/>
+          </p:nvSpPr>
+          <p:spPr>
+            <a:xfrm>
+              <a:off x="440418" y="5694830"/>
+              <a:ext cx="9183262" cy="973802"/>
+            </a:xfrm>
+            <a:prstGeom prst="rect">
+              <a:avLst/>
+            </a:prstGeom>
+            <a:solidFill>
+              <a:schemeClr val="accent1">
+                <a:lumMod val="75000"/>
+              </a:schemeClr>
+            </a:solidFill>
+          </p:spPr>
+          <p:style>
+            <a:lnRef idx="2">
+              <a:schemeClr val="accent1">
+                <a:shade val="50000"/>
+              </a:schemeClr>
+            </a:lnRef>
+            <a:fillRef idx="1">
+              <a:schemeClr val="accent1"/>
+            </a:fillRef>
+            <a:effectRef idx="0">
+              <a:schemeClr val="accent1"/>
+            </a:effectRef>
+            <a:fontRef idx="minor">
+              <a:schemeClr val="lt1"/>
+            </a:fontRef>
+          </p:style>
+          <p:txBody>
+            <a:bodyPr lIns="86970" tIns="43485" rIns="86970" bIns="43485" rtlCol="0" anchor="ctr"/>
+            <a:lstStyle/>
+            <a:p>
+              <a:pPr algn="ctr"/>
+              <a:r>
+                <a:rPr lang="en-US" sz="5400" b="1" dirty="0">
+                  <a:solidFill>
+                    <a:schemeClr val="accent3">
+                      <a:lumMod val="20000"/>
+                      <a:lumOff val="80000"/>
+                    </a:schemeClr>
+                  </a:solidFill>
+                </a:rPr>
+                <a:t>Introduction</a:t>
+              </a:r>
+            </a:p>
+          </p:txBody>
+        </p:sp>
+      </p:grpSp>
+      <p:grpSp>
+        <p:nvGrpSpPr>
+          <p:cNvPr id="57" name="Group 56">
+            <a:extLst>
+              <a:ext uri="{FF2B5EF4-FFF2-40B4-BE49-F238E27FC236}">
+                <a16:creationId xmlns:a16="http://schemas.microsoft.com/office/drawing/2014/main" id="{E64BEBB4-2B07-8A00-0D3E-4D50D99D61F4}"/>
+              </a:ext>
+            </a:extLst>
+          </p:cNvPr>
+          <p:cNvGrpSpPr/>
+          <p:nvPr/>
+        </p:nvGrpSpPr>
+        <p:grpSpPr>
+          <a:xfrm>
+            <a:off x="14392421" y="3091330"/>
+            <a:ext cx="6748634" cy="8711716"/>
+            <a:chOff x="440418" y="5694830"/>
+            <a:chExt cx="9183262" cy="8711716"/>
+          </a:xfrm>
+        </p:grpSpPr>
+        <p:sp>
+          <p:nvSpPr>
+            <p:cNvPr id="58" name="Text Box 189">
+              <a:extLst>
+                <a:ext uri="{FF2B5EF4-FFF2-40B4-BE49-F238E27FC236}">
+                  <a16:creationId xmlns:a16="http://schemas.microsoft.com/office/drawing/2014/main" id="{31DB89BC-58E0-5E44-5C43-8A5243839716}"/>
+                </a:ext>
+              </a:extLst>
+            </p:cNvPr>
+            <p:cNvSpPr txBox="1">
+              <a:spLocks noChangeArrowheads="1"/>
+            </p:cNvSpPr>
+            <p:nvPr/>
+          </p:nvSpPr>
+          <p:spPr bwMode="auto">
+            <a:xfrm>
+              <a:off x="440418" y="6668631"/>
+              <a:ext cx="9183262" cy="7737915"/>
+            </a:xfrm>
+            <a:prstGeom prst="rect">
+              <a:avLst/>
+            </a:prstGeom>
+            <a:solidFill>
+              <a:schemeClr val="bg1"/>
+            </a:solidFill>
+            <a:ln w="12700">
+              <a:solidFill>
+                <a:schemeClr val="accent1">
+                  <a:lumMod val="75000"/>
+                </a:schemeClr>
+              </a:solidFill>
+            </a:ln>
+            <a:effectLst/>
+          </p:spPr>
+          <p:txBody>
+            <a:bodyPr wrap="square" lIns="173940" tIns="173940" rIns="173940" bIns="173940">
+              <a:spAutoFit/>
+            </a:bodyPr>
+            <a:lstStyle>
+              <a:lvl1pPr eaLnBrk="0" hangingPunct="0">
+                <a:defRPr sz="2200">
+                  <a:solidFill>
+                    <a:schemeClr val="tx1"/>
+                  </a:solidFill>
+                  <a:latin typeface="Arial" charset="0"/>
+                </a:defRPr>
+              </a:lvl1pPr>
+              <a:lvl2pPr marL="742950" indent="-285750" eaLnBrk="0" hangingPunct="0">
+                <a:defRPr sz="2200">
+                  <a:solidFill>
+                    <a:schemeClr val="tx1"/>
+                  </a:solidFill>
+                  <a:latin typeface="Arial" charset="0"/>
+                </a:defRPr>
+              </a:lvl2pPr>
+              <a:lvl3pPr marL="1143000" indent="-228600" eaLnBrk="0" hangingPunct="0">
+                <a:defRPr sz="2200">
+                  <a:solidFill>
+                    <a:schemeClr val="tx1"/>
+                  </a:solidFill>
+                  <a:latin typeface="Arial" charset="0"/>
+                </a:defRPr>
+              </a:lvl3pPr>
+              <a:lvl4pPr marL="1600200" indent="-228600" eaLnBrk="0" hangingPunct="0">
+                <a:defRPr sz="2200">
+                  <a:solidFill>
+                    <a:schemeClr val="tx1"/>
+                  </a:solidFill>
+                  <a:latin typeface="Arial" charset="0"/>
+                </a:defRPr>
+              </a:lvl4pPr>
+              <a:lvl5pPr marL="2057400" indent="-228600" eaLnBrk="0" hangingPunct="0">
+                <a:defRPr sz="2200">
+                  <a:solidFill>
+                    <a:schemeClr val="tx1"/>
+                  </a:solidFill>
+                  <a:latin typeface="Arial" charset="0"/>
+                </a:defRPr>
+              </a:lvl5pPr>
+              <a:lvl6pPr marL="2514600" indent="-228600" eaLnBrk="0" fontAlgn="base" hangingPunct="0">
+                <a:spcBef>
+                  <a:spcPct val="0"/>
+                </a:spcBef>
+                <a:spcAft>
+                  <a:spcPct val="0"/>
+                </a:spcAft>
+                <a:defRPr sz="2200">
+                  <a:solidFill>
+                    <a:schemeClr val="tx1"/>
+                  </a:solidFill>
+                  <a:latin typeface="Arial" charset="0"/>
+                </a:defRPr>
+              </a:lvl6pPr>
+              <a:lvl7pPr marL="2971800" indent="-228600" eaLnBrk="0" fontAlgn="base" hangingPunct="0">
+                <a:spcBef>
+                  <a:spcPct val="0"/>
+                </a:spcBef>
+                <a:spcAft>
+                  <a:spcPct val="0"/>
+                </a:spcAft>
+                <a:defRPr sz="2200">
+                  <a:solidFill>
+                    <a:schemeClr val="tx1"/>
+                  </a:solidFill>
+                  <a:latin typeface="Arial" charset="0"/>
+                </a:defRPr>
+              </a:lvl7pPr>
+              <a:lvl8pPr marL="3429000" indent="-228600" eaLnBrk="0" fontAlgn="base" hangingPunct="0">
+                <a:spcBef>
+                  <a:spcPct val="0"/>
+                </a:spcBef>
+                <a:spcAft>
+                  <a:spcPct val="0"/>
+                </a:spcAft>
+                <a:defRPr sz="2200">
+                  <a:solidFill>
+                    <a:schemeClr val="tx1"/>
+                  </a:solidFill>
+                  <a:latin typeface="Arial" charset="0"/>
+                </a:defRPr>
+              </a:lvl8pPr>
+              <a:lvl9pPr marL="3886200" indent="-228600" eaLnBrk="0" fontAlgn="base" hangingPunct="0">
+                <a:spcBef>
+                  <a:spcPct val="0"/>
+                </a:spcBef>
+                <a:spcAft>
+                  <a:spcPct val="0"/>
+                </a:spcAft>
+                <a:defRPr sz="2200">
+                  <a:solidFill>
+                    <a:schemeClr val="tx1"/>
+                  </a:solidFill>
+                  <a:latin typeface="Arial" charset="0"/>
+                </a:defRPr>
+              </a:lvl9pPr>
+            </a:lstStyle>
+            <a:p>
+              <a:pPr eaLnBrk="1" hangingPunct="1"/>
+              <a:r>
+                <a:rPr lang="en-US" sz="3200" dirty="0">
+                  <a:latin typeface="+mn-lt"/>
+                </a:rPr>
+                <a:t>Inspired by CNC machining, this project creates an automated drawing machine using an Etch A Sketch board</a:t>
+              </a:r>
+              <a:r>
+                <a:rPr lang="en-US" sz="3200" baseline="30000" dirty="0">
+                  <a:latin typeface="Calibri" pitchFamily="34" charset="0"/>
+                </a:rPr>
+                <a:t>[1]</a:t>
+              </a:r>
+              <a:r>
+                <a:rPr lang="en-US" sz="3200" dirty="0">
+                  <a:latin typeface="Calibri" pitchFamily="34" charset="0"/>
+                </a:rPr>
+                <a:t>.</a:t>
+              </a:r>
+              <a:r>
+                <a:rPr lang="en-US" sz="3200" dirty="0">
+                  <a:latin typeface="+mn-lt"/>
+                </a:rPr>
+                <a:t> </a:t>
+              </a:r>
+            </a:p>
+            <a:p>
+              <a:pPr eaLnBrk="1" hangingPunct="1"/>
+              <a:endParaRPr lang="en-US" sz="3200" dirty="0">
+                <a:latin typeface="+mn-lt"/>
+              </a:endParaRPr>
+            </a:p>
+            <a:p>
+              <a:pPr eaLnBrk="1" hangingPunct="1"/>
+              <a:r>
+                <a:rPr lang="en-US" sz="3200" dirty="0">
+                  <a:latin typeface="+mn-lt"/>
+                </a:rPr>
+                <a:t>It first introduces a software pipeline that transforms digital images into continuous-line drawings. By employing edge detection techniques and a specialized depth-first search (DFS) algorithm, our system generates optimized G-code instructions tailored for our custom-built drawing machine.</a:t>
+              </a:r>
+            </a:p>
+            <a:p>
+              <a:pPr eaLnBrk="1" hangingPunct="1"/>
+              <a:br>
+                <a:rPr lang="en-US" sz="3200" dirty="0">
+                  <a:latin typeface="+mn-lt"/>
+                </a:rPr>
+              </a:br>
+              <a:r>
+                <a:rPr lang="en-US" sz="3200" dirty="0">
+                  <a:latin typeface="+mn-lt"/>
+                </a:rPr>
+                <a:t>The hardware system interprets these instructions and uses two stepper motors to precisely control the Etch A Sketch knobs, allowing the machine to replicate digital images as physical sketches.</a:t>
+              </a:r>
+            </a:p>
+          </p:txBody>
+        </p:sp>
+        <p:sp>
+          <p:nvSpPr>
+            <p:cNvPr id="59" name="Rectangle 58">
+              <a:extLst>
+                <a:ext uri="{FF2B5EF4-FFF2-40B4-BE49-F238E27FC236}">
+                  <a16:creationId xmlns:a16="http://schemas.microsoft.com/office/drawing/2014/main" id="{B3D28B58-D871-A128-44C7-E9F0E35DAAEB}"/>
+                </a:ext>
+              </a:extLst>
+            </p:cNvPr>
+            <p:cNvSpPr/>
+            <p:nvPr/>
+          </p:nvSpPr>
+          <p:spPr>
+            <a:xfrm>
+              <a:off x="440418" y="5694830"/>
+              <a:ext cx="9183262" cy="973802"/>
+            </a:xfrm>
+            <a:prstGeom prst="rect">
+              <a:avLst/>
+            </a:prstGeom>
+            <a:solidFill>
+              <a:schemeClr val="accent1">
+                <a:lumMod val="75000"/>
+              </a:schemeClr>
+            </a:solidFill>
+          </p:spPr>
+          <p:style>
+            <a:lnRef idx="2">
+              <a:schemeClr val="accent1">
+                <a:shade val="50000"/>
+              </a:schemeClr>
+            </a:lnRef>
+            <a:fillRef idx="1">
+              <a:schemeClr val="accent1"/>
+            </a:fillRef>
+            <a:effectRef idx="0">
+              <a:schemeClr val="accent1"/>
+            </a:effectRef>
+            <a:fontRef idx="minor">
+              <a:schemeClr val="lt1"/>
+            </a:fontRef>
+          </p:style>
+          <p:txBody>
+            <a:bodyPr lIns="86970" tIns="43485" rIns="86970" bIns="43485" rtlCol="0" anchor="ctr"/>
+            <a:lstStyle/>
+            <a:p>
+              <a:pPr algn="ctr"/>
+              <a:r>
+                <a:rPr lang="en-US" sz="5400" b="1">
+                  <a:solidFill>
+                    <a:schemeClr val="accent3">
+                      <a:lumMod val="20000"/>
+                      <a:lumOff val="80000"/>
+                    </a:schemeClr>
+                  </a:solidFill>
+                </a:rPr>
+                <a:t>Introduction</a:t>
+              </a:r>
+            </a:p>
+          </p:txBody>
+        </p:sp>
+      </p:grpSp>
+      <p:pic>
+        <p:nvPicPr>
+          <p:cNvPr id="1029" name="Picture 5" descr="Schematic diagram of experimental setup.">
+            <a:extLst>
+              <a:ext uri="{FF2B5EF4-FFF2-40B4-BE49-F238E27FC236}">
+                <a16:creationId xmlns:a16="http://schemas.microsoft.com/office/drawing/2014/main" id="{FCA622DA-7B21-8627-4272-39CB7D6265CB}"/>
+              </a:ext>
+            </a:extLst>
+          </p:cNvPr>
+          <p:cNvPicPr>
+            <a:picLocks noChangeAspect="1" noChangeArrowheads="1"/>
+          </p:cNvPicPr>
+          <p:nvPr/>
+        </p:nvPicPr>
+        <p:blipFill>
+          <a:blip r:embed="rId4">
+            <a:extLst>
+              <a:ext uri="{28A0092B-C50C-407E-A947-70E740481C1C}">
+                <a14:useLocalDpi xmlns:a14="http://schemas.microsoft.com/office/drawing/2010/main" val="0"/>
+              </a:ext>
+            </a:extLst>
+          </a:blip>
+          <a:srcRect/>
+          <a:stretch>
+            <a:fillRect/>
+          </a:stretch>
+        </p:blipFill>
+        <p:spPr bwMode="auto">
+          <a:xfrm>
+            <a:off x="1482065" y="5725782"/>
+            <a:ext cx="4187216" cy="3359624"/>
+          </a:xfrm>
+          <a:prstGeom prst="rect">
+            <a:avLst/>
+          </a:prstGeom>
+          <a:noFill/>
+          <a:extLst>
+            <a:ext uri="{909E8E84-426E-40DD-AFC4-6F175D3DCCD1}">
+              <a14:hiddenFill xmlns:a14="http://schemas.microsoft.com/office/drawing/2010/main">
+                <a:solidFill>
+                  <a:srgbClr val="FFFFFF"/>
+                </a:solidFill>
+              </a14:hiddenFill>
+            </a:ext>
+          </a:extLst>
+        </p:spPr>
+      </p:pic>
+      <p:pic>
+        <p:nvPicPr>
+          <p:cNvPr id="60" name="Picture 59">
+            <a:extLst>
+              <a:ext uri="{FF2B5EF4-FFF2-40B4-BE49-F238E27FC236}">
+                <a16:creationId xmlns:a16="http://schemas.microsoft.com/office/drawing/2014/main" id="{2996D8F0-137B-63DD-86A7-74B0537DAB7C}"/>
+              </a:ext>
+            </a:extLst>
+          </p:cNvPr>
+          <p:cNvPicPr>
+            <a:picLocks noChangeAspect="1"/>
+          </p:cNvPicPr>
+          <p:nvPr/>
+        </p:nvPicPr>
+        <p:blipFill>
+          <a:blip r:embed="rId5"/>
+          <a:stretch>
+            <a:fillRect/>
+          </a:stretch>
+        </p:blipFill>
+        <p:spPr>
+          <a:xfrm>
+            <a:off x="1126647" y="13913567"/>
+            <a:ext cx="4777310" cy="3582982"/>
+          </a:xfrm>
+          <a:prstGeom prst="rect">
+            <a:avLst/>
+          </a:prstGeom>
+        </p:spPr>
+      </p:pic>
+      <p:grpSp>
+        <p:nvGrpSpPr>
+          <p:cNvPr id="61" name="Group 60">
+            <a:extLst>
+              <a:ext uri="{FF2B5EF4-FFF2-40B4-BE49-F238E27FC236}">
+                <a16:creationId xmlns:a16="http://schemas.microsoft.com/office/drawing/2014/main" id="{CE60D2E9-18EC-7A44-614B-498DB790D767}"/>
+              </a:ext>
+            </a:extLst>
+          </p:cNvPr>
+          <p:cNvGrpSpPr/>
+          <p:nvPr/>
+        </p:nvGrpSpPr>
+        <p:grpSpPr>
+          <a:xfrm>
+            <a:off x="229885" y="18199581"/>
+            <a:ext cx="6748634" cy="10958485"/>
+            <a:chOff x="440418" y="5694830"/>
+            <a:chExt cx="9183262" cy="10958485"/>
+          </a:xfrm>
+        </p:grpSpPr>
+        <p:sp>
+          <p:nvSpPr>
+            <p:cNvPr id="62" name="Text Box 189">
+              <a:extLst>
+                <a:ext uri="{FF2B5EF4-FFF2-40B4-BE49-F238E27FC236}">
+                  <a16:creationId xmlns:a16="http://schemas.microsoft.com/office/drawing/2014/main" id="{E7D69C59-0935-BBC8-C3FC-5D2657984F4D}"/>
+                </a:ext>
+              </a:extLst>
+            </p:cNvPr>
+            <p:cNvSpPr txBox="1">
+              <a:spLocks noChangeArrowheads="1"/>
+            </p:cNvSpPr>
+            <p:nvPr/>
+          </p:nvSpPr>
+          <p:spPr bwMode="auto">
+            <a:xfrm>
+              <a:off x="440418" y="6668631"/>
+              <a:ext cx="9183262" cy="9984684"/>
+            </a:xfrm>
+            <a:prstGeom prst="rect">
+              <a:avLst/>
+            </a:prstGeom>
+            <a:solidFill>
+              <a:schemeClr val="bg1"/>
+            </a:solidFill>
+            <a:ln w="12700">
+              <a:solidFill>
+                <a:schemeClr val="accent1">
+                  <a:lumMod val="75000"/>
+                </a:schemeClr>
+              </a:solidFill>
+            </a:ln>
+            <a:effectLst/>
+          </p:spPr>
+          <p:txBody>
+            <a:bodyPr wrap="square" lIns="173940" tIns="173940" rIns="173940" bIns="173940">
+              <a:spAutoFit/>
+            </a:bodyPr>
+            <a:lstStyle>
+              <a:lvl1pPr eaLnBrk="0" hangingPunct="0">
+                <a:defRPr sz="2200">
+                  <a:solidFill>
+                    <a:schemeClr val="tx1"/>
+                  </a:solidFill>
+                  <a:latin typeface="Arial" charset="0"/>
+                </a:defRPr>
+              </a:lvl1pPr>
+              <a:lvl2pPr marL="742950" indent="-285750" eaLnBrk="0" hangingPunct="0">
+                <a:defRPr sz="2200">
+                  <a:solidFill>
+                    <a:schemeClr val="tx1"/>
+                  </a:solidFill>
+                  <a:latin typeface="Arial" charset="0"/>
+                </a:defRPr>
+              </a:lvl2pPr>
+              <a:lvl3pPr marL="1143000" indent="-228600" eaLnBrk="0" hangingPunct="0">
+                <a:defRPr sz="2200">
+                  <a:solidFill>
+                    <a:schemeClr val="tx1"/>
+                  </a:solidFill>
+                  <a:latin typeface="Arial" charset="0"/>
+                </a:defRPr>
+              </a:lvl3pPr>
+              <a:lvl4pPr marL="1600200" indent="-228600" eaLnBrk="0" hangingPunct="0">
+                <a:defRPr sz="2200">
+                  <a:solidFill>
+                    <a:schemeClr val="tx1"/>
+                  </a:solidFill>
+                  <a:latin typeface="Arial" charset="0"/>
+                </a:defRPr>
+              </a:lvl4pPr>
+              <a:lvl5pPr marL="2057400" indent="-228600" eaLnBrk="0" hangingPunct="0">
+                <a:defRPr sz="2200">
+                  <a:solidFill>
+                    <a:schemeClr val="tx1"/>
+                  </a:solidFill>
+                  <a:latin typeface="Arial" charset="0"/>
+                </a:defRPr>
+              </a:lvl5pPr>
+              <a:lvl6pPr marL="2514600" indent="-228600" eaLnBrk="0" fontAlgn="base" hangingPunct="0">
+                <a:spcBef>
+                  <a:spcPct val="0"/>
+                </a:spcBef>
+                <a:spcAft>
+                  <a:spcPct val="0"/>
+                </a:spcAft>
+                <a:defRPr sz="2200">
+                  <a:solidFill>
+                    <a:schemeClr val="tx1"/>
+                  </a:solidFill>
+                  <a:latin typeface="Arial" charset="0"/>
+                </a:defRPr>
+              </a:lvl6pPr>
+              <a:lvl7pPr marL="2971800" indent="-228600" eaLnBrk="0" fontAlgn="base" hangingPunct="0">
+                <a:spcBef>
+                  <a:spcPct val="0"/>
+                </a:spcBef>
+                <a:spcAft>
+                  <a:spcPct val="0"/>
+                </a:spcAft>
+                <a:defRPr sz="2200">
+                  <a:solidFill>
+                    <a:schemeClr val="tx1"/>
+                  </a:solidFill>
+                  <a:latin typeface="Arial" charset="0"/>
+                </a:defRPr>
+              </a:lvl7pPr>
+              <a:lvl8pPr marL="3429000" indent="-228600" eaLnBrk="0" fontAlgn="base" hangingPunct="0">
+                <a:spcBef>
+                  <a:spcPct val="0"/>
+                </a:spcBef>
+                <a:spcAft>
+                  <a:spcPct val="0"/>
+                </a:spcAft>
+                <a:defRPr sz="2200">
+                  <a:solidFill>
+                    <a:schemeClr val="tx1"/>
+                  </a:solidFill>
+                  <a:latin typeface="Arial" charset="0"/>
+                </a:defRPr>
+              </a:lvl8pPr>
+              <a:lvl9pPr marL="3886200" indent="-228600" eaLnBrk="0" fontAlgn="base" hangingPunct="0">
+                <a:spcBef>
+                  <a:spcPct val="0"/>
+                </a:spcBef>
+                <a:spcAft>
+                  <a:spcPct val="0"/>
+                </a:spcAft>
+                <a:defRPr sz="2200">
+                  <a:solidFill>
+                    <a:schemeClr val="tx1"/>
+                  </a:solidFill>
+                  <a:latin typeface="Arial" charset="0"/>
+                </a:defRPr>
+              </a:lvl9pPr>
+            </a:lstStyle>
+            <a:p>
+              <a:pPr eaLnBrk="1" hangingPunct="1">
+                <a:spcAft>
+                  <a:spcPts val="600"/>
+                </a:spcAft>
+              </a:pPr>
+              <a:r>
+                <a:rPr lang="en-US" sz="2400" dirty="0">
+                  <a:latin typeface="+mn-lt"/>
+                </a:rPr>
+                <a:t>The project is conducted in </a:t>
+              </a:r>
+              <a:r>
+                <a:rPr lang="en-US" sz="2400" b="1" dirty="0">
+                  <a:latin typeface="+mn-lt"/>
+                </a:rPr>
+                <a:t>4 iterative phases</a:t>
+              </a:r>
+              <a:r>
+                <a:rPr lang="en-US" sz="2400" dirty="0">
+                  <a:latin typeface="+mn-lt"/>
+                </a:rPr>
+                <a:t>, each building on the previous one to enhance model performance and interpretability.</a:t>
+              </a:r>
+            </a:p>
+            <a:p>
+              <a:pPr eaLnBrk="1" hangingPunct="1">
+                <a:spcAft>
+                  <a:spcPts val="600"/>
+                </a:spcAft>
+              </a:pPr>
+              <a:r>
+                <a:rPr lang="en-US" sz="2400" b="1" dirty="0">
+                  <a:latin typeface="+mn-lt"/>
+                </a:rPr>
+                <a:t>Phase 1</a:t>
+              </a:r>
+              <a:r>
+                <a:rPr lang="en-US" sz="2400" dirty="0">
+                  <a:latin typeface="+mn-lt"/>
+                </a:rPr>
+                <a:t>: Baseline modeling with PCA-reduced OES features + discharge parameters.</a:t>
+              </a:r>
+            </a:p>
+            <a:p>
+              <a:pPr marL="342900" indent="-342900" eaLnBrk="1" hangingPunct="1">
+                <a:spcAft>
+                  <a:spcPts val="600"/>
+                </a:spcAft>
+                <a:buFont typeface="Arial" panose="020B0604020202020204" pitchFamily="34" charset="0"/>
+                <a:buChar char="•"/>
+              </a:pPr>
+              <a:r>
+                <a:rPr lang="en-US" sz="2400" dirty="0">
+                  <a:latin typeface="+mn-lt"/>
+                </a:rPr>
+                <a:t>Models tested: Ridge, PLS, SVR, </a:t>
+              </a:r>
+              <a:r>
+                <a:rPr lang="en-US" sz="2400" dirty="0" err="1">
+                  <a:latin typeface="+mn-lt"/>
+                </a:rPr>
+                <a:t>XGBoost</a:t>
+              </a:r>
+              <a:r>
+                <a:rPr lang="en-US" sz="2400" dirty="0">
+                  <a:latin typeface="+mn-lt"/>
+                </a:rPr>
+                <a:t>, RF, MLP, CNN.</a:t>
+              </a:r>
+            </a:p>
+            <a:p>
+              <a:pPr marL="342900" indent="-342900" eaLnBrk="1" hangingPunct="1">
+                <a:spcAft>
+                  <a:spcPts val="600"/>
+                </a:spcAft>
+                <a:buFont typeface="Arial" panose="020B0604020202020204" pitchFamily="34" charset="0"/>
+                <a:buChar char="•"/>
+              </a:pPr>
+              <a:r>
+                <a:rPr lang="en-US" sz="2400" dirty="0">
+                  <a:latin typeface="+mn-lt"/>
+                </a:rPr>
+                <a:t>Three configs of features are used as input data for models. </a:t>
+              </a:r>
+              <a:br>
+                <a:rPr lang="en-US" sz="2400" dirty="0">
+                  <a:latin typeface="+mn-lt"/>
+                </a:rPr>
+              </a:br>
+              <a:endParaRPr lang="en-US" sz="2400" dirty="0">
+                <a:latin typeface="+mn-lt"/>
+              </a:endParaRPr>
+            </a:p>
+            <a:p>
+              <a:pPr marL="342900" indent="-342900" eaLnBrk="1" hangingPunct="1">
+                <a:spcAft>
+                  <a:spcPts val="600"/>
+                </a:spcAft>
+                <a:buFont typeface="Arial" panose="020B0604020202020204" pitchFamily="34" charset="0"/>
+                <a:buChar char="•"/>
+              </a:pPr>
+              <a:endParaRPr lang="en-US" sz="2400" dirty="0">
+                <a:latin typeface="+mn-lt"/>
+              </a:endParaRPr>
+            </a:p>
+            <a:p>
+              <a:pPr eaLnBrk="1" hangingPunct="1">
+                <a:spcAft>
+                  <a:spcPts val="600"/>
+                </a:spcAft>
+              </a:pPr>
+              <a:r>
+                <a:rPr lang="en-US" sz="2400" b="1" dirty="0">
+                  <a:latin typeface="+mn-lt"/>
+                </a:rPr>
+                <a:t>Phase 2</a:t>
+              </a:r>
+              <a:r>
+                <a:rPr lang="en-US" sz="2400" dirty="0">
+                  <a:latin typeface="+mn-lt"/>
+                </a:rPr>
+                <a:t>: Hyperparameter tuning of nonlinear models (RF, MLP, CNN) using Bayesian optimization.</a:t>
+              </a:r>
+            </a:p>
+            <a:p>
+              <a:pPr marL="342900" indent="-342900" eaLnBrk="1" hangingPunct="1">
+                <a:spcAft>
+                  <a:spcPts val="600"/>
+                </a:spcAft>
+                <a:buFont typeface="Arial" panose="020B0604020202020204" pitchFamily="34" charset="0"/>
+                <a:buChar char="•"/>
+              </a:pPr>
+              <a:r>
+                <a:rPr lang="en-US" sz="2400" dirty="0">
+                  <a:latin typeface="+mn-lt"/>
+                </a:rPr>
+                <a:t>Applied </a:t>
+              </a:r>
+              <a:r>
+                <a:rPr lang="en-US" sz="2400" dirty="0" err="1">
+                  <a:latin typeface="+mn-lt"/>
+                </a:rPr>
+                <a:t>Optuna</a:t>
+              </a:r>
+              <a:r>
+                <a:rPr lang="en-US" sz="2400" dirty="0">
+                  <a:latin typeface="+mn-lt"/>
+                </a:rPr>
+                <a:t> (TPE sampler) with nested LOOCV. </a:t>
+              </a:r>
+            </a:p>
+            <a:p>
+              <a:pPr marL="342900" indent="-342900" eaLnBrk="1" hangingPunct="1">
+                <a:spcAft>
+                  <a:spcPts val="600"/>
+                </a:spcAft>
+                <a:buFont typeface="Arial" panose="020B0604020202020204" pitchFamily="34" charset="0"/>
+                <a:buChar char="•"/>
+              </a:pPr>
+              <a:r>
+                <a:rPr lang="en-US" sz="2400" dirty="0">
+                  <a:latin typeface="+mn-lt"/>
+                </a:rPr>
+                <a:t>Tuned RF, MLP and CNN with over 100 trails per model-config pair.</a:t>
+              </a:r>
+            </a:p>
+            <a:p>
+              <a:pPr eaLnBrk="1" hangingPunct="1">
+                <a:spcAft>
+                  <a:spcPts val="600"/>
+                </a:spcAft>
+              </a:pPr>
+              <a:r>
+                <a:rPr lang="en-US" sz="2400" b="1" dirty="0">
+                  <a:latin typeface="+mn-lt"/>
+                </a:rPr>
+                <a:t>Phase 3</a:t>
+              </a:r>
+              <a:r>
+                <a:rPr lang="en-US" sz="2400" dirty="0">
+                  <a:latin typeface="+mn-lt"/>
+                </a:rPr>
+                <a:t>: Manually construction input features based on plasma chemistry domain-knowledge.</a:t>
+              </a:r>
+            </a:p>
+            <a:p>
+              <a:pPr marL="342900" indent="-342900" eaLnBrk="1" hangingPunct="1">
+                <a:spcAft>
+                  <a:spcPts val="600"/>
+                </a:spcAft>
+                <a:buFont typeface="Arial" panose="020B0604020202020204" pitchFamily="34" charset="0"/>
+                <a:buChar char="•"/>
+              </a:pPr>
+              <a:r>
+                <a:rPr lang="en-US" altLang="zh-CN" sz="2400" dirty="0">
+                  <a:latin typeface="+mn-lt"/>
+                </a:rPr>
+                <a:t>Construct</a:t>
+              </a:r>
+              <a:r>
+                <a:rPr lang="en-US" sz="2400" dirty="0">
+                  <a:latin typeface="+mn-lt"/>
+                </a:rPr>
+                <a:t> physically meaningful features</a:t>
+              </a:r>
+              <a:r>
+                <a:rPr lang="zh-CN" altLang="en-US" sz="2400" dirty="0">
+                  <a:latin typeface="+mn-lt"/>
+                </a:rPr>
+                <a:t> </a:t>
+              </a:r>
+              <a:r>
+                <a:rPr lang="en-US" altLang="zh-CN" sz="2400" dirty="0">
+                  <a:latin typeface="+mn-lt"/>
+                </a:rPr>
+                <a:t>instead</a:t>
+              </a:r>
+              <a:r>
+                <a:rPr lang="zh-CN" altLang="en-US" sz="2400" dirty="0">
+                  <a:latin typeface="+mn-lt"/>
+                </a:rPr>
+                <a:t> </a:t>
+              </a:r>
+              <a:r>
+                <a:rPr lang="en-US" altLang="zh-CN" sz="2400" dirty="0">
+                  <a:latin typeface="+mn-lt"/>
+                </a:rPr>
+                <a:t>of</a:t>
+              </a:r>
+              <a:r>
+                <a:rPr lang="zh-CN" altLang="en-US" sz="2400" dirty="0">
+                  <a:latin typeface="+mn-lt"/>
+                </a:rPr>
+                <a:t> </a:t>
+              </a:r>
+              <a:r>
+                <a:rPr lang="en-US" sz="2400" dirty="0">
+                  <a:latin typeface="+mn-lt"/>
+                </a:rPr>
+                <a:t>PCA-selected OES components</a:t>
+              </a:r>
+              <a:r>
+                <a:rPr lang="en-US" altLang="zh-CN" sz="2400" dirty="0">
+                  <a:latin typeface="+mn-lt"/>
+                </a:rPr>
+                <a:t>.</a:t>
+              </a:r>
+            </a:p>
+            <a:p>
+              <a:pPr marL="342900" indent="-342900" eaLnBrk="1" hangingPunct="1">
+                <a:spcAft>
+                  <a:spcPts val="600"/>
+                </a:spcAft>
+                <a:buFont typeface="Arial" panose="020B0604020202020204" pitchFamily="34" charset="0"/>
+                <a:buChar char="•"/>
+              </a:pPr>
+              <a:r>
+                <a:rPr lang="en-US" altLang="zh-CN" sz="2400" dirty="0">
+                  <a:latin typeface="+mn-lt"/>
+                </a:rPr>
+                <a:t>U</a:t>
+              </a:r>
+              <a:r>
+                <a:rPr lang="en-US" sz="2400" dirty="0">
+                  <a:latin typeface="+mn-lt"/>
+                </a:rPr>
+                <a:t>pdate three </a:t>
+              </a:r>
+              <a:r>
+                <a:rPr lang="en-US" altLang="zh-CN" sz="2400" dirty="0">
+                  <a:latin typeface="+mn-lt"/>
+                </a:rPr>
+                <a:t>training</a:t>
+              </a:r>
+              <a:r>
+                <a:rPr lang="zh-CN" altLang="en-US" sz="2400" dirty="0">
+                  <a:latin typeface="+mn-lt"/>
+                </a:rPr>
+                <a:t> </a:t>
+              </a:r>
+              <a:r>
+                <a:rPr lang="en-US" altLang="zh-CN" sz="2400" dirty="0">
+                  <a:latin typeface="+mn-lt"/>
+                </a:rPr>
+                <a:t>input</a:t>
+              </a:r>
+              <a:r>
+                <a:rPr lang="zh-CN" altLang="en-US" sz="2400" dirty="0">
+                  <a:latin typeface="+mn-lt"/>
+                </a:rPr>
+                <a:t> </a:t>
+              </a:r>
+              <a:r>
+                <a:rPr lang="en-US" sz="2400" dirty="0">
+                  <a:latin typeface="+mn-lt"/>
+                </a:rPr>
+                <a:t>configs</a:t>
+              </a:r>
+              <a:r>
+                <a:rPr lang="zh-CN" altLang="en-US" sz="2400" dirty="0">
+                  <a:latin typeface="+mn-lt"/>
+                </a:rPr>
+                <a:t> </a:t>
+              </a:r>
+              <a:r>
+                <a:rPr lang="en-US" altLang="zh-CN" sz="2400" dirty="0">
+                  <a:latin typeface="+mn-lt"/>
+                </a:rPr>
+                <a:t>with</a:t>
+              </a:r>
+              <a:r>
+                <a:rPr lang="zh-CN" altLang="en-US" sz="2400" dirty="0">
+                  <a:latin typeface="+mn-lt"/>
+                </a:rPr>
+                <a:t> </a:t>
+              </a:r>
+              <a:r>
+                <a:rPr lang="en-US" altLang="zh-CN" sz="2400" dirty="0">
+                  <a:latin typeface="+mn-lt"/>
+                </a:rPr>
+                <a:t>new</a:t>
+              </a:r>
+              <a:r>
+                <a:rPr lang="zh-CN" altLang="en-US" sz="2400" dirty="0">
+                  <a:latin typeface="+mn-lt"/>
+                </a:rPr>
+                <a:t> </a:t>
+              </a:r>
+              <a:r>
+                <a:rPr lang="en-US" altLang="zh-CN" sz="2400" dirty="0">
+                  <a:latin typeface="+mn-lt"/>
+                </a:rPr>
+                <a:t>features</a:t>
+              </a:r>
+              <a:r>
+                <a:rPr lang="en-US" sz="2400" dirty="0">
+                  <a:latin typeface="+mn-lt"/>
+                </a:rPr>
+                <a:t>.</a:t>
+              </a:r>
+            </a:p>
+          </p:txBody>
+        </p:sp>
+        <p:sp>
+          <p:nvSpPr>
+            <p:cNvPr id="63" name="Rectangle 62">
+              <a:extLst>
+                <a:ext uri="{FF2B5EF4-FFF2-40B4-BE49-F238E27FC236}">
+                  <a16:creationId xmlns:a16="http://schemas.microsoft.com/office/drawing/2014/main" id="{384DA1A1-38BF-844A-D549-D04E388006A4}"/>
+                </a:ext>
+              </a:extLst>
+            </p:cNvPr>
+            <p:cNvSpPr/>
+            <p:nvPr/>
+          </p:nvSpPr>
+          <p:spPr>
+            <a:xfrm>
+              <a:off x="440418" y="5694830"/>
+              <a:ext cx="9183262" cy="973802"/>
+            </a:xfrm>
+            <a:prstGeom prst="rect">
+              <a:avLst/>
+            </a:prstGeom>
+            <a:solidFill>
+              <a:schemeClr val="accent1">
+                <a:lumMod val="75000"/>
+              </a:schemeClr>
+            </a:solidFill>
+          </p:spPr>
+          <p:style>
+            <a:lnRef idx="2">
+              <a:schemeClr val="accent1">
+                <a:shade val="50000"/>
+              </a:schemeClr>
+            </a:lnRef>
+            <a:fillRef idx="1">
+              <a:schemeClr val="accent1"/>
+            </a:fillRef>
+            <a:effectRef idx="0">
+              <a:schemeClr val="accent1"/>
+            </a:effectRef>
+            <a:fontRef idx="minor">
+              <a:schemeClr val="lt1"/>
+            </a:fontRef>
+          </p:style>
+          <p:txBody>
+            <a:bodyPr lIns="86970" tIns="43485" rIns="86970" bIns="43485" rtlCol="0" anchor="ctr"/>
+            <a:lstStyle/>
+            <a:p>
+              <a:pPr algn="ctr"/>
+              <a:r>
+                <a:rPr lang="en-US" sz="5400" b="1" dirty="0">
+                  <a:solidFill>
+                    <a:schemeClr val="accent3">
+                      <a:lumMod val="20000"/>
+                      <a:lumOff val="80000"/>
+                    </a:schemeClr>
+                  </a:solidFill>
+                </a:rPr>
+                <a:t>Methodology</a:t>
+              </a:r>
+            </a:p>
+          </p:txBody>
+        </p:sp>
+      </p:grpSp>
+      <p:pic>
+        <p:nvPicPr>
+          <p:cNvPr id="1026" name="Picture 1025">
+            <a:extLst>
+              <a:ext uri="{FF2B5EF4-FFF2-40B4-BE49-F238E27FC236}">
+                <a16:creationId xmlns:a16="http://schemas.microsoft.com/office/drawing/2014/main" id="{F60A19EB-6313-5386-3248-D7D54E3A51AE}"/>
+              </a:ext>
+            </a:extLst>
+          </p:cNvPr>
+          <p:cNvPicPr>
+            <a:picLocks noChangeAspect="1"/>
+          </p:cNvPicPr>
+          <p:nvPr/>
+        </p:nvPicPr>
+        <p:blipFill>
+          <a:blip r:embed="rId6"/>
+          <a:stretch>
+            <a:fillRect/>
+          </a:stretch>
+        </p:blipFill>
+        <p:spPr>
+          <a:xfrm>
+            <a:off x="2904647" y="22805945"/>
+            <a:ext cx="4067653" cy="1062875"/>
+          </a:xfrm>
+          <a:prstGeom prst="rect">
+            <a:avLst/>
+          </a:prstGeom>
+        </p:spPr>
+      </p:pic>
+      <p:sp>
+        <p:nvSpPr>
+          <p:cNvPr id="1028" name="Rectangle 1027">
+            <a:extLst>
+              <a:ext uri="{FF2B5EF4-FFF2-40B4-BE49-F238E27FC236}">
+                <a16:creationId xmlns:a16="http://schemas.microsoft.com/office/drawing/2014/main" id="{730FCA34-DC1C-7B2E-3263-D5908DF662D8}"/>
+              </a:ext>
+            </a:extLst>
+          </p:cNvPr>
+          <p:cNvSpPr/>
+          <p:nvPr/>
+        </p:nvSpPr>
+        <p:spPr>
+          <a:xfrm>
+            <a:off x="0" y="29301411"/>
+            <a:ext cx="21695418" cy="973802"/>
+          </a:xfrm>
+          <a:prstGeom prst="rect">
+            <a:avLst/>
+          </a:prstGeom>
+          <a:solidFill>
+            <a:srgbClr val="355F93"/>
+          </a:solidFill>
+          <a:ln>
+            <a:noFill/>
+          </a:ln>
+        </p:spPr>
+        <p:style>
+          <a:lnRef idx="2">
+            <a:schemeClr val="accent1">
+              <a:shade val="15000"/>
+            </a:schemeClr>
+          </a:lnRef>
+          <a:fillRef idx="1">
+            <a:schemeClr val="accent1"/>
+          </a:fillRef>
+          <a:effectRef idx="0">
+            <a:schemeClr val="accent1"/>
+          </a:effectRef>
+          <a:fontRef idx="minor">
+            <a:schemeClr val="lt1"/>
+          </a:fontRef>
+        </p:style>
+        <p:txBody>
+          <a:bodyPr rtlCol="0" anchor="ctr"/>
+          <a:lstStyle/>
+          <a:p>
+            <a:pPr algn="ctr"/>
+            <a:r>
+              <a:rPr lang="en-US" altLang="zh-CN" sz="4096" dirty="0"/>
+              <a:t>`</a:t>
+            </a:r>
+            <a:endParaRPr lang="en-CN" sz="4096" dirty="0"/>
+          </a:p>
+        </p:txBody>
+      </p:sp>
+      <p:sp>
+        <p:nvSpPr>
+          <p:cNvPr id="1031" name="Text Box 189">
+            <a:extLst>
+              <a:ext uri="{FF2B5EF4-FFF2-40B4-BE49-F238E27FC236}">
+                <a16:creationId xmlns:a16="http://schemas.microsoft.com/office/drawing/2014/main" id="{A3F1484F-2201-0648-A414-29FF4773B7EA}"/>
+              </a:ext>
+            </a:extLst>
+          </p:cNvPr>
+          <p:cNvSpPr txBox="1">
+            <a:spLocks noChangeArrowheads="1"/>
+          </p:cNvSpPr>
+          <p:nvPr/>
+        </p:nvSpPr>
+        <p:spPr bwMode="auto">
+          <a:xfrm>
+            <a:off x="7348061" y="3091330"/>
+            <a:ext cx="6724016" cy="5737367"/>
+          </a:xfrm>
+          <a:prstGeom prst="rect">
+            <a:avLst/>
+          </a:prstGeom>
+          <a:solidFill>
+            <a:schemeClr val="bg1"/>
+          </a:solidFill>
+          <a:ln w="12700">
+            <a:solidFill>
+              <a:schemeClr val="accent1">
+                <a:lumMod val="75000"/>
+              </a:schemeClr>
+            </a:solidFill>
+          </a:ln>
+          <a:effectLst/>
+        </p:spPr>
+        <p:txBody>
+          <a:bodyPr wrap="square" lIns="173940" tIns="173940" rIns="173940" bIns="173940">
+            <a:spAutoFit/>
+          </a:bodyPr>
+          <a:lstStyle>
+            <a:lvl1pPr eaLnBrk="0" hangingPunct="0">
+              <a:defRPr sz="2200">
+                <a:solidFill>
+                  <a:schemeClr val="tx1"/>
+                </a:solidFill>
+                <a:latin typeface="Arial" charset="0"/>
+              </a:defRPr>
+            </a:lvl1pPr>
+            <a:lvl2pPr marL="742950" indent="-285750" eaLnBrk="0" hangingPunct="0">
+              <a:defRPr sz="2200">
+                <a:solidFill>
+                  <a:schemeClr val="tx1"/>
+                </a:solidFill>
+                <a:latin typeface="Arial" charset="0"/>
+              </a:defRPr>
+            </a:lvl2pPr>
+            <a:lvl3pPr marL="1143000" indent="-228600" eaLnBrk="0" hangingPunct="0">
+              <a:defRPr sz="2200">
+                <a:solidFill>
+                  <a:schemeClr val="tx1"/>
+                </a:solidFill>
+                <a:latin typeface="Arial" charset="0"/>
+              </a:defRPr>
+            </a:lvl3pPr>
+            <a:lvl4pPr marL="1600200" indent="-228600" eaLnBrk="0" hangingPunct="0">
+              <a:defRPr sz="2200">
+                <a:solidFill>
+                  <a:schemeClr val="tx1"/>
+                </a:solidFill>
+                <a:latin typeface="Arial" charset="0"/>
+              </a:defRPr>
+            </a:lvl4pPr>
+            <a:lvl5pPr marL="2057400" indent="-228600" eaLnBrk="0" hangingPunct="0">
+              <a:defRPr sz="2200">
+                <a:solidFill>
+                  <a:schemeClr val="tx1"/>
+                </a:solidFill>
+                <a:latin typeface="Arial" charset="0"/>
+              </a:defRPr>
+            </a:lvl5pPr>
+            <a:lvl6pPr marL="2514600" indent="-228600" eaLnBrk="0" fontAlgn="base" hangingPunct="0">
+              <a:spcBef>
+                <a:spcPct val="0"/>
+              </a:spcBef>
+              <a:spcAft>
+                <a:spcPct val="0"/>
+              </a:spcAft>
+              <a:defRPr sz="2200">
+                <a:solidFill>
+                  <a:schemeClr val="tx1"/>
+                </a:solidFill>
+                <a:latin typeface="Arial" charset="0"/>
+              </a:defRPr>
+            </a:lvl6pPr>
+            <a:lvl7pPr marL="2971800" indent="-228600" eaLnBrk="0" fontAlgn="base" hangingPunct="0">
+              <a:spcBef>
+                <a:spcPct val="0"/>
+              </a:spcBef>
+              <a:spcAft>
+                <a:spcPct val="0"/>
+              </a:spcAft>
+              <a:defRPr sz="2200">
+                <a:solidFill>
+                  <a:schemeClr val="tx1"/>
+                </a:solidFill>
+                <a:latin typeface="Arial" charset="0"/>
+              </a:defRPr>
+            </a:lvl7pPr>
+            <a:lvl8pPr marL="3429000" indent="-228600" eaLnBrk="0" fontAlgn="base" hangingPunct="0">
+              <a:spcBef>
+                <a:spcPct val="0"/>
+              </a:spcBef>
+              <a:spcAft>
+                <a:spcPct val="0"/>
+              </a:spcAft>
+              <a:defRPr sz="2200">
+                <a:solidFill>
+                  <a:schemeClr val="tx1"/>
+                </a:solidFill>
+                <a:latin typeface="Arial" charset="0"/>
+              </a:defRPr>
+            </a:lvl8pPr>
+            <a:lvl9pPr marL="3886200" indent="-228600" eaLnBrk="0" fontAlgn="base" hangingPunct="0">
+              <a:spcBef>
+                <a:spcPct val="0"/>
+              </a:spcBef>
+              <a:spcAft>
+                <a:spcPct val="0"/>
+              </a:spcAft>
+              <a:defRPr sz="2200">
+                <a:solidFill>
+                  <a:schemeClr val="tx1"/>
+                </a:solidFill>
+                <a:latin typeface="Arial" charset="0"/>
+              </a:defRPr>
+            </a:lvl9pPr>
+          </a:lstStyle>
+          <a:p>
+            <a:r>
+              <a:rPr lang="en-US" sz="2400" b="1" dirty="0">
+                <a:latin typeface="+mn-lt"/>
+              </a:rPr>
+              <a:t>P</a:t>
+            </a:r>
+            <a:r>
+              <a:rPr lang="en-US" altLang="zh-CN" sz="2400" b="1" dirty="0">
+                <a:latin typeface="+mn-lt"/>
+              </a:rPr>
+              <a:t>hase</a:t>
+            </a:r>
+            <a:r>
+              <a:rPr lang="zh-CN" altLang="en-US" sz="2400" b="1" dirty="0">
+                <a:latin typeface="+mn-lt"/>
+              </a:rPr>
+              <a:t> </a:t>
+            </a:r>
+            <a:r>
+              <a:rPr lang="en-US" altLang="zh-CN" sz="2400" b="1" dirty="0">
+                <a:latin typeface="+mn-lt"/>
+              </a:rPr>
+              <a:t>4:</a:t>
+            </a:r>
+            <a:r>
+              <a:rPr lang="en-US" altLang="zh-CN" sz="2400" dirty="0">
+                <a:latin typeface="+mn-lt"/>
+              </a:rPr>
+              <a:t> </a:t>
+            </a:r>
+            <a:r>
+              <a:rPr lang="en-US" dirty="0"/>
+              <a:t>Interpretability analysis and feature reduction via multi-model consensus and backward elimination</a:t>
+            </a:r>
+          </a:p>
+          <a:p>
+            <a:pPr marL="342900" indent="-342900">
+              <a:buFont typeface="Arial" panose="020B0604020202020204" pitchFamily="34" charset="0"/>
+              <a:buChar char="•"/>
+            </a:pPr>
+            <a:r>
+              <a:rPr lang="en-US" dirty="0"/>
+              <a:t>Evaluate feature importance for each model via different methods.</a:t>
+            </a:r>
+          </a:p>
+          <a:p>
+            <a:endParaRPr lang="en-US" dirty="0"/>
+          </a:p>
+          <a:p>
+            <a:pPr eaLnBrk="1" hangingPunct="1"/>
+            <a:endParaRPr lang="en-US" sz="2400" dirty="0">
+              <a:latin typeface="+mn-lt"/>
+            </a:endParaRPr>
+          </a:p>
+          <a:p>
+            <a:pPr eaLnBrk="1" hangingPunct="1"/>
+            <a:endParaRPr lang="en-US" sz="2400" dirty="0">
+              <a:latin typeface="+mn-lt"/>
+            </a:endParaRPr>
+          </a:p>
+          <a:p>
+            <a:pPr eaLnBrk="1" hangingPunct="1"/>
+            <a:endParaRPr lang="en-US" sz="2400" dirty="0">
+              <a:latin typeface="+mn-lt"/>
+            </a:endParaRPr>
+          </a:p>
+          <a:p>
+            <a:pPr eaLnBrk="1" hangingPunct="1"/>
+            <a:endParaRPr lang="en-US" sz="2400" dirty="0">
+              <a:latin typeface="+mn-lt"/>
+            </a:endParaRPr>
+          </a:p>
+          <a:p>
+            <a:pPr marL="342900" indent="-342900" eaLnBrk="1" hangingPunct="1">
+              <a:buFont typeface="Arial" panose="020B0604020202020204" pitchFamily="34" charset="0"/>
+              <a:buChar char="•"/>
+            </a:pPr>
+            <a:r>
+              <a:rPr lang="en-US" sz="2400" dirty="0">
+                <a:latin typeface="+mn-lt"/>
+              </a:rPr>
+              <a:t>Evaluate R</a:t>
+            </a:r>
+            <a:r>
+              <a:rPr lang="en-US" sz="2400" baseline="30000" dirty="0">
+                <a:latin typeface="+mn-lt"/>
+              </a:rPr>
+              <a:t>2</a:t>
+            </a:r>
+            <a:r>
+              <a:rPr lang="en-US" sz="2400" dirty="0">
+                <a:latin typeface="+mn-lt"/>
+              </a:rPr>
+              <a:t> </a:t>
+            </a:r>
+            <a:r>
+              <a:rPr lang="en-US" sz="2400" dirty="0"/>
+              <a:t>confidence interval </a:t>
+            </a:r>
+            <a:r>
+              <a:rPr lang="en-US" sz="2400" dirty="0">
+                <a:latin typeface="+mn-lt"/>
+              </a:rPr>
+              <a:t>of  Ridge and PLS using bootstrap resampling, </a:t>
+            </a:r>
+          </a:p>
+          <a:p>
+            <a:pPr marL="342900" indent="-342900" eaLnBrk="1" hangingPunct="1">
+              <a:buFont typeface="Arial" panose="020B0604020202020204" pitchFamily="34" charset="0"/>
+              <a:buChar char="•"/>
+            </a:pPr>
+            <a:r>
+              <a:rPr lang="en-US" sz="2400" dirty="0">
+                <a:latin typeface="+mn-lt"/>
+              </a:rPr>
+              <a:t>Examine the overall best model and config via eliminating features.</a:t>
+            </a:r>
+          </a:p>
+          <a:p>
+            <a:pPr eaLnBrk="1" hangingPunct="1"/>
+            <a:endParaRPr lang="en-US" sz="2400" dirty="0">
+              <a:latin typeface="+mn-lt"/>
+            </a:endParaRPr>
+          </a:p>
+        </p:txBody>
+      </p:sp>
+      <p:pic>
+        <p:nvPicPr>
+          <p:cNvPr id="1033" name="Picture 1032">
+            <a:extLst>
+              <a:ext uri="{FF2B5EF4-FFF2-40B4-BE49-F238E27FC236}">
+                <a16:creationId xmlns:a16="http://schemas.microsoft.com/office/drawing/2014/main" id="{034E1230-AC65-D4BF-2133-4BB6ECEC2587}"/>
+              </a:ext>
+            </a:extLst>
+          </p:cNvPr>
+          <p:cNvPicPr>
+            <a:picLocks noChangeAspect="1"/>
+          </p:cNvPicPr>
+          <p:nvPr/>
+        </p:nvPicPr>
+        <p:blipFill>
+          <a:blip r:embed="rId7"/>
+          <a:stretch>
+            <a:fillRect/>
+          </a:stretch>
+        </p:blipFill>
+        <p:spPr>
+          <a:xfrm>
+            <a:off x="7796413" y="4998748"/>
+            <a:ext cx="5827312" cy="1789890"/>
+          </a:xfrm>
+          <a:prstGeom prst="rect">
+            <a:avLst/>
+          </a:prstGeom>
+        </p:spPr>
+      </p:pic>
     </p:spTree>
     <p:extLst>
       <p:ext uri="{BB962C8B-B14F-4D97-AF65-F5344CB8AC3E}">

</xml_diff>

<commit_message>
Update presentation and document files with revised content and corrections
</commit_message>
<xml_diff>
--- a/bench inspection poster/Presentation2.pptx
+++ b/bench inspection poster/Presentation2.pptx
@@ -107,6 +107,11 @@
       </a:defRPr>
     </a:lvl9pPr>
   </p:defaultTextStyle>
+  <p:extLst>
+    <p:ext uri="{EFAFB233-063F-42B5-8137-9DF3F51BA10A}">
+      <p15:sldGuideLst xmlns:p15="http://schemas.microsoft.com/office/powerpoint/2012/main"/>
+    </p:ext>
+  </p:extLst>
 </p:presentation>
 </file>
 
@@ -192,7 +197,7 @@
           <a:p>
             <a:fld id="{A7312384-EEA0-B942-9C1C-50C8244C080B}" type="datetimeFigureOut">
               <a:rPr lang="en-CN" smtClean="0"/>
-              <a:t>2026/3/10</a:t>
+              <a:t>2026/3/14</a:t>
             </a:fld>
             <a:endParaRPr lang="en-CN"/>
           </a:p>
@@ -680,7 +685,7 @@
           <a:p>
             <a:fld id="{E82979C4-88EC-9C4B-9267-35BA343BA14B}" type="datetimeFigureOut">
               <a:rPr lang="en-CN" smtClean="0"/>
-              <a:t>2026/3/10</a:t>
+              <a:t>2026/3/14</a:t>
             </a:fld>
             <a:endParaRPr lang="en-CN"/>
           </a:p>
@@ -850,7 +855,7 @@
           <a:p>
             <a:fld id="{E82979C4-88EC-9C4B-9267-35BA343BA14B}" type="datetimeFigureOut">
               <a:rPr lang="en-CN" smtClean="0"/>
-              <a:t>2026/3/10</a:t>
+              <a:t>2026/3/14</a:t>
             </a:fld>
             <a:endParaRPr lang="en-CN"/>
           </a:p>
@@ -1030,7 +1035,7 @@
           <a:p>
             <a:fld id="{E82979C4-88EC-9C4B-9267-35BA343BA14B}" type="datetimeFigureOut">
               <a:rPr lang="en-CN" smtClean="0"/>
-              <a:t>2026/3/10</a:t>
+              <a:t>2026/3/14</a:t>
             </a:fld>
             <a:endParaRPr lang="en-CN"/>
           </a:p>
@@ -1200,7 +1205,7 @@
           <a:p>
             <a:fld id="{E82979C4-88EC-9C4B-9267-35BA343BA14B}" type="datetimeFigureOut">
               <a:rPr lang="en-CN" smtClean="0"/>
-              <a:t>2026/3/10</a:t>
+              <a:t>2026/3/14</a:t>
             </a:fld>
             <a:endParaRPr lang="en-CN"/>
           </a:p>
@@ -1446,7 +1451,7 @@
           <a:p>
             <a:fld id="{E82979C4-88EC-9C4B-9267-35BA343BA14B}" type="datetimeFigureOut">
               <a:rPr lang="en-CN" smtClean="0"/>
-              <a:t>2026/3/10</a:t>
+              <a:t>2026/3/14</a:t>
             </a:fld>
             <a:endParaRPr lang="en-CN"/>
           </a:p>
@@ -1678,7 +1683,7 @@
           <a:p>
             <a:fld id="{E82979C4-88EC-9C4B-9267-35BA343BA14B}" type="datetimeFigureOut">
               <a:rPr lang="en-CN" smtClean="0"/>
-              <a:t>2026/3/10</a:t>
+              <a:t>2026/3/14</a:t>
             </a:fld>
             <a:endParaRPr lang="en-CN"/>
           </a:p>
@@ -2045,7 +2050,7 @@
           <a:p>
             <a:fld id="{E82979C4-88EC-9C4B-9267-35BA343BA14B}" type="datetimeFigureOut">
               <a:rPr lang="en-CN" smtClean="0"/>
-              <a:t>2026/3/10</a:t>
+              <a:t>2026/3/14</a:t>
             </a:fld>
             <a:endParaRPr lang="en-CN"/>
           </a:p>
@@ -2163,7 +2168,7 @@
           <a:p>
             <a:fld id="{E82979C4-88EC-9C4B-9267-35BA343BA14B}" type="datetimeFigureOut">
               <a:rPr lang="en-CN" smtClean="0"/>
-              <a:t>2026/3/10</a:t>
+              <a:t>2026/3/14</a:t>
             </a:fld>
             <a:endParaRPr lang="en-CN"/>
           </a:p>
@@ -2258,7 +2263,7 @@
           <a:p>
             <a:fld id="{E82979C4-88EC-9C4B-9267-35BA343BA14B}" type="datetimeFigureOut">
               <a:rPr lang="en-CN" smtClean="0"/>
-              <a:t>2026/3/10</a:t>
+              <a:t>2026/3/14</a:t>
             </a:fld>
             <a:endParaRPr lang="en-CN"/>
           </a:p>
@@ -2535,7 +2540,7 @@
           <a:p>
             <a:fld id="{E82979C4-88EC-9C4B-9267-35BA343BA14B}" type="datetimeFigureOut">
               <a:rPr lang="en-CN" smtClean="0"/>
-              <a:t>2026/3/10</a:t>
+              <a:t>2026/3/14</a:t>
             </a:fld>
             <a:endParaRPr lang="en-CN"/>
           </a:p>
@@ -2792,7 +2797,7 @@
           <a:p>
             <a:fld id="{E82979C4-88EC-9C4B-9267-35BA343BA14B}" type="datetimeFigureOut">
               <a:rPr lang="en-CN" smtClean="0"/>
-              <a:t>2026/3/10</a:t>
+              <a:t>2026/3/14</a:t>
             </a:fld>
             <a:endParaRPr lang="en-CN"/>
           </a:p>
@@ -3005,7 +3010,7 @@
           <a:p>
             <a:fld id="{E82979C4-88EC-9C4B-9267-35BA343BA14B}" type="datetimeFigureOut">
               <a:rPr lang="en-CN" smtClean="0"/>
-              <a:t>2026/3/10</a:t>
+              <a:t>2026/3/14</a:t>
             </a:fld>
             <a:endParaRPr lang="en-CN"/>
           </a:p>
@@ -3412,6 +3417,62 @@
       </p:grpSpPr>
       <p:sp>
         <p:nvSpPr>
+          <p:cNvPr id="1028" name="Rectangle 1027">
+            <a:extLst>
+              <a:ext uri="{FF2B5EF4-FFF2-40B4-BE49-F238E27FC236}">
+                <a16:creationId xmlns:a16="http://schemas.microsoft.com/office/drawing/2014/main" id="{730FCA34-DC1C-7B2E-3263-D5908DF662D8}"/>
+              </a:ext>
+            </a:extLst>
+          </p:cNvPr>
+          <p:cNvSpPr/>
+          <p:nvPr/>
+        </p:nvSpPr>
+        <p:spPr>
+          <a:xfrm>
+            <a:off x="0" y="29301411"/>
+            <a:ext cx="21695418" cy="973802"/>
+          </a:xfrm>
+          <a:prstGeom prst="rect">
+            <a:avLst/>
+          </a:prstGeom>
+          <a:solidFill>
+            <a:srgbClr val="355F93"/>
+          </a:solidFill>
+          <a:ln>
+            <a:noFill/>
+          </a:ln>
+        </p:spPr>
+        <p:style>
+          <a:lnRef idx="2">
+            <a:schemeClr val="accent1">
+              <a:shade val="15000"/>
+            </a:schemeClr>
+          </a:lnRef>
+          <a:fillRef idx="1">
+            <a:schemeClr val="accent1"/>
+          </a:fillRef>
+          <a:effectRef idx="0">
+            <a:schemeClr val="accent1"/>
+          </a:effectRef>
+          <a:fontRef idx="minor">
+            <a:schemeClr val="lt1"/>
+          </a:fontRef>
+        </p:style>
+        <p:txBody>
+          <a:bodyPr rtlCol="0" anchor="ctr"/>
+          <a:lstStyle/>
+          <a:p>
+            <a:pPr algn="ctr"/>
+            <a:r>
+              <a:rPr lang="en-US" altLang="zh-CN" sz="4096" dirty="0"/>
+              <a:t>`</a:t>
+            </a:r>
+            <a:endParaRPr lang="en-CN" sz="4096" dirty="0"/>
+          </a:p>
+        </p:txBody>
+      </p:sp>
+      <p:sp>
+        <p:nvSpPr>
           <p:cNvPr id="5" name="Rectangle 4">
             <a:extLst>
               <a:ext uri="{FF2B5EF4-FFF2-40B4-BE49-F238E27FC236}">
@@ -3665,10 +3726,10 @@
         </p:nvGrpSpPr>
         <p:grpSpPr>
           <a:xfrm>
-            <a:off x="7348061" y="9085406"/>
-            <a:ext cx="6724016" cy="8711716"/>
+            <a:off x="7348061" y="16387456"/>
+            <a:ext cx="6724016" cy="12774366"/>
             <a:chOff x="440418" y="5694830"/>
-            <a:chExt cx="9183262" cy="8711716"/>
+            <a:chExt cx="9183262" cy="12774366"/>
           </a:xfrm>
         </p:grpSpPr>
         <p:sp>
@@ -3688,7 +3749,7 @@
           <p:spPr bwMode="auto">
             <a:xfrm>
               <a:off x="440418" y="6668631"/>
-              <a:ext cx="9183262" cy="7737915"/>
+              <a:ext cx="9183262" cy="11800565"/>
             </a:xfrm>
             <a:prstGeom prst="rect">
               <a:avLst/>
@@ -3808,60 +3869,401 @@
               </a:lvl9pPr>
             </a:lstStyle>
             <a:p>
-              <a:pPr eaLnBrk="1" hangingPunct="1"/>
+              <a:pPr marL="0" marR="0" lvl="0" indent="0" defTabSz="457200" rtl="0" eaLnBrk="1" fontAlgn="auto" latinLnBrk="0" hangingPunct="1">
+                <a:lnSpc>
+                  <a:spcPct val="100000"/>
+                </a:lnSpc>
+                <a:spcBef>
+                  <a:spcPts val="0"/>
+                </a:spcBef>
+                <a:spcAft>
+                  <a:spcPts val="1200"/>
+                </a:spcAft>
+                <a:buClrTx/>
+                <a:buSzTx/>
+                <a:buFontTx/>
+                <a:buNone/>
+                <a:tabLst/>
+                <a:defRPr/>
+              </a:pPr>
               <a:r>
-                <a:rPr lang="en-US" sz="3200" dirty="0">
+                <a:rPr kumimoji="0" lang="en-US" sz="2400" b="0" i="0" u="none" strike="noStrike" kern="1200" cap="none" spc="0" normalizeH="0" baseline="0" noProof="0" dirty="0">
+                  <a:ln>
+                    <a:noFill/>
+                  </a:ln>
+                  <a:solidFill>
+                    <a:prstClr val="black"/>
+                  </a:solidFill>
+                  <a:effectLst/>
+                  <a:uLnTx/>
+                  <a:uFillTx/>
                   <a:latin typeface="+mn-lt"/>
+                  <a:ea typeface="+mn-ea"/>
+                  <a:cs typeface="+mn-cs"/>
                 </a:rPr>
-                <a:t>Inspired by CNC machining, this project creates an automated drawing machine using an Etch A Sketch board</a:t>
-              </a:r>
-              <a:r>
-                <a:rPr lang="en-US" sz="3200" baseline="30000" dirty="0">
-                  <a:latin typeface="Calibri" pitchFamily="34" charset="0"/>
-                </a:rPr>
-                <a:t>[1]</a:t>
-              </a:r>
-              <a:r>
-                <a:rPr lang="en-US" sz="3200" dirty="0">
-                  <a:latin typeface="Calibri" pitchFamily="34" charset="0"/>
-                </a:rPr>
-                <a:t>.</a:t>
-              </a:r>
-              <a:r>
-                <a:rPr lang="en-US" sz="3200" dirty="0">
-                  <a:latin typeface="+mn-lt"/>
-                </a:rPr>
-                <a:t> </a:t>
+                <a:t>Principle component analysis on 701 OES frequencies requires 11 components to reach 95% cumulative variance, and first 5 PCs capture ~74% of variance. </a:t>
               </a:r>
             </a:p>
             <a:p>
-              <a:pPr eaLnBrk="1" hangingPunct="1"/>
-              <a:endParaRPr lang="en-US" sz="3200" dirty="0">
+              <a:pPr marL="0" marR="0" lvl="0" indent="0" defTabSz="457200" rtl="0" eaLnBrk="1" fontAlgn="auto" latinLnBrk="0" hangingPunct="1">
+                <a:lnSpc>
+                  <a:spcPct val="100000"/>
+                </a:lnSpc>
+                <a:spcBef>
+                  <a:spcPts val="0"/>
+                </a:spcBef>
+                <a:spcAft>
+                  <a:spcPts val="1200"/>
+                </a:spcAft>
+                <a:buClrTx/>
+                <a:buSzTx/>
+                <a:buFontTx/>
+                <a:buNone/>
+                <a:tabLst/>
+                <a:defRPr/>
+              </a:pPr>
+              <a:endParaRPr lang="en-US" sz="2400" dirty="0">
+                <a:solidFill>
+                  <a:prstClr val="black"/>
+                </a:solidFill>
                 <a:latin typeface="+mn-lt"/>
               </a:endParaRPr>
             </a:p>
             <a:p>
-              <a:pPr eaLnBrk="1" hangingPunct="1"/>
+              <a:pPr marL="0" marR="0" lvl="0" indent="0" defTabSz="457200" rtl="0" eaLnBrk="1" fontAlgn="auto" latinLnBrk="0" hangingPunct="1">
+                <a:lnSpc>
+                  <a:spcPct val="100000"/>
+                </a:lnSpc>
+                <a:spcBef>
+                  <a:spcPts val="0"/>
+                </a:spcBef>
+                <a:spcAft>
+                  <a:spcPts val="1200"/>
+                </a:spcAft>
+                <a:buClrTx/>
+                <a:buSzTx/>
+                <a:buFontTx/>
+                <a:buNone/>
+                <a:tabLst/>
+                <a:defRPr/>
+              </a:pPr>
+              <a:endParaRPr kumimoji="0" lang="en-US" sz="2400" b="0" i="0" u="none" strike="noStrike" kern="1200" cap="none" spc="0" normalizeH="0" baseline="0" noProof="0" dirty="0">
+                <a:ln>
+                  <a:noFill/>
+                </a:ln>
+                <a:solidFill>
+                  <a:prstClr val="black"/>
+                </a:solidFill>
+                <a:effectLst/>
+                <a:uLnTx/>
+                <a:uFillTx/>
+                <a:latin typeface="+mn-lt"/>
+                <a:ea typeface="+mn-ea"/>
+                <a:cs typeface="+mn-cs"/>
+              </a:endParaRPr>
+            </a:p>
+            <a:p>
+              <a:pPr marL="0" marR="0" lvl="0" indent="0" defTabSz="457200" rtl="0" eaLnBrk="1" fontAlgn="auto" latinLnBrk="0" hangingPunct="1">
+                <a:lnSpc>
+                  <a:spcPct val="100000"/>
+                </a:lnSpc>
+                <a:spcBef>
+                  <a:spcPts val="0"/>
+                </a:spcBef>
+                <a:spcAft>
+                  <a:spcPts val="1200"/>
+                </a:spcAft>
+                <a:buClrTx/>
+                <a:buSzTx/>
+                <a:buFontTx/>
+                <a:buNone/>
+                <a:tabLst/>
+                <a:defRPr/>
+              </a:pPr>
+              <a:endParaRPr kumimoji="0" lang="en-US" sz="2400" b="0" i="0" u="none" strike="noStrike" kern="1200" cap="none" spc="0" normalizeH="0" baseline="0" noProof="0" dirty="0">
+                <a:ln>
+                  <a:noFill/>
+                </a:ln>
+                <a:solidFill>
+                  <a:prstClr val="black"/>
+                </a:solidFill>
+                <a:effectLst/>
+                <a:uLnTx/>
+                <a:uFillTx/>
+                <a:latin typeface="+mn-lt"/>
+                <a:ea typeface="+mn-ea"/>
+                <a:cs typeface="+mn-cs"/>
+              </a:endParaRPr>
+            </a:p>
+            <a:p>
+              <a:pPr marL="0" marR="0" lvl="0" indent="0" defTabSz="457200" rtl="0" eaLnBrk="1" fontAlgn="auto" latinLnBrk="0" hangingPunct="1">
+                <a:lnSpc>
+                  <a:spcPct val="100000"/>
+                </a:lnSpc>
+                <a:spcBef>
+                  <a:spcPts val="0"/>
+                </a:spcBef>
+                <a:spcAft>
+                  <a:spcPts val="1200"/>
+                </a:spcAft>
+                <a:buClrTx/>
+                <a:buSzTx/>
+                <a:buFontTx/>
+                <a:buNone/>
+                <a:tabLst/>
+                <a:defRPr/>
+              </a:pPr>
+              <a:endParaRPr kumimoji="0" lang="en-US" sz="2400" b="0" i="0" u="none" strike="noStrike" kern="1200" cap="none" spc="0" normalizeH="0" baseline="0" noProof="0" dirty="0">
+                <a:ln>
+                  <a:noFill/>
+                </a:ln>
+                <a:solidFill>
+                  <a:prstClr val="black"/>
+                </a:solidFill>
+                <a:effectLst/>
+                <a:uLnTx/>
+                <a:uFillTx/>
+                <a:latin typeface="+mn-lt"/>
+                <a:ea typeface="+mn-ea"/>
+                <a:cs typeface="+mn-cs"/>
+              </a:endParaRPr>
+            </a:p>
+            <a:p>
+              <a:pPr marL="0" marR="0" lvl="0" indent="0" defTabSz="457200" rtl="0" eaLnBrk="1" fontAlgn="auto" latinLnBrk="0" hangingPunct="1">
+                <a:lnSpc>
+                  <a:spcPct val="100000"/>
+                </a:lnSpc>
+                <a:spcBef>
+                  <a:spcPts val="0"/>
+                </a:spcBef>
+                <a:spcAft>
+                  <a:spcPts val="1200"/>
+                </a:spcAft>
+                <a:buClrTx/>
+                <a:buSzTx/>
+                <a:buFontTx/>
+                <a:buNone/>
+                <a:tabLst/>
+                <a:defRPr/>
+              </a:pPr>
               <a:r>
-                <a:rPr lang="en-US" sz="3200" dirty="0">
+                <a:rPr kumimoji="0" lang="en-US" sz="2400" b="0" i="0" u="none" strike="noStrike" kern="1200" cap="none" spc="0" normalizeH="0" baseline="0" noProof="0" dirty="0">
+                  <a:ln>
+                    <a:noFill/>
+                  </a:ln>
+                  <a:solidFill>
+                    <a:prstClr val="black"/>
+                  </a:solidFill>
+                  <a:effectLst/>
+                  <a:uLnTx/>
+                  <a:uFillTx/>
                   <a:latin typeface="+mn-lt"/>
+                  <a:ea typeface="+mn-ea"/>
+                  <a:cs typeface="+mn-cs"/>
                 </a:rPr>
-                <a:t>It first introduces a software pipeline that transforms digital images into continuous-line drawings. By employing edge detection techniques and a specialized depth-first search (DFS) algorithm, our system generates optimized G-code instructions tailored for our custom-built drawing machine.</a:t>
+                <a:t>However, in phase 1, discharge parameter-only configurations dominate for most models, and OES-only inputs performs poorly.</a:t>
               </a:r>
             </a:p>
             <a:p>
-              <a:pPr eaLnBrk="1" hangingPunct="1"/>
-              <a:br>
-                <a:rPr lang="en-US" sz="3200" dirty="0">
+              <a:pPr marL="0" marR="0" lvl="0" indent="0" defTabSz="457200" rtl="0" eaLnBrk="1" fontAlgn="auto" latinLnBrk="0" hangingPunct="1">
+                <a:lnSpc>
+                  <a:spcPct val="100000"/>
+                </a:lnSpc>
+                <a:spcBef>
+                  <a:spcPts val="0"/>
+                </a:spcBef>
+                <a:spcAft>
+                  <a:spcPts val="1200"/>
+                </a:spcAft>
+                <a:buClrTx/>
+                <a:buSzTx/>
+                <a:buFontTx/>
+                <a:buNone/>
+                <a:tabLst/>
+                <a:defRPr/>
+              </a:pPr>
+              <a:r>
+                <a:rPr lang="en-US" sz="2400" dirty="0">
+                  <a:solidFill>
+                    <a:prstClr val="black"/>
+                  </a:solidFill>
                   <a:latin typeface="+mn-lt"/>
                 </a:rPr>
-              </a:br>
+                <a:t>After tuning parameters in phase 2, R</a:t>
+              </a:r>
               <a:r>
-                <a:rPr lang="en-US" sz="3200" dirty="0">
+                <a:rPr lang="en-US" sz="2400" baseline="30000" dirty="0">
+                  <a:solidFill>
+                    <a:prstClr val="black"/>
+                  </a:solidFill>
                   <a:latin typeface="+mn-lt"/>
                 </a:rPr>
-                <a:t>The hardware system interprets these instructions and uses two stepper motors to precisely control the Etch A Sketch knobs, allowing the machine to replicate digital images as physical sketches.</a:t>
+                <a:t>2 </a:t>
               </a:r>
+              <a:r>
+                <a:rPr lang="en-US" sz="2400" dirty="0">
+                  <a:solidFill>
+                    <a:prstClr val="black"/>
+                  </a:solidFill>
+                  <a:latin typeface="+mn-lt"/>
+                </a:rPr>
+                <a:t>for all models are improved universally. MLP shows the most significant recovery from -1.13 to 0.33 for Config C and reaches 0.86 for Config B. CNN with config C remains the best OES-utilizing model.</a:t>
+              </a:r>
+            </a:p>
+            <a:p>
+              <a:pPr lvl="0" eaLnBrk="1" hangingPunct="1">
+                <a:spcAft>
+                  <a:spcPts val="1200"/>
+                </a:spcAft>
+                <a:defRPr/>
+              </a:pPr>
+              <a:r>
+                <a:rPr lang="en-US" sz="2400" dirty="0">
+                  <a:solidFill>
+                    <a:prstClr val="black"/>
+                  </a:solidFill>
+                  <a:latin typeface="+mn-lt"/>
+                </a:rPr>
+                <a:t>The most </a:t>
+              </a:r>
+              <a:r>
+                <a:rPr lang="en-US" sz="2400" dirty="0"/>
+                <a:t>pivotal</a:t>
+              </a:r>
+              <a:r>
+                <a:rPr lang="en-US" sz="2400" dirty="0">
+                  <a:solidFill>
+                    <a:prstClr val="black"/>
+                  </a:solidFill>
+                  <a:latin typeface="+mn-lt"/>
+                </a:rPr>
+                <a:t> breakthrough is in phase 3. Feature engineering dramatically improved Config C for MLP model from 0.33 to 0.80 and Ridge model from -0.17 to 0.80.</a:t>
+              </a:r>
+            </a:p>
+            <a:p>
+              <a:pPr marL="0" marR="0" lvl="0" indent="0" defTabSz="457200" rtl="0" eaLnBrk="1" fontAlgn="auto" latinLnBrk="0" hangingPunct="1">
+                <a:lnSpc>
+                  <a:spcPct val="100000"/>
+                </a:lnSpc>
+                <a:spcBef>
+                  <a:spcPts val="0"/>
+                </a:spcBef>
+                <a:spcAft>
+                  <a:spcPts val="1200"/>
+                </a:spcAft>
+                <a:buClrTx/>
+                <a:buSzTx/>
+                <a:buFontTx/>
+                <a:buNone/>
+                <a:tabLst/>
+                <a:defRPr/>
+              </a:pPr>
+              <a:endParaRPr lang="en-US" sz="2400" dirty="0">
+                <a:solidFill>
+                  <a:prstClr val="black"/>
+                </a:solidFill>
+                <a:latin typeface="+mn-lt"/>
+              </a:endParaRPr>
+            </a:p>
+            <a:p>
+              <a:pPr marL="0" marR="0" lvl="0" indent="0" defTabSz="457200" rtl="0" eaLnBrk="1" fontAlgn="auto" latinLnBrk="0" hangingPunct="1">
+                <a:lnSpc>
+                  <a:spcPct val="100000"/>
+                </a:lnSpc>
+                <a:spcBef>
+                  <a:spcPts val="0"/>
+                </a:spcBef>
+                <a:spcAft>
+                  <a:spcPts val="1200"/>
+                </a:spcAft>
+                <a:buClrTx/>
+                <a:buSzTx/>
+                <a:buFontTx/>
+                <a:buNone/>
+                <a:tabLst/>
+                <a:defRPr/>
+              </a:pPr>
+              <a:endParaRPr lang="en-US" sz="2400" dirty="0">
+                <a:solidFill>
+                  <a:prstClr val="black"/>
+                </a:solidFill>
+                <a:latin typeface="+mn-lt"/>
+              </a:endParaRPr>
+            </a:p>
+            <a:p>
+              <a:pPr marL="0" marR="0" lvl="0" indent="0" defTabSz="457200" rtl="0" eaLnBrk="1" fontAlgn="auto" latinLnBrk="0" hangingPunct="1">
+                <a:lnSpc>
+                  <a:spcPct val="100000"/>
+                </a:lnSpc>
+                <a:spcBef>
+                  <a:spcPts val="0"/>
+                </a:spcBef>
+                <a:spcAft>
+                  <a:spcPts val="1200"/>
+                </a:spcAft>
+                <a:buClrTx/>
+                <a:buSzTx/>
+                <a:buFontTx/>
+                <a:buNone/>
+                <a:tabLst/>
+                <a:defRPr/>
+              </a:pPr>
+              <a:endParaRPr lang="en-US" sz="2400" dirty="0">
+                <a:solidFill>
+                  <a:prstClr val="black"/>
+                </a:solidFill>
+                <a:latin typeface="+mn-lt"/>
+              </a:endParaRPr>
+            </a:p>
+            <a:p>
+              <a:pPr marL="0" marR="0" lvl="0" indent="0" defTabSz="457200" rtl="0" eaLnBrk="1" fontAlgn="auto" latinLnBrk="0" hangingPunct="1">
+                <a:lnSpc>
+                  <a:spcPct val="100000"/>
+                </a:lnSpc>
+                <a:spcBef>
+                  <a:spcPts val="0"/>
+                </a:spcBef>
+                <a:spcAft>
+                  <a:spcPts val="1200"/>
+                </a:spcAft>
+                <a:buClrTx/>
+                <a:buSzTx/>
+                <a:buFontTx/>
+                <a:buNone/>
+                <a:tabLst/>
+                <a:defRPr/>
+              </a:pPr>
+              <a:endParaRPr lang="en-US" sz="2400" dirty="0">
+                <a:solidFill>
+                  <a:prstClr val="black"/>
+                </a:solidFill>
+                <a:latin typeface="+mn-lt"/>
+              </a:endParaRPr>
+            </a:p>
+            <a:p>
+              <a:pPr marL="0" marR="0" lvl="0" indent="0" defTabSz="457200" rtl="0" eaLnBrk="1" fontAlgn="auto" latinLnBrk="0" hangingPunct="1">
+                <a:lnSpc>
+                  <a:spcPct val="100000"/>
+                </a:lnSpc>
+                <a:spcBef>
+                  <a:spcPts val="0"/>
+                </a:spcBef>
+                <a:spcAft>
+                  <a:spcPts val="1200"/>
+                </a:spcAft>
+                <a:buClrTx/>
+                <a:buSzTx/>
+                <a:buFontTx/>
+                <a:buNone/>
+                <a:tabLst/>
+                <a:defRPr/>
+              </a:pPr>
+              <a:endParaRPr lang="en-US" sz="2400" dirty="0">
+                <a:solidFill>
+                  <a:prstClr val="black"/>
+                </a:solidFill>
+                <a:latin typeface="+mn-lt"/>
+              </a:endParaRPr>
             </a:p>
           </p:txBody>
         </p:sp>
@@ -4344,7 +4746,7 @@
         </p:nvGrpSpPr>
         <p:grpSpPr>
           <a:xfrm>
-            <a:off x="14392421" y="3091330"/>
+            <a:off x="14392421" y="17013613"/>
             <a:ext cx="6748634" cy="8711716"/>
             <a:chOff x="440418" y="5694830"/>
             <a:chExt cx="9183262" cy="8711716"/>
@@ -4698,9 +5100,9 @@
         <p:grpSpPr>
           <a:xfrm>
             <a:off x="229885" y="18199581"/>
-            <a:ext cx="6748634" cy="10958485"/>
+            <a:ext cx="6748634" cy="10881541"/>
             <a:chOff x="440418" y="5694830"/>
-            <a:chExt cx="9183262" cy="10958485"/>
+            <a:chExt cx="9183262" cy="10881541"/>
           </a:xfrm>
         </p:grpSpPr>
         <p:sp>
@@ -4720,7 +5122,7 @@
           <p:spPr bwMode="auto">
             <a:xfrm>
               <a:off x="440418" y="6668631"/>
-              <a:ext cx="9183262" cy="9984684"/>
+              <a:ext cx="9183262" cy="9907740"/>
             </a:xfrm>
             <a:prstGeom prst="rect">
               <a:avLst/>
@@ -4895,7 +5297,34 @@
                 <a:rPr lang="en-US" sz="2400" dirty="0">
                   <a:latin typeface="+mn-lt"/>
                 </a:rPr>
-                <a:t>Models tested: Ridge, PLS, SVR, </a:t>
+                <a:t>Principle Component Analysis is a dimensionality reduction technique that utilizes covariance matrix and solves its eigenvector as PCs.</a:t>
+              </a:r>
+            </a:p>
+            <a:p>
+              <a:pPr marL="342900" indent="-342900" eaLnBrk="1" hangingPunct="1">
+                <a:spcAft>
+                  <a:spcPts val="600"/>
+                </a:spcAft>
+                <a:buFont typeface="Arial" panose="020B0604020202020204" pitchFamily="34" charset="0"/>
+                <a:buChar char="•"/>
+              </a:pPr>
+              <a:endParaRPr lang="en-US" sz="2400" dirty="0">
+                <a:latin typeface="+mn-lt"/>
+              </a:endParaRPr>
+            </a:p>
+            <a:p>
+              <a:pPr marL="342900" indent="-342900" eaLnBrk="1" hangingPunct="1">
+                <a:spcAft>
+                  <a:spcPts val="600"/>
+                </a:spcAft>
+                <a:buFont typeface="Arial" panose="020B0604020202020204" pitchFamily="34" charset="0"/>
+                <a:buChar char="•"/>
+              </a:pPr>
+              <a:r>
+                <a:rPr lang="en-US" sz="2400" dirty="0">
+                  <a:latin typeface="+mn-lt"/>
+                </a:rPr>
+                <a:t>Both linear and non-linear models are tested: Ridge, PLS, SVR, </a:t>
               </a:r>
               <a:r>
                 <a:rPr lang="en-US" sz="2400" dirty="0" err="1">
@@ -4922,13 +5351,25 @@
                 <a:rPr lang="en-US" sz="2400" dirty="0">
                   <a:latin typeface="+mn-lt"/>
                 </a:rPr>
-                <a:t>Three configs of features are used as input data for models. </a:t>
+                <a:t>Three configs of features/parameters are used as input data for models. </a:t>
               </a:r>
               <a:br>
                 <a:rPr lang="en-US" sz="2400" dirty="0">
                   <a:latin typeface="+mn-lt"/>
                 </a:rPr>
               </a:br>
+              <a:endParaRPr lang="en-US" sz="2400" dirty="0">
+                <a:latin typeface="+mn-lt"/>
+              </a:endParaRPr>
+            </a:p>
+            <a:p>
+              <a:pPr marL="342900" indent="-342900" eaLnBrk="1" hangingPunct="1">
+                <a:spcAft>
+                  <a:spcPts val="600"/>
+                </a:spcAft>
+                <a:buFont typeface="Arial" panose="020B0604020202020204" pitchFamily="34" charset="0"/>
+                <a:buChar char="•"/>
+              </a:pPr>
               <a:endParaRPr lang="en-US" sz="2400" dirty="0">
                 <a:latin typeface="+mn-lt"/>
               </a:endParaRPr>
@@ -4973,12 +5414,6 @@
                 <a:buChar char="•"/>
               </a:pPr>
               <a:r>
-                <a:rPr lang="en-US" sz="2400" dirty="0">
-                  <a:latin typeface="+mn-lt"/>
-                </a:rPr>
-                <a:t>Applied </a:t>
-              </a:r>
-              <a:r>
                 <a:rPr lang="en-US" sz="2400" dirty="0" err="1">
                   <a:latin typeface="+mn-lt"/>
                 </a:rPr>
@@ -4988,197 +5423,19 @@
                 <a:rPr lang="en-US" sz="2400" dirty="0">
                   <a:latin typeface="+mn-lt"/>
                 </a:rPr>
-                <a:t> (TPE sampler) with nested LOOCV. </a:t>
+                <a:t> is a framework for hyperparameter tuning. It use Tree-structured </a:t>
               </a:r>
-            </a:p>
-            <a:p>
-              <a:pPr marL="342900" indent="-342900" eaLnBrk="1" hangingPunct="1">
-                <a:spcAft>
-                  <a:spcPts val="600"/>
-                </a:spcAft>
-                <a:buFont typeface="Arial" panose="020B0604020202020204" pitchFamily="34" charset="0"/>
-                <a:buChar char="•"/>
-              </a:pPr>
               <a:r>
-                <a:rPr lang="en-US" sz="2400" dirty="0">
+                <a:rPr lang="en-US" sz="2400" dirty="0" err="1">
                   <a:latin typeface="+mn-lt"/>
                 </a:rPr>
-                <a:t>Tuned RF, MLP and CNN with over 100 trails per model-config pair.</a:t>
-              </a:r>
-            </a:p>
-            <a:p>
-              <a:pPr eaLnBrk="1" hangingPunct="1">
-                <a:spcAft>
-                  <a:spcPts val="600"/>
-                </a:spcAft>
-              </a:pPr>
-              <a:r>
-                <a:rPr lang="en-US" sz="2400" b="1" dirty="0">
-                  <a:latin typeface="+mn-lt"/>
-                </a:rPr>
-                <a:t>Phase 3</a:t>
+                <a:t>Parzen</a:t>
               </a:r>
               <a:r>
                 <a:rPr lang="en-US" sz="2400" dirty="0">
                   <a:latin typeface="+mn-lt"/>
                 </a:rPr>
-                <a:t>: Manually construction input features based on plasma chemistry domain-knowledge.</a:t>
-              </a:r>
-            </a:p>
-            <a:p>
-              <a:pPr marL="342900" indent="-342900" eaLnBrk="1" hangingPunct="1">
-                <a:spcAft>
-                  <a:spcPts val="600"/>
-                </a:spcAft>
-                <a:buFont typeface="Arial" panose="020B0604020202020204" pitchFamily="34" charset="0"/>
-                <a:buChar char="•"/>
-              </a:pPr>
-              <a:r>
-                <a:rPr lang="en-US" altLang="zh-CN" sz="2400" dirty="0">
-                  <a:latin typeface="+mn-lt"/>
-                </a:rPr>
-                <a:t>Construct</a:t>
-              </a:r>
-              <a:r>
-                <a:rPr lang="en-US" sz="2400" dirty="0">
-                  <a:latin typeface="+mn-lt"/>
-                </a:rPr>
-                <a:t> physically meaningful features</a:t>
-              </a:r>
-              <a:r>
-                <a:rPr lang="zh-CN" altLang="en-US" sz="2400" dirty="0">
-                  <a:latin typeface="+mn-lt"/>
-                </a:rPr>
-                <a:t> </a:t>
-              </a:r>
-              <a:r>
-                <a:rPr lang="en-US" altLang="zh-CN" sz="2400" dirty="0">
-                  <a:latin typeface="+mn-lt"/>
-                </a:rPr>
-                <a:t>instead</a:t>
-              </a:r>
-              <a:r>
-                <a:rPr lang="zh-CN" altLang="en-US" sz="2400" dirty="0">
-                  <a:latin typeface="+mn-lt"/>
-                </a:rPr>
-                <a:t> </a:t>
-              </a:r>
-              <a:r>
-                <a:rPr lang="en-US" altLang="zh-CN" sz="2400" dirty="0">
-                  <a:latin typeface="+mn-lt"/>
-                </a:rPr>
-                <a:t>of</a:t>
-              </a:r>
-              <a:r>
-                <a:rPr lang="zh-CN" altLang="en-US" sz="2400" dirty="0">
-                  <a:latin typeface="+mn-lt"/>
-                </a:rPr>
-                <a:t> </a:t>
-              </a:r>
-              <a:r>
-                <a:rPr lang="en-US" sz="2400" dirty="0">
-                  <a:latin typeface="+mn-lt"/>
-                </a:rPr>
-                <a:t>PCA-selected OES components</a:t>
-              </a:r>
-              <a:r>
-                <a:rPr lang="en-US" altLang="zh-CN" sz="2400" dirty="0">
-                  <a:latin typeface="+mn-lt"/>
-                </a:rPr>
-                <a:t>.</a:t>
-              </a:r>
-            </a:p>
-            <a:p>
-              <a:pPr marL="342900" indent="-342900" eaLnBrk="1" hangingPunct="1">
-                <a:spcAft>
-                  <a:spcPts val="600"/>
-                </a:spcAft>
-                <a:buFont typeface="Arial" panose="020B0604020202020204" pitchFamily="34" charset="0"/>
-                <a:buChar char="•"/>
-              </a:pPr>
-              <a:r>
-                <a:rPr lang="en-US" altLang="zh-CN" sz="2400" dirty="0">
-                  <a:latin typeface="+mn-lt"/>
-                </a:rPr>
-                <a:t>U</a:t>
-              </a:r>
-              <a:r>
-                <a:rPr lang="en-US" sz="2400" dirty="0">
-                  <a:latin typeface="+mn-lt"/>
-                </a:rPr>
-                <a:t>pdate three </a:t>
-              </a:r>
-              <a:r>
-                <a:rPr lang="en-US" altLang="zh-CN" sz="2400" dirty="0">
-                  <a:latin typeface="+mn-lt"/>
-                </a:rPr>
-                <a:t>training</a:t>
-              </a:r>
-              <a:r>
-                <a:rPr lang="zh-CN" altLang="en-US" sz="2400" dirty="0">
-                  <a:latin typeface="+mn-lt"/>
-                </a:rPr>
-                <a:t> </a:t>
-              </a:r>
-              <a:r>
-                <a:rPr lang="en-US" altLang="zh-CN" sz="2400" dirty="0">
-                  <a:latin typeface="+mn-lt"/>
-                </a:rPr>
-                <a:t>input</a:t>
-              </a:r>
-              <a:r>
-                <a:rPr lang="zh-CN" altLang="en-US" sz="2400" dirty="0">
-                  <a:latin typeface="+mn-lt"/>
-                </a:rPr>
-                <a:t> </a:t>
-              </a:r>
-              <a:r>
-                <a:rPr lang="en-US" sz="2400" dirty="0">
-                  <a:latin typeface="+mn-lt"/>
-                </a:rPr>
-                <a:t>configs</a:t>
-              </a:r>
-              <a:r>
-                <a:rPr lang="zh-CN" altLang="en-US" sz="2400" dirty="0">
-                  <a:latin typeface="+mn-lt"/>
-                </a:rPr>
-                <a:t> </a:t>
-              </a:r>
-              <a:r>
-                <a:rPr lang="en-US" altLang="zh-CN" sz="2400" dirty="0">
-                  <a:latin typeface="+mn-lt"/>
-                </a:rPr>
-                <a:t>with</a:t>
-              </a:r>
-              <a:r>
-                <a:rPr lang="zh-CN" altLang="en-US" sz="2400" dirty="0">
-                  <a:latin typeface="+mn-lt"/>
-                </a:rPr>
-                <a:t> </a:t>
-              </a:r>
-              <a:r>
-                <a:rPr lang="en-US" altLang="zh-CN" sz="2400" dirty="0">
-                  <a:latin typeface="+mn-lt"/>
-                </a:rPr>
-                <a:t>new</a:t>
-              </a:r>
-              <a:r>
-                <a:rPr lang="zh-CN" altLang="en-US" sz="2400" dirty="0">
-                  <a:latin typeface="+mn-lt"/>
-                </a:rPr>
-                <a:t> </a:t>
-              </a:r>
-              <a:r>
-                <a:rPr lang="en-US" altLang="zh-CN" sz="2400" dirty="0">
-                  <a:latin typeface="+mn-lt"/>
-                </a:rPr>
-                <a:t>features</a:t>
-              </a:r>
-              <a:r>
-                <a:rPr lang="en-US" sz="2400" dirty="0">
-                  <a:latin typeface="+mn-lt"/>
-                </a:rPr>
-                <a:t>.</a:t>
+                <a:t> Estimator to optimize hyperparameter for each model.</a:t>
               </a:r>
             </a:p>
           </p:txBody>
@@ -5267,70 +5524,14 @@
         </p:blipFill>
         <p:spPr>
           <a:xfrm>
-            <a:off x="2904647" y="22805945"/>
-            <a:ext cx="4067653" cy="1062875"/>
+            <a:off x="1270808" y="24851344"/>
+            <a:ext cx="4609730" cy="1204520"/>
           </a:xfrm>
           <a:prstGeom prst="rect">
             <a:avLst/>
           </a:prstGeom>
         </p:spPr>
       </p:pic>
-      <p:sp>
-        <p:nvSpPr>
-          <p:cNvPr id="1028" name="Rectangle 1027">
-            <a:extLst>
-              <a:ext uri="{FF2B5EF4-FFF2-40B4-BE49-F238E27FC236}">
-                <a16:creationId xmlns:a16="http://schemas.microsoft.com/office/drawing/2014/main" id="{730FCA34-DC1C-7B2E-3263-D5908DF662D8}"/>
-              </a:ext>
-            </a:extLst>
-          </p:cNvPr>
-          <p:cNvSpPr/>
-          <p:nvPr/>
-        </p:nvSpPr>
-        <p:spPr>
-          <a:xfrm>
-            <a:off x="0" y="29301411"/>
-            <a:ext cx="21695418" cy="973802"/>
-          </a:xfrm>
-          <a:prstGeom prst="rect">
-            <a:avLst/>
-          </a:prstGeom>
-          <a:solidFill>
-            <a:srgbClr val="355F93"/>
-          </a:solidFill>
-          <a:ln>
-            <a:noFill/>
-          </a:ln>
-        </p:spPr>
-        <p:style>
-          <a:lnRef idx="2">
-            <a:schemeClr val="accent1">
-              <a:shade val="15000"/>
-            </a:schemeClr>
-          </a:lnRef>
-          <a:fillRef idx="1">
-            <a:schemeClr val="accent1"/>
-          </a:fillRef>
-          <a:effectRef idx="0">
-            <a:schemeClr val="accent1"/>
-          </a:effectRef>
-          <a:fontRef idx="minor">
-            <a:schemeClr val="lt1"/>
-          </a:fontRef>
-        </p:style>
-        <p:txBody>
-          <a:bodyPr rtlCol="0" anchor="ctr"/>
-          <a:lstStyle/>
-          <a:p>
-            <a:pPr algn="ctr"/>
-            <a:r>
-              <a:rPr lang="en-US" altLang="zh-CN" sz="4096" dirty="0"/>
-              <a:t>`</a:t>
-            </a:r>
-            <a:endParaRPr lang="en-CN" sz="4096" dirty="0"/>
-          </a:p>
-        </p:txBody>
-      </p:sp>
       <p:sp>
         <p:nvSpPr>
           <p:cNvPr id="1031" name="Text Box 189">
@@ -5348,7 +5549,7 @@
         <p:spPr bwMode="auto">
           <a:xfrm>
             <a:off x="7348061" y="3091330"/>
-            <a:ext cx="6724016" cy="5737367"/>
+            <a:ext cx="6724016" cy="13139393"/>
           </a:xfrm>
           <a:prstGeom prst="rect">
             <a:avLst/>
@@ -5468,6 +5669,303 @@
             </a:lvl9pPr>
           </a:lstStyle>
           <a:p>
+            <a:pPr marL="342900" marR="0" lvl="0" indent="-342900" algn="l" defTabSz="457200" rtl="0" eaLnBrk="1" fontAlgn="auto" latinLnBrk="0" hangingPunct="1">
+              <a:lnSpc>
+                <a:spcPct val="100000"/>
+              </a:lnSpc>
+              <a:spcBef>
+                <a:spcPts val="0"/>
+              </a:spcBef>
+              <a:spcAft>
+                <a:spcPts val="600"/>
+              </a:spcAft>
+              <a:buClrTx/>
+              <a:buSzTx/>
+              <a:buFont typeface="Arial" panose="020B0604020202020204" pitchFamily="34" charset="0"/>
+              <a:buChar char="•"/>
+              <a:tabLst/>
+              <a:defRPr/>
+            </a:pPr>
+            <a:r>
+              <a:rPr kumimoji="0" lang="en-US" sz="2400" b="0" i="0" u="none" strike="noStrike" kern="1200" cap="none" spc="0" normalizeH="0" baseline="0" noProof="0" dirty="0">
+                <a:ln>
+                  <a:noFill/>
+                </a:ln>
+                <a:solidFill>
+                  <a:prstClr val="black"/>
+                </a:solidFill>
+                <a:effectLst/>
+                <a:uLnTx/>
+                <a:uFillTx/>
+                <a:latin typeface="Aptos" panose="02110004020202020204"/>
+                <a:ea typeface="+mn-ea"/>
+                <a:cs typeface="+mn-cs"/>
+              </a:rPr>
+              <a:t>RF, MLP and CNN are tuned with over 100 trails per model-config pair.</a:t>
+            </a:r>
+            <a:endParaRPr lang="en-US" sz="2400" b="1" dirty="0">
+              <a:latin typeface="+mn-lt"/>
+            </a:endParaRPr>
+          </a:p>
+          <a:p>
+            <a:pPr marL="0" marR="0" lvl="0" indent="0" fontAlgn="auto">
+              <a:lnSpc>
+                <a:spcPct val="100000"/>
+              </a:lnSpc>
+              <a:spcBef>
+                <a:spcPts val="0"/>
+              </a:spcBef>
+              <a:spcAft>
+                <a:spcPts val="600"/>
+              </a:spcAft>
+              <a:buClrTx/>
+              <a:buSzTx/>
+              <a:buFontTx/>
+              <a:buNone/>
+              <a:tabLst/>
+              <a:defRPr/>
+            </a:pPr>
+            <a:r>
+              <a:rPr lang="en-US" sz="2400" b="1" dirty="0">
+                <a:latin typeface="+mn-lt"/>
+              </a:rPr>
+              <a:t>Phase 3: </a:t>
+            </a:r>
+            <a:r>
+              <a:rPr lang="en-US" sz="2400" dirty="0">
+                <a:latin typeface="+mn-lt"/>
+              </a:rPr>
+              <a:t>Manually construction input features based on plasma chemistry domain-knowledge.</a:t>
+            </a:r>
+          </a:p>
+          <a:p>
+            <a:pPr marL="342900" marR="0" lvl="0" indent="-342900" fontAlgn="auto">
+              <a:lnSpc>
+                <a:spcPct val="100000"/>
+              </a:lnSpc>
+              <a:spcBef>
+                <a:spcPts val="0"/>
+              </a:spcBef>
+              <a:spcAft>
+                <a:spcPts val="600"/>
+              </a:spcAft>
+              <a:buClrTx/>
+              <a:buSzTx/>
+              <a:buFont typeface="Arial" panose="020B0604020202020204" pitchFamily="34" charset="0"/>
+              <a:buChar char="•"/>
+              <a:tabLst/>
+              <a:defRPr/>
+            </a:pPr>
+            <a:r>
+              <a:rPr lang="en-US" altLang="zh-CN" sz="2400" dirty="0">
+                <a:latin typeface="+mn-lt"/>
+              </a:rPr>
+              <a:t>Construct</a:t>
+            </a:r>
+            <a:r>
+              <a:rPr lang="en-US" sz="2400" dirty="0">
+                <a:latin typeface="+mn-lt"/>
+              </a:rPr>
+              <a:t> physically meaningful features based on </a:t>
+            </a:r>
+            <a:r>
+              <a:rPr lang="en-US" sz="2400" dirty="0" err="1">
+                <a:latin typeface="+mn-lt"/>
+              </a:rPr>
+              <a:t>plamsa</a:t>
+            </a:r>
+            <a:r>
+              <a:rPr lang="en-US" sz="2400" dirty="0">
+                <a:latin typeface="+mn-lt"/>
+              </a:rPr>
+              <a:t> chemistry domain knowledge, </a:t>
+            </a:r>
+            <a:r>
+              <a:rPr lang="en-US" altLang="zh-CN" sz="2400" dirty="0">
+                <a:latin typeface="+mn-lt"/>
+              </a:rPr>
+              <a:t>instead</a:t>
+            </a:r>
+            <a:r>
+              <a:rPr lang="zh-CN" altLang="en-US" sz="2400" dirty="0">
+                <a:latin typeface="+mn-lt"/>
+              </a:rPr>
+              <a:t> </a:t>
+            </a:r>
+            <a:r>
+              <a:rPr lang="en-US" altLang="zh-CN" sz="2400" dirty="0">
+                <a:latin typeface="+mn-lt"/>
+              </a:rPr>
+              <a:t>of</a:t>
+            </a:r>
+            <a:r>
+              <a:rPr lang="zh-CN" altLang="en-US" sz="2400" dirty="0">
+                <a:latin typeface="+mn-lt"/>
+              </a:rPr>
+              <a:t> </a:t>
+            </a:r>
+            <a:r>
+              <a:rPr lang="en-US" sz="2400" dirty="0">
+                <a:latin typeface="+mn-lt"/>
+              </a:rPr>
+              <a:t>PCA-selected OES components</a:t>
+            </a:r>
+            <a:r>
+              <a:rPr lang="en-US" altLang="zh-CN" sz="2400" dirty="0">
+                <a:latin typeface="+mn-lt"/>
+              </a:rPr>
+              <a:t>. </a:t>
+            </a:r>
+          </a:p>
+          <a:p>
+            <a:pPr marL="342900" marR="0" lvl="0" indent="-342900" fontAlgn="auto">
+              <a:lnSpc>
+                <a:spcPct val="100000"/>
+              </a:lnSpc>
+              <a:spcBef>
+                <a:spcPts val="0"/>
+              </a:spcBef>
+              <a:spcAft>
+                <a:spcPts val="600"/>
+              </a:spcAft>
+              <a:buClrTx/>
+              <a:buSzTx/>
+              <a:buFont typeface="Arial" panose="020B0604020202020204" pitchFamily="34" charset="0"/>
+              <a:buChar char="•"/>
+              <a:tabLst/>
+              <a:defRPr/>
+            </a:pPr>
+            <a:r>
+              <a:rPr lang="en-US" altLang="zh-CN" sz="2400" dirty="0">
+                <a:latin typeface="+mn-lt"/>
+              </a:rPr>
+              <a:t>U</a:t>
+            </a:r>
+            <a:r>
+              <a:rPr lang="en-US" sz="2400" dirty="0">
+                <a:latin typeface="+mn-lt"/>
+              </a:rPr>
+              <a:t>pdate three </a:t>
+            </a:r>
+            <a:r>
+              <a:rPr lang="en-US" altLang="zh-CN" sz="2400" dirty="0">
+                <a:latin typeface="+mn-lt"/>
+              </a:rPr>
+              <a:t>training</a:t>
+            </a:r>
+            <a:r>
+              <a:rPr lang="zh-CN" altLang="en-US" sz="2400" dirty="0">
+                <a:latin typeface="+mn-lt"/>
+              </a:rPr>
+              <a:t> </a:t>
+            </a:r>
+            <a:r>
+              <a:rPr lang="en-US" altLang="zh-CN" sz="2400" dirty="0">
+                <a:latin typeface="+mn-lt"/>
+              </a:rPr>
+              <a:t>input</a:t>
+            </a:r>
+            <a:r>
+              <a:rPr lang="zh-CN" altLang="en-US" sz="2400" dirty="0">
+                <a:latin typeface="+mn-lt"/>
+              </a:rPr>
+              <a:t> </a:t>
+            </a:r>
+            <a:r>
+              <a:rPr lang="en-US" sz="2400" dirty="0">
+                <a:latin typeface="+mn-lt"/>
+              </a:rPr>
+              <a:t>configs</a:t>
+            </a:r>
+            <a:r>
+              <a:rPr lang="zh-CN" altLang="en-US" sz="2400" dirty="0">
+                <a:latin typeface="+mn-lt"/>
+              </a:rPr>
+              <a:t> </a:t>
+            </a:r>
+            <a:r>
+              <a:rPr lang="en-US" altLang="zh-CN" sz="2400" dirty="0">
+                <a:latin typeface="+mn-lt"/>
+              </a:rPr>
+              <a:t>with</a:t>
+            </a:r>
+            <a:r>
+              <a:rPr lang="zh-CN" altLang="en-US" sz="2400" dirty="0">
+                <a:latin typeface="+mn-lt"/>
+              </a:rPr>
+              <a:t> </a:t>
+            </a:r>
+            <a:r>
+              <a:rPr lang="en-US" altLang="zh-CN" sz="2400" dirty="0">
+                <a:latin typeface="+mn-lt"/>
+              </a:rPr>
+              <a:t>new</a:t>
+            </a:r>
+            <a:r>
+              <a:rPr lang="zh-CN" altLang="en-US" sz="2400" dirty="0">
+                <a:latin typeface="+mn-lt"/>
+              </a:rPr>
+              <a:t> </a:t>
+            </a:r>
+            <a:r>
+              <a:rPr lang="en-US" altLang="zh-CN" sz="2400" dirty="0">
+                <a:latin typeface="+mn-lt"/>
+              </a:rPr>
+              <a:t>features</a:t>
+            </a:r>
+            <a:r>
+              <a:rPr lang="en-US" sz="2400" dirty="0">
+                <a:latin typeface="+mn-lt"/>
+              </a:rPr>
+              <a:t>.</a:t>
+            </a:r>
+          </a:p>
+          <a:p>
+            <a:endParaRPr lang="en-US" sz="2400" b="1" dirty="0">
+              <a:latin typeface="+mn-lt"/>
+            </a:endParaRPr>
+          </a:p>
+          <a:p>
+            <a:endParaRPr lang="en-US" sz="2400" b="1" dirty="0">
+              <a:latin typeface="+mn-lt"/>
+            </a:endParaRPr>
+          </a:p>
+          <a:p>
+            <a:endParaRPr lang="en-US" sz="2400" b="1" dirty="0">
+              <a:latin typeface="+mn-lt"/>
+            </a:endParaRPr>
+          </a:p>
+          <a:p>
+            <a:endParaRPr lang="en-US" sz="2400" b="1" dirty="0">
+              <a:latin typeface="+mn-lt"/>
+            </a:endParaRPr>
+          </a:p>
+          <a:p>
+            <a:endParaRPr lang="en-US" sz="2400" b="1" dirty="0">
+              <a:latin typeface="+mn-lt"/>
+            </a:endParaRPr>
+          </a:p>
+          <a:p>
+            <a:endParaRPr lang="en-US" sz="2400" b="1" dirty="0">
+              <a:latin typeface="+mn-lt"/>
+            </a:endParaRPr>
+          </a:p>
+          <a:p>
+            <a:endParaRPr lang="en-US" sz="2400" b="1" dirty="0">
+              <a:latin typeface="+mn-lt"/>
+            </a:endParaRPr>
+          </a:p>
+          <a:p>
+            <a:endParaRPr lang="en-US" sz="2400" b="1" dirty="0">
+              <a:latin typeface="+mn-lt"/>
+            </a:endParaRPr>
+          </a:p>
+          <a:p>
+            <a:endParaRPr lang="en-US" sz="2400" b="1" dirty="0">
+              <a:latin typeface="+mn-lt"/>
+            </a:endParaRPr>
+          </a:p>
+          <a:p>
             <a:r>
               <a:rPr lang="en-US" sz="2400" b="1" dirty="0">
                 <a:latin typeface="+mn-lt"/>
@@ -5499,7 +5997,9 @@
               <a:t> </a:t>
             </a:r>
             <a:r>
-              <a:rPr lang="en-US" dirty="0"/>
+              <a:rPr lang="en-US" dirty="0">
+                <a:latin typeface="+mn-lt"/>
+              </a:rPr>
               <a:t>Interpretability analysis and feature reduction via multi-model consensus and backward elimination</a:t>
             </a:r>
           </a:p>
@@ -5509,12 +6009,16 @@
               <a:buChar char="•"/>
             </a:pPr>
             <a:r>
-              <a:rPr lang="en-US" dirty="0"/>
+              <a:rPr lang="en-US" dirty="0">
+                <a:latin typeface="+mn-lt"/>
+              </a:rPr>
               <a:t>Evaluate feature importance for each model via different methods.</a:t>
             </a:r>
           </a:p>
           <a:p>
-            <a:endParaRPr lang="en-US" dirty="0"/>
+            <a:endParaRPr lang="en-US" dirty="0">
+              <a:latin typeface="+mn-lt"/>
+            </a:endParaRPr>
           </a:p>
           <a:p>
             <a:pPr eaLnBrk="1" hangingPunct="1"/>
@@ -5561,17 +6065,7 @@
               <a:rPr lang="en-US" sz="2400" dirty="0">
                 <a:latin typeface="+mn-lt"/>
               </a:rPr>
-              <a:t> </a:t>
-            </a:r>
-            <a:r>
-              <a:rPr lang="en-US" sz="2400" dirty="0"/>
-              <a:t>confidence interval </a:t>
-            </a:r>
-            <a:r>
-              <a:rPr lang="en-US" sz="2400" dirty="0">
-                <a:latin typeface="+mn-lt"/>
-              </a:rPr>
-              <a:t>of  Ridge and PLS using bootstrap resampling, </a:t>
+              <a:t> confidence interval of  Ridge and PLS using bootstrap resampling, </a:t>
             </a:r>
           </a:p>
           <a:p>
@@ -5585,12 +6079,6 @@
               </a:rPr>
               <a:t>Examine the overall best model and config via eliminating features.</a:t>
             </a:r>
-          </a:p>
-          <a:p>
-            <a:pPr eaLnBrk="1" hangingPunct="1"/>
-            <a:endParaRPr lang="en-US" sz="2400" dirty="0">
-              <a:latin typeface="+mn-lt"/>
-            </a:endParaRPr>
           </a:p>
         </p:txBody>
       </p:sp>
@@ -5616,7 +6104,7 @@
         </p:blipFill>
         <p:spPr>
           <a:xfrm>
-            <a:off x="7796413" y="4998748"/>
+            <a:off x="7779220" y="12234049"/>
             <a:ext cx="5827312" cy="1789890"/>
           </a:xfrm>
           <a:prstGeom prst="rect">
@@ -5624,6 +6112,437 @@
           </a:prstGeom>
         </p:spPr>
       </p:pic>
+      <p:pic>
+        <p:nvPicPr>
+          <p:cNvPr id="2" name="Picture 1">
+            <a:extLst>
+              <a:ext uri="{FF2B5EF4-FFF2-40B4-BE49-F238E27FC236}">
+                <a16:creationId xmlns:a16="http://schemas.microsoft.com/office/drawing/2014/main" id="{D5880BC2-DD9A-5C57-7BB5-24CED8CABEAD}"/>
+              </a:ext>
+            </a:extLst>
+          </p:cNvPr>
+          <p:cNvPicPr>
+            <a:picLocks noChangeAspect="1"/>
+          </p:cNvPicPr>
+          <p:nvPr/>
+        </p:nvPicPr>
+        <p:blipFill>
+          <a:blip r:embed="rId8"/>
+          <a:stretch>
+            <a:fillRect/>
+          </a:stretch>
+        </p:blipFill>
+        <p:spPr>
+          <a:xfrm>
+            <a:off x="1291503" y="22713846"/>
+            <a:ext cx="4447598" cy="691433"/>
+          </a:xfrm>
+          <a:prstGeom prst="rect">
+            <a:avLst/>
+          </a:prstGeom>
+        </p:spPr>
+      </p:pic>
+      <p:pic>
+        <p:nvPicPr>
+          <p:cNvPr id="3" name="Picture 2">
+            <a:extLst>
+              <a:ext uri="{FF2B5EF4-FFF2-40B4-BE49-F238E27FC236}">
+                <a16:creationId xmlns:a16="http://schemas.microsoft.com/office/drawing/2014/main" id="{F35E7776-D517-3CDD-C5EA-526127865368}"/>
+              </a:ext>
+            </a:extLst>
+          </p:cNvPr>
+          <p:cNvPicPr>
+            <a:picLocks noChangeAspect="1"/>
+          </p:cNvPicPr>
+          <p:nvPr/>
+        </p:nvPicPr>
+        <p:blipFill>
+          <a:blip r:embed="rId9"/>
+          <a:stretch>
+            <a:fillRect/>
+          </a:stretch>
+        </p:blipFill>
+        <p:spPr>
+          <a:xfrm>
+            <a:off x="399350" y="5669970"/>
+            <a:ext cx="6409704" cy="3765574"/>
+          </a:xfrm>
+          <a:prstGeom prst="rect">
+            <a:avLst/>
+          </a:prstGeom>
+        </p:spPr>
+      </p:pic>
+      <p:pic>
+        <p:nvPicPr>
+          <p:cNvPr id="4" name="Picture 3">
+            <a:extLst>
+              <a:ext uri="{FF2B5EF4-FFF2-40B4-BE49-F238E27FC236}">
+                <a16:creationId xmlns:a16="http://schemas.microsoft.com/office/drawing/2014/main" id="{F3A94253-8789-26E5-5210-DD83FB638AE8}"/>
+              </a:ext>
+            </a:extLst>
+          </p:cNvPr>
+          <p:cNvPicPr>
+            <a:picLocks noChangeAspect="1"/>
+          </p:cNvPicPr>
+          <p:nvPr/>
+        </p:nvPicPr>
+        <p:blipFill>
+          <a:blip r:embed="rId10"/>
+          <a:srcRect t="8304"/>
+          <a:stretch>
+            <a:fillRect/>
+          </a:stretch>
+        </p:blipFill>
+        <p:spPr>
+          <a:xfrm>
+            <a:off x="7687173" y="7187901"/>
+            <a:ext cx="6321072" cy="3305467"/>
+          </a:xfrm>
+          <a:prstGeom prst="rect">
+            <a:avLst/>
+          </a:prstGeom>
+        </p:spPr>
+      </p:pic>
+      <p:pic>
+        <p:nvPicPr>
+          <p:cNvPr id="6" name="Picture 5">
+            <a:extLst>
+              <a:ext uri="{FF2B5EF4-FFF2-40B4-BE49-F238E27FC236}">
+                <a16:creationId xmlns:a16="http://schemas.microsoft.com/office/drawing/2014/main" id="{C5CFB691-92EA-998A-7F75-A9309CAF12BB}"/>
+              </a:ext>
+            </a:extLst>
+          </p:cNvPr>
+          <p:cNvPicPr>
+            <a:picLocks noChangeAspect="1"/>
+          </p:cNvPicPr>
+          <p:nvPr/>
+        </p:nvPicPr>
+        <p:blipFill>
+          <a:blip r:embed="rId11"/>
+          <a:stretch>
+            <a:fillRect/>
+          </a:stretch>
+        </p:blipFill>
+        <p:spPr>
+          <a:xfrm>
+            <a:off x="8443475" y="18992254"/>
+            <a:ext cx="4498802" cy="2249402"/>
+          </a:xfrm>
+          <a:prstGeom prst="rect">
+            <a:avLst/>
+          </a:prstGeom>
+        </p:spPr>
+      </p:pic>
+      <p:pic>
+        <p:nvPicPr>
+          <p:cNvPr id="7" name="Picture 6">
+            <a:extLst>
+              <a:ext uri="{FF2B5EF4-FFF2-40B4-BE49-F238E27FC236}">
+                <a16:creationId xmlns:a16="http://schemas.microsoft.com/office/drawing/2014/main" id="{F20AF61B-B1F5-5EA9-D336-F730C1D07EA5}"/>
+              </a:ext>
+            </a:extLst>
+          </p:cNvPr>
+          <p:cNvPicPr>
+            <a:picLocks noChangeAspect="1"/>
+          </p:cNvPicPr>
+          <p:nvPr/>
+        </p:nvPicPr>
+        <p:blipFill>
+          <a:blip r:embed="rId12"/>
+          <a:stretch>
+            <a:fillRect/>
+          </a:stretch>
+        </p:blipFill>
+        <p:spPr>
+          <a:xfrm>
+            <a:off x="7367373" y="26509224"/>
+            <a:ext cx="6651006" cy="2217002"/>
+          </a:xfrm>
+          <a:prstGeom prst="rect">
+            <a:avLst/>
+          </a:prstGeom>
+        </p:spPr>
+      </p:pic>
+      <p:sp>
+        <p:nvSpPr>
+          <p:cNvPr id="8" name="Text Box 189">
+            <a:extLst>
+              <a:ext uri="{FF2B5EF4-FFF2-40B4-BE49-F238E27FC236}">
+                <a16:creationId xmlns:a16="http://schemas.microsoft.com/office/drawing/2014/main" id="{37F55E27-045C-0A8A-3D80-3AD92A7911A1}"/>
+              </a:ext>
+            </a:extLst>
+          </p:cNvPr>
+          <p:cNvSpPr txBox="1">
+            <a:spLocks noChangeArrowheads="1"/>
+          </p:cNvSpPr>
+          <p:nvPr/>
+        </p:nvSpPr>
+        <p:spPr bwMode="auto">
+          <a:xfrm>
+            <a:off x="14392421" y="3093708"/>
+            <a:ext cx="6724016" cy="2813490"/>
+          </a:xfrm>
+          <a:prstGeom prst="rect">
+            <a:avLst/>
+          </a:prstGeom>
+          <a:solidFill>
+            <a:schemeClr val="bg1"/>
+          </a:solidFill>
+          <a:ln w="12700">
+            <a:solidFill>
+              <a:schemeClr val="accent1">
+                <a:lumMod val="75000"/>
+              </a:schemeClr>
+            </a:solidFill>
+          </a:ln>
+          <a:effectLst/>
+        </p:spPr>
+        <p:txBody>
+          <a:bodyPr wrap="square" lIns="173940" tIns="173940" rIns="173940" bIns="173940">
+            <a:spAutoFit/>
+          </a:bodyPr>
+          <a:lstStyle>
+            <a:lvl1pPr eaLnBrk="0" hangingPunct="0">
+              <a:defRPr sz="2200">
+                <a:solidFill>
+                  <a:schemeClr val="tx1"/>
+                </a:solidFill>
+                <a:latin typeface="Arial" charset="0"/>
+              </a:defRPr>
+            </a:lvl1pPr>
+            <a:lvl2pPr marL="742950" indent="-285750" eaLnBrk="0" hangingPunct="0">
+              <a:defRPr sz="2200">
+                <a:solidFill>
+                  <a:schemeClr val="tx1"/>
+                </a:solidFill>
+                <a:latin typeface="Arial" charset="0"/>
+              </a:defRPr>
+            </a:lvl2pPr>
+            <a:lvl3pPr marL="1143000" indent="-228600" eaLnBrk="0" hangingPunct="0">
+              <a:defRPr sz="2200">
+                <a:solidFill>
+                  <a:schemeClr val="tx1"/>
+                </a:solidFill>
+                <a:latin typeface="Arial" charset="0"/>
+              </a:defRPr>
+            </a:lvl3pPr>
+            <a:lvl4pPr marL="1600200" indent="-228600" eaLnBrk="0" hangingPunct="0">
+              <a:defRPr sz="2200">
+                <a:solidFill>
+                  <a:schemeClr val="tx1"/>
+                </a:solidFill>
+                <a:latin typeface="Arial" charset="0"/>
+              </a:defRPr>
+            </a:lvl4pPr>
+            <a:lvl5pPr marL="2057400" indent="-228600" eaLnBrk="0" hangingPunct="0">
+              <a:defRPr sz="2200">
+                <a:solidFill>
+                  <a:schemeClr val="tx1"/>
+                </a:solidFill>
+                <a:latin typeface="Arial" charset="0"/>
+              </a:defRPr>
+            </a:lvl5pPr>
+            <a:lvl6pPr marL="2514600" indent="-228600" eaLnBrk="0" fontAlgn="base" hangingPunct="0">
+              <a:spcBef>
+                <a:spcPct val="0"/>
+              </a:spcBef>
+              <a:spcAft>
+                <a:spcPct val="0"/>
+              </a:spcAft>
+              <a:defRPr sz="2200">
+                <a:solidFill>
+                  <a:schemeClr val="tx1"/>
+                </a:solidFill>
+                <a:latin typeface="Arial" charset="0"/>
+              </a:defRPr>
+            </a:lvl6pPr>
+            <a:lvl7pPr marL="2971800" indent="-228600" eaLnBrk="0" fontAlgn="base" hangingPunct="0">
+              <a:spcBef>
+                <a:spcPct val="0"/>
+              </a:spcBef>
+              <a:spcAft>
+                <a:spcPct val="0"/>
+              </a:spcAft>
+              <a:defRPr sz="2200">
+                <a:solidFill>
+                  <a:schemeClr val="tx1"/>
+                </a:solidFill>
+                <a:latin typeface="Arial" charset="0"/>
+              </a:defRPr>
+            </a:lvl7pPr>
+            <a:lvl8pPr marL="3429000" indent="-228600" eaLnBrk="0" fontAlgn="base" hangingPunct="0">
+              <a:spcBef>
+                <a:spcPct val="0"/>
+              </a:spcBef>
+              <a:spcAft>
+                <a:spcPct val="0"/>
+              </a:spcAft>
+              <a:defRPr sz="2200">
+                <a:solidFill>
+                  <a:schemeClr val="tx1"/>
+                </a:solidFill>
+                <a:latin typeface="Arial" charset="0"/>
+              </a:defRPr>
+            </a:lvl8pPr>
+            <a:lvl9pPr marL="3886200" indent="-228600" eaLnBrk="0" fontAlgn="base" hangingPunct="0">
+              <a:spcBef>
+                <a:spcPct val="0"/>
+              </a:spcBef>
+              <a:spcAft>
+                <a:spcPct val="0"/>
+              </a:spcAft>
+              <a:defRPr sz="2200">
+                <a:solidFill>
+                  <a:schemeClr val="tx1"/>
+                </a:solidFill>
+                <a:latin typeface="Arial" charset="0"/>
+              </a:defRPr>
+            </a:lvl9pPr>
+          </a:lstStyle>
+          <a:p>
+            <a:pPr marL="0" marR="0" lvl="0" indent="0" defTabSz="457200" rtl="0" eaLnBrk="1" fontAlgn="auto" latinLnBrk="0" hangingPunct="1">
+              <a:lnSpc>
+                <a:spcPct val="100000"/>
+              </a:lnSpc>
+              <a:spcBef>
+                <a:spcPts val="0"/>
+              </a:spcBef>
+              <a:spcAft>
+                <a:spcPts val="1200"/>
+              </a:spcAft>
+              <a:buClrTx/>
+              <a:buSzTx/>
+              <a:buFontTx/>
+              <a:buNone/>
+              <a:tabLst/>
+              <a:defRPr/>
+            </a:pPr>
+            <a:r>
+              <a:rPr kumimoji="0" lang="en-US" sz="2400" b="0" i="0" u="none" strike="noStrike" kern="1200" cap="none" spc="0" normalizeH="0" baseline="0" noProof="0" dirty="0">
+                <a:ln>
+                  <a:noFill/>
+                </a:ln>
+                <a:solidFill>
+                  <a:prstClr val="black"/>
+                </a:solidFill>
+                <a:effectLst/>
+                <a:uLnTx/>
+                <a:uFillTx/>
+                <a:latin typeface="+mn-lt"/>
+                <a:ea typeface="+mn-ea"/>
+                <a:cs typeface="+mn-cs"/>
+              </a:rPr>
+              <a:t>Phase 4  </a:t>
+            </a:r>
+            <a:endParaRPr lang="en-US" sz="2400" dirty="0">
+              <a:solidFill>
+                <a:prstClr val="black"/>
+              </a:solidFill>
+              <a:latin typeface="+mn-lt"/>
+            </a:endParaRPr>
+          </a:p>
+          <a:p>
+            <a:pPr marL="0" marR="0" lvl="0" indent="0" defTabSz="457200" rtl="0" eaLnBrk="1" fontAlgn="auto" latinLnBrk="0" hangingPunct="1">
+              <a:lnSpc>
+                <a:spcPct val="100000"/>
+              </a:lnSpc>
+              <a:spcBef>
+                <a:spcPts val="0"/>
+              </a:spcBef>
+              <a:spcAft>
+                <a:spcPts val="1200"/>
+              </a:spcAft>
+              <a:buClrTx/>
+              <a:buSzTx/>
+              <a:buFontTx/>
+              <a:buNone/>
+              <a:tabLst/>
+              <a:defRPr/>
+            </a:pPr>
+            <a:endParaRPr lang="en-US" sz="2400" dirty="0">
+              <a:solidFill>
+                <a:prstClr val="black"/>
+              </a:solidFill>
+              <a:latin typeface="+mn-lt"/>
+            </a:endParaRPr>
+          </a:p>
+          <a:p>
+            <a:pPr marL="0" marR="0" lvl="0" indent="0" defTabSz="457200" rtl="0" eaLnBrk="1" fontAlgn="auto" latinLnBrk="0" hangingPunct="1">
+              <a:lnSpc>
+                <a:spcPct val="100000"/>
+              </a:lnSpc>
+              <a:spcBef>
+                <a:spcPts val="0"/>
+              </a:spcBef>
+              <a:spcAft>
+                <a:spcPts val="1200"/>
+              </a:spcAft>
+              <a:buClrTx/>
+              <a:buSzTx/>
+              <a:buFontTx/>
+              <a:buNone/>
+              <a:tabLst/>
+              <a:defRPr/>
+            </a:pPr>
+            <a:endParaRPr lang="en-US" sz="2400" dirty="0">
+              <a:solidFill>
+                <a:prstClr val="black"/>
+              </a:solidFill>
+              <a:latin typeface="+mn-lt"/>
+            </a:endParaRPr>
+          </a:p>
+          <a:p>
+            <a:pPr marL="0" marR="0" lvl="0" indent="0" defTabSz="457200" rtl="0" eaLnBrk="1" fontAlgn="auto" latinLnBrk="0" hangingPunct="1">
+              <a:lnSpc>
+                <a:spcPct val="100000"/>
+              </a:lnSpc>
+              <a:spcBef>
+                <a:spcPts val="0"/>
+              </a:spcBef>
+              <a:spcAft>
+                <a:spcPts val="1200"/>
+              </a:spcAft>
+              <a:buClrTx/>
+              <a:buSzTx/>
+              <a:buFontTx/>
+              <a:buNone/>
+              <a:tabLst/>
+              <a:defRPr/>
+            </a:pPr>
+            <a:endParaRPr lang="en-US" sz="2400" dirty="0">
+              <a:solidFill>
+                <a:prstClr val="black"/>
+              </a:solidFill>
+              <a:latin typeface="+mn-lt"/>
+            </a:endParaRPr>
+          </a:p>
+          <a:p>
+            <a:pPr marL="0" marR="0" lvl="0" indent="0" defTabSz="457200" rtl="0" eaLnBrk="1" fontAlgn="auto" latinLnBrk="0" hangingPunct="1">
+              <a:lnSpc>
+                <a:spcPct val="100000"/>
+              </a:lnSpc>
+              <a:spcBef>
+                <a:spcPts val="0"/>
+              </a:spcBef>
+              <a:spcAft>
+                <a:spcPts val="1200"/>
+              </a:spcAft>
+              <a:buClrTx/>
+              <a:buSzTx/>
+              <a:buFontTx/>
+              <a:buNone/>
+              <a:tabLst/>
+              <a:defRPr/>
+            </a:pPr>
+            <a:endParaRPr lang="en-US" sz="2400" dirty="0">
+              <a:solidFill>
+                <a:prstClr val="black"/>
+              </a:solidFill>
+              <a:latin typeface="+mn-lt"/>
+            </a:endParaRPr>
+          </a:p>
+        </p:txBody>
+      </p:sp>
     </p:spTree>
     <p:extLst>
       <p:ext uri="{BB962C8B-B14F-4D97-AF65-F5344CB8AC3E}">

</xml_diff>

<commit_message>
Add Phase 4 results summary and analysis to phase4_result.txt
</commit_message>
<xml_diff>
--- a/bench inspection poster/Presentation2.pptx
+++ b/bench inspection poster/Presentation2.pptx
@@ -3726,10 +3726,10 @@
         </p:nvGrpSpPr>
         <p:grpSpPr>
           <a:xfrm>
-            <a:off x="7348061" y="16387456"/>
-            <a:ext cx="6724016" cy="12774366"/>
+            <a:off x="7348061" y="17790950"/>
+            <a:ext cx="6724016" cy="11420150"/>
             <a:chOff x="440418" y="5694830"/>
-            <a:chExt cx="9183262" cy="12774366"/>
+            <a:chExt cx="9183262" cy="11420150"/>
           </a:xfrm>
         </p:grpSpPr>
         <p:sp>
@@ -3749,7 +3749,7 @@
           <p:spPr bwMode="auto">
             <a:xfrm>
               <a:off x="440418" y="6668631"/>
-              <a:ext cx="9183262" cy="11800565"/>
+              <a:ext cx="9183262" cy="10446349"/>
             </a:xfrm>
             <a:prstGeom prst="rect">
               <a:avLst/>
@@ -4139,25 +4139,22 @@
                 </a:rPr>
                 <a:t> breakthrough is in phase 3. Feature engineering dramatically improved Config C for MLP model from 0.33 to 0.80 and Ridge model from -0.17 to 0.80.</a:t>
               </a:r>
-            </a:p>
-            <a:p>
-              <a:pPr marL="0" marR="0" lvl="0" indent="0" defTabSz="457200" rtl="0" eaLnBrk="1" fontAlgn="auto" latinLnBrk="0" hangingPunct="1">
-                <a:lnSpc>
-                  <a:spcPct val="100000"/>
-                </a:lnSpc>
-                <a:spcBef>
-                  <a:spcPts val="0"/>
-                </a:spcBef>
-                <a:spcAft>
-                  <a:spcPts val="1200"/>
-                </a:spcAft>
-                <a:buClrTx/>
-                <a:buSzTx/>
-                <a:buFontTx/>
-                <a:buNone/>
-                <a:tabLst/>
-                <a:defRPr/>
-              </a:pPr>
+              <a:br>
+                <a:rPr lang="en-US" sz="2400" dirty="0">
+                  <a:solidFill>
+                    <a:prstClr val="black"/>
+                  </a:solidFill>
+                  <a:latin typeface="+mn-lt"/>
+                </a:rPr>
+              </a:br>
+              <a:br>
+                <a:rPr lang="en-US" sz="2400" dirty="0">
+                  <a:solidFill>
+                    <a:prstClr val="black"/>
+                  </a:solidFill>
+                  <a:latin typeface="+mn-lt"/>
+                </a:rPr>
+              </a:br>
               <a:endParaRPr lang="en-US" sz="2400" dirty="0">
                 <a:solidFill>
                   <a:prstClr val="black"/>
@@ -4166,96 +4163,10 @@
               </a:endParaRPr>
             </a:p>
             <a:p>
-              <a:pPr marL="0" marR="0" lvl="0" indent="0" defTabSz="457200" rtl="0" eaLnBrk="1" fontAlgn="auto" latinLnBrk="0" hangingPunct="1">
-                <a:lnSpc>
-                  <a:spcPct val="100000"/>
-                </a:lnSpc>
-                <a:spcBef>
-                  <a:spcPts val="0"/>
-                </a:spcBef>
+              <a:pPr lvl="0" eaLnBrk="1" hangingPunct="1">
                 <a:spcAft>
                   <a:spcPts val="1200"/>
                 </a:spcAft>
-                <a:buClrTx/>
-                <a:buSzTx/>
-                <a:buFontTx/>
-                <a:buNone/>
-                <a:tabLst/>
-                <a:defRPr/>
-              </a:pPr>
-              <a:endParaRPr lang="en-US" sz="2400" dirty="0">
-                <a:solidFill>
-                  <a:prstClr val="black"/>
-                </a:solidFill>
-                <a:latin typeface="+mn-lt"/>
-              </a:endParaRPr>
-            </a:p>
-            <a:p>
-              <a:pPr marL="0" marR="0" lvl="0" indent="0" defTabSz="457200" rtl="0" eaLnBrk="1" fontAlgn="auto" latinLnBrk="0" hangingPunct="1">
-                <a:lnSpc>
-                  <a:spcPct val="100000"/>
-                </a:lnSpc>
-                <a:spcBef>
-                  <a:spcPts val="0"/>
-                </a:spcBef>
-                <a:spcAft>
-                  <a:spcPts val="1200"/>
-                </a:spcAft>
-                <a:buClrTx/>
-                <a:buSzTx/>
-                <a:buFontTx/>
-                <a:buNone/>
-                <a:tabLst/>
-                <a:defRPr/>
-              </a:pPr>
-              <a:endParaRPr lang="en-US" sz="2400" dirty="0">
-                <a:solidFill>
-                  <a:prstClr val="black"/>
-                </a:solidFill>
-                <a:latin typeface="+mn-lt"/>
-              </a:endParaRPr>
-            </a:p>
-            <a:p>
-              <a:pPr marL="0" marR="0" lvl="0" indent="0" defTabSz="457200" rtl="0" eaLnBrk="1" fontAlgn="auto" latinLnBrk="0" hangingPunct="1">
-                <a:lnSpc>
-                  <a:spcPct val="100000"/>
-                </a:lnSpc>
-                <a:spcBef>
-                  <a:spcPts val="0"/>
-                </a:spcBef>
-                <a:spcAft>
-                  <a:spcPts val="1200"/>
-                </a:spcAft>
-                <a:buClrTx/>
-                <a:buSzTx/>
-                <a:buFontTx/>
-                <a:buNone/>
-                <a:tabLst/>
-                <a:defRPr/>
-              </a:pPr>
-              <a:endParaRPr lang="en-US" sz="2400" dirty="0">
-                <a:solidFill>
-                  <a:prstClr val="black"/>
-                </a:solidFill>
-                <a:latin typeface="+mn-lt"/>
-              </a:endParaRPr>
-            </a:p>
-            <a:p>
-              <a:pPr marL="0" marR="0" lvl="0" indent="0" defTabSz="457200" rtl="0" eaLnBrk="1" fontAlgn="auto" latinLnBrk="0" hangingPunct="1">
-                <a:lnSpc>
-                  <a:spcPct val="100000"/>
-                </a:lnSpc>
-                <a:spcBef>
-                  <a:spcPts val="0"/>
-                </a:spcBef>
-                <a:spcAft>
-                  <a:spcPts val="1200"/>
-                </a:spcAft>
-                <a:buClrTx/>
-                <a:buSzTx/>
-                <a:buFontTx/>
-                <a:buNone/>
-                <a:tabLst/>
                 <a:defRPr/>
               </a:pPr>
               <a:endParaRPr lang="en-US" sz="2400" dirty="0">
@@ -4746,10 +4657,10 @@
         </p:nvGrpSpPr>
         <p:grpSpPr>
           <a:xfrm>
-            <a:off x="14392421" y="17013613"/>
-            <a:ext cx="6748634" cy="8711716"/>
+            <a:off x="14392421" y="17826413"/>
+            <a:ext cx="6748634" cy="1817521"/>
             <a:chOff x="440418" y="5694830"/>
-            <a:chExt cx="9183262" cy="8711716"/>
+            <a:chExt cx="9183262" cy="1817521"/>
           </a:xfrm>
         </p:grpSpPr>
         <p:sp>
@@ -4769,7 +4680,7 @@
           <p:spPr bwMode="auto">
             <a:xfrm>
               <a:off x="440418" y="6668631"/>
-              <a:ext cx="9183262" cy="7737915"/>
+              <a:ext cx="9183262" cy="843720"/>
             </a:xfrm>
             <a:prstGeom prst="rect">
               <a:avLst/>
@@ -4890,59 +4801,9 @@
             </a:lstStyle>
             <a:p>
               <a:pPr eaLnBrk="1" hangingPunct="1"/>
-              <a:r>
-                <a:rPr lang="en-US" sz="3200" dirty="0">
-                  <a:latin typeface="+mn-lt"/>
-                </a:rPr>
-                <a:t>Inspired by CNC machining, this project creates an automated drawing machine using an Etch A Sketch board</a:t>
-              </a:r>
-              <a:r>
-                <a:rPr lang="en-US" sz="3200" baseline="30000" dirty="0">
-                  <a:latin typeface="Calibri" pitchFamily="34" charset="0"/>
-                </a:rPr>
-                <a:t>[1]</a:t>
-              </a:r>
-              <a:r>
-                <a:rPr lang="en-US" sz="3200" dirty="0">
-                  <a:latin typeface="Calibri" pitchFamily="34" charset="0"/>
-                </a:rPr>
-                <a:t>.</a:t>
-              </a:r>
-              <a:r>
-                <a:rPr lang="en-US" sz="3200" dirty="0">
-                  <a:latin typeface="+mn-lt"/>
-                </a:rPr>
-                <a:t> </a:t>
-              </a:r>
-            </a:p>
-            <a:p>
-              <a:pPr eaLnBrk="1" hangingPunct="1"/>
               <a:endParaRPr lang="en-US" sz="3200" dirty="0">
                 <a:latin typeface="+mn-lt"/>
               </a:endParaRPr>
-            </a:p>
-            <a:p>
-              <a:pPr eaLnBrk="1" hangingPunct="1"/>
-              <a:r>
-                <a:rPr lang="en-US" sz="3200" dirty="0">
-                  <a:latin typeface="+mn-lt"/>
-                </a:rPr>
-                <a:t>It first introduces a software pipeline that transforms digital images into continuous-line drawings. By employing edge detection techniques and a specialized depth-first search (DFS) algorithm, our system generates optimized G-code instructions tailored for our custom-built drawing machine.</a:t>
-              </a:r>
-            </a:p>
-            <a:p>
-              <a:pPr eaLnBrk="1" hangingPunct="1"/>
-              <a:br>
-                <a:rPr lang="en-US" sz="3200" dirty="0">
-                  <a:latin typeface="+mn-lt"/>
-                </a:rPr>
-              </a:br>
-              <a:r>
-                <a:rPr lang="en-US" sz="3200" dirty="0">
-                  <a:latin typeface="+mn-lt"/>
-                </a:rPr>
-                <a:t>The hardware system interprets these instructions and uses two stepper motors to precisely control the Etch A Sketch knobs, allowing the machine to replicate digital images as physical sketches.</a:t>
-              </a:r>
             </a:p>
           </p:txBody>
         </p:sp>
@@ -4994,7 +4855,7 @@
             <a:p>
               <a:pPr algn="ctr"/>
               <a:r>
-                <a:rPr lang="en-US" sz="5400" b="1">
+                <a:rPr lang="en-US" sz="5400" b="1" dirty="0">
                   <a:solidFill>
                     <a:schemeClr val="accent3">
                       <a:lumMod val="20000"/>
@@ -5002,7 +4863,7 @@
                     </a:schemeClr>
                   </a:solidFill>
                 </a:rPr>
-                <a:t>Introduction</a:t>
+                <a:t>Conclusion</a:t>
               </a:r>
             </a:p>
           </p:txBody>
@@ -5549,7 +5410,7 @@
         <p:spPr bwMode="auto">
           <a:xfrm>
             <a:off x="7348061" y="3091330"/>
-            <a:ext cx="6724016" cy="13139393"/>
+            <a:ext cx="6724016" cy="14539777"/>
           </a:xfrm>
           <a:prstGeom prst="rect">
             <a:avLst/>
@@ -6053,7 +5914,7 @@
               <a:rPr lang="en-US" sz="2400" dirty="0">
                 <a:latin typeface="+mn-lt"/>
               </a:rPr>
-              <a:t>Evaluate R</a:t>
+              <a:t>Statistically evaluate R</a:t>
             </a:r>
             <a:r>
               <a:rPr lang="en-US" sz="2400" baseline="30000" dirty="0">
@@ -6065,7 +5926,7 @@
               <a:rPr lang="en-US" sz="2400" dirty="0">
                 <a:latin typeface="+mn-lt"/>
               </a:rPr>
-              <a:t> confidence interval of  Ridge and PLS using bootstrap resampling, </a:t>
+              <a:t> confidence interval of  Ridge and PLS using bootstrap resampling.</a:t>
             </a:r>
           </a:p>
           <a:p>
@@ -6077,7 +5938,19 @@
               <a:rPr lang="en-US" sz="2400" dirty="0">
                 <a:latin typeface="+mn-lt"/>
               </a:rPr>
-              <a:t>Examine the overall best model and config via eliminating features.</a:t>
+              <a:t>Analyze model’s essential learning outcome using permutation test.</a:t>
+            </a:r>
+          </a:p>
+          <a:p>
+            <a:pPr marL="342900" indent="-342900" eaLnBrk="1" hangingPunct="1">
+              <a:buFont typeface="Arial" panose="020B0604020202020204" pitchFamily="34" charset="0"/>
+              <a:buChar char="•"/>
+            </a:pPr>
+            <a:r>
+              <a:rPr lang="en-US" sz="2400" dirty="0">
+                <a:latin typeface="+mn-lt"/>
+              </a:rPr>
+              <a:t>Remove low representative features via eliminating one-by-one (backward elimination) or category-by-category (category ablation), to find the best performed model and config.</a:t>
             </a:r>
           </a:p>
         </p:txBody>
@@ -6225,38 +6098,8 @@
         </p:blipFill>
         <p:spPr>
           <a:xfrm>
-            <a:off x="8443475" y="18992254"/>
+            <a:off x="8443475" y="20464444"/>
             <a:ext cx="4498802" cy="2249402"/>
-          </a:xfrm>
-          <a:prstGeom prst="rect">
-            <a:avLst/>
-          </a:prstGeom>
-        </p:spPr>
-      </p:pic>
-      <p:pic>
-        <p:nvPicPr>
-          <p:cNvPr id="7" name="Picture 6">
-            <a:extLst>
-              <a:ext uri="{FF2B5EF4-FFF2-40B4-BE49-F238E27FC236}">
-                <a16:creationId xmlns:a16="http://schemas.microsoft.com/office/drawing/2014/main" id="{F20AF61B-B1F5-5EA9-D336-F730C1D07EA5}"/>
-              </a:ext>
-            </a:extLst>
-          </p:cNvPr>
-          <p:cNvPicPr>
-            <a:picLocks noChangeAspect="1"/>
-          </p:cNvPicPr>
-          <p:nvPr/>
-        </p:nvPicPr>
-        <p:blipFill>
-          <a:blip r:embed="rId12"/>
-          <a:stretch>
-            <a:fillRect/>
-          </a:stretch>
-        </p:blipFill>
-        <p:spPr>
-          <a:xfrm>
-            <a:off x="7367373" y="26509224"/>
-            <a:ext cx="6651006" cy="2217002"/>
           </a:xfrm>
           <a:prstGeom prst="rect">
             <a:avLst/>
@@ -6280,7 +6123,7 @@
         <p:spPr bwMode="auto">
           <a:xfrm>
             <a:off x="14392421" y="3093708"/>
-            <a:ext cx="6724016" cy="2813490"/>
+            <a:ext cx="6724016" cy="14508999"/>
           </a:xfrm>
           <a:prstGeom prst="rect">
             <a:avLst/>
@@ -6417,28 +6260,19 @@
               <a:tabLst/>
               <a:defRPr/>
             </a:pPr>
-            <a:r>
-              <a:rPr kumimoji="0" lang="en-US" sz="2400" b="0" i="0" u="none" strike="noStrike" kern="1200" cap="none" spc="0" normalizeH="0" baseline="0" noProof="0" dirty="0">
-                <a:ln>
-                  <a:noFill/>
-                </a:ln>
-                <a:solidFill>
-                  <a:prstClr val="black"/>
-                </a:solidFill>
-                <a:effectLst/>
-                <a:uLnTx/>
-                <a:uFillTx/>
-                <a:latin typeface="+mn-lt"/>
-                <a:ea typeface="+mn-ea"/>
-                <a:cs typeface="+mn-cs"/>
-              </a:rPr>
-              <a:t>Phase 4  </a:t>
-            </a:r>
-            <a:endParaRPr lang="en-US" sz="2400" dirty="0">
+            <a:endParaRPr kumimoji="0" lang="en-US" sz="2400" b="0" i="0" u="none" strike="noStrike" kern="1200" cap="none" spc="0" normalizeH="0" baseline="0" noProof="0" dirty="0">
+              <a:ln>
+                <a:noFill/>
+              </a:ln>
               <a:solidFill>
                 <a:prstClr val="black"/>
               </a:solidFill>
+              <a:effectLst/>
+              <a:uLnTx/>
+              <a:uFillTx/>
               <a:latin typeface="+mn-lt"/>
+              <a:ea typeface="+mn-ea"/>
+              <a:cs typeface="+mn-cs"/>
             </a:endParaRPr>
           </a:p>
           <a:p>
@@ -6484,11 +6318,19 @@
               <a:tabLst/>
               <a:defRPr/>
             </a:pPr>
-            <a:endParaRPr lang="en-US" sz="2400" dirty="0">
+            <a:endParaRPr kumimoji="0" lang="en-US" sz="2400" b="0" i="0" u="none" strike="noStrike" kern="1200" cap="none" spc="0" normalizeH="0" baseline="0" noProof="0" dirty="0">
+              <a:ln>
+                <a:noFill/>
+              </a:ln>
               <a:solidFill>
                 <a:prstClr val="black"/>
               </a:solidFill>
+              <a:effectLst/>
+              <a:uLnTx/>
+              <a:uFillTx/>
               <a:latin typeface="+mn-lt"/>
+              <a:ea typeface="+mn-ea"/>
+              <a:cs typeface="+mn-cs"/>
             </a:endParaRPr>
           </a:p>
           <a:p>
@@ -6534,6 +6376,170 @@
               <a:tabLst/>
               <a:defRPr/>
             </a:pPr>
+            <a:r>
+              <a:rPr kumimoji="0" lang="en-US" sz="2400" b="0" i="0" u="none" strike="noStrike" kern="1200" cap="none" spc="0" normalizeH="0" baseline="0" noProof="0" dirty="0">
+                <a:ln>
+                  <a:noFill/>
+                </a:ln>
+                <a:solidFill>
+                  <a:prstClr val="black"/>
+                </a:solidFill>
+                <a:effectLst/>
+                <a:uLnTx/>
+                <a:uFillTx/>
+                <a:latin typeface="+mn-lt"/>
+                <a:ea typeface="+mn-ea"/>
+                <a:cs typeface="+mn-cs"/>
+              </a:rPr>
+              <a:t>Phase 4 discovers that CO</a:t>
+            </a:r>
+            <a:r>
+              <a:rPr kumimoji="0" lang="en-US" sz="2400" b="0" i="0" u="none" strike="noStrike" kern="1200" cap="none" spc="0" normalizeH="0" baseline="-25000" noProof="0" dirty="0">
+                <a:ln>
+                  <a:noFill/>
+                </a:ln>
+                <a:solidFill>
+                  <a:prstClr val="black"/>
+                </a:solidFill>
+                <a:effectLst/>
+                <a:uLnTx/>
+                <a:uFillTx/>
+                <a:latin typeface="+mn-lt"/>
+                <a:ea typeface="+mn-ea"/>
+                <a:cs typeface="+mn-cs"/>
+              </a:rPr>
+              <a:t>2</a:t>
+            </a:r>
+            <a:r>
+              <a:rPr kumimoji="0" lang="en-US" sz="2400" b="0" i="0" u="none" strike="noStrike" kern="1200" cap="none" spc="0" normalizeH="0" noProof="0" dirty="0">
+                <a:ln>
+                  <a:noFill/>
+                </a:ln>
+                <a:solidFill>
+                  <a:prstClr val="black"/>
+                </a:solidFill>
+                <a:effectLst/>
+                <a:uLnTx/>
+                <a:uFillTx/>
+                <a:latin typeface="+mn-lt"/>
+                <a:ea typeface="+mn-ea"/>
+                <a:cs typeface="+mn-cs"/>
+              </a:rPr>
+              <a:t> flow rate and its OES band integral are two most important factor that affect H</a:t>
+            </a:r>
+            <a:r>
+              <a:rPr kumimoji="0" lang="en-US" sz="2400" b="0" i="0" u="none" strike="noStrike" kern="1200" cap="none" spc="0" normalizeH="0" baseline="-25000" noProof="0" dirty="0">
+                <a:ln>
+                  <a:noFill/>
+                </a:ln>
+                <a:solidFill>
+                  <a:prstClr val="black"/>
+                </a:solidFill>
+                <a:effectLst/>
+                <a:uLnTx/>
+                <a:uFillTx/>
+                <a:latin typeface="+mn-lt"/>
+                <a:ea typeface="+mn-ea"/>
+                <a:cs typeface="+mn-cs"/>
+              </a:rPr>
+              <a:t>2</a:t>
+            </a:r>
+            <a:r>
+              <a:rPr kumimoji="0" lang="en-US" sz="2400" b="0" i="0" u="none" strike="noStrike" kern="1200" cap="none" spc="0" normalizeH="0" noProof="0" dirty="0">
+                <a:ln>
+                  <a:noFill/>
+                </a:ln>
+                <a:solidFill>
+                  <a:prstClr val="black"/>
+                </a:solidFill>
+                <a:effectLst/>
+                <a:uLnTx/>
+                <a:uFillTx/>
+                <a:latin typeface="+mn-lt"/>
+                <a:ea typeface="+mn-ea"/>
+                <a:cs typeface="+mn-cs"/>
+              </a:rPr>
+              <a:t>O</a:t>
+            </a:r>
+            <a:r>
+              <a:rPr kumimoji="0" lang="en-US" sz="2400" b="0" i="0" u="none" strike="noStrike" kern="1200" cap="none" spc="0" normalizeH="0" baseline="-25000" noProof="0" dirty="0">
+                <a:ln>
+                  <a:noFill/>
+                </a:ln>
+                <a:solidFill>
+                  <a:prstClr val="black"/>
+                </a:solidFill>
+                <a:effectLst/>
+                <a:uLnTx/>
+                <a:uFillTx/>
+                <a:latin typeface="+mn-lt"/>
+                <a:ea typeface="+mn-ea"/>
+                <a:cs typeface="+mn-cs"/>
+              </a:rPr>
+              <a:t>2 </a:t>
+            </a:r>
+            <a:r>
+              <a:rPr kumimoji="0" lang="en-US" sz="2400" b="0" i="0" u="none" strike="noStrike" kern="1200" cap="none" spc="0" normalizeH="0" noProof="0" dirty="0">
+                <a:ln>
+                  <a:noFill/>
+                </a:ln>
+                <a:solidFill>
+                  <a:prstClr val="black"/>
+                </a:solidFill>
+                <a:effectLst/>
+                <a:uLnTx/>
+                <a:uFillTx/>
+                <a:latin typeface="+mn-lt"/>
+                <a:ea typeface="+mn-ea"/>
+                <a:cs typeface="+mn-cs"/>
+              </a:rPr>
+              <a:t>yield. Meanwhile, bootstrap confidence interval analysis shows that there </a:t>
+            </a:r>
+            <a:r>
+              <a:rPr lang="en-US" sz="2400" dirty="0">
+                <a:solidFill>
+                  <a:prstClr val="black"/>
+                </a:solidFill>
+                <a:latin typeface="+mn-lt"/>
+              </a:rPr>
+              <a:t>is no statistic difference between </a:t>
+            </a:r>
+            <a:r>
+              <a:rPr kumimoji="0" lang="en-US" sz="2400" b="0" i="0" u="none" strike="noStrike" kern="1200" cap="none" spc="0" normalizeH="0" noProof="0" dirty="0">
+                <a:ln>
+                  <a:noFill/>
+                </a:ln>
+                <a:solidFill>
+                  <a:prstClr val="black"/>
+                </a:solidFill>
+                <a:effectLst/>
+                <a:uLnTx/>
+                <a:uFillTx/>
+                <a:latin typeface="+mn-lt"/>
+                <a:ea typeface="+mn-ea"/>
+                <a:cs typeface="+mn-cs"/>
+              </a:rPr>
+              <a:t>Ridge config C and MLP config C. </a:t>
+            </a:r>
+          </a:p>
+          <a:p>
+            <a:pPr marL="0" marR="0" lvl="0" indent="0" defTabSz="457200" rtl="0" eaLnBrk="1" fontAlgn="auto" latinLnBrk="0" hangingPunct="1">
+              <a:lnSpc>
+                <a:spcPct val="100000"/>
+              </a:lnSpc>
+              <a:spcBef>
+                <a:spcPts val="0"/>
+              </a:spcBef>
+              <a:spcAft>
+                <a:spcPts val="1200"/>
+              </a:spcAft>
+              <a:buClrTx/>
+              <a:buSzTx/>
+              <a:buFontTx/>
+              <a:buNone/>
+              <a:tabLst/>
+              <a:defRPr/>
+            </a:pPr>
             <a:endParaRPr lang="en-US" sz="2400" dirty="0">
               <a:solidFill>
                 <a:prstClr val="black"/>
@@ -6541,8 +6547,420 @@
               <a:latin typeface="+mn-lt"/>
             </a:endParaRPr>
           </a:p>
+          <a:p>
+            <a:pPr marL="0" marR="0" lvl="0" indent="0" defTabSz="457200" rtl="0" eaLnBrk="1" fontAlgn="auto" latinLnBrk="0" hangingPunct="1">
+              <a:lnSpc>
+                <a:spcPct val="100000"/>
+              </a:lnSpc>
+              <a:spcBef>
+                <a:spcPts val="0"/>
+              </a:spcBef>
+              <a:spcAft>
+                <a:spcPts val="1200"/>
+              </a:spcAft>
+              <a:buClrTx/>
+              <a:buSzTx/>
+              <a:buFontTx/>
+              <a:buNone/>
+              <a:tabLst/>
+              <a:defRPr/>
+            </a:pPr>
+            <a:endParaRPr lang="en-US" sz="2400" dirty="0">
+              <a:solidFill>
+                <a:prstClr val="black"/>
+              </a:solidFill>
+              <a:latin typeface="+mn-lt"/>
+            </a:endParaRPr>
+          </a:p>
+          <a:p>
+            <a:pPr marL="0" marR="0" lvl="0" indent="0" defTabSz="457200" rtl="0" eaLnBrk="1" fontAlgn="auto" latinLnBrk="0" hangingPunct="1">
+              <a:lnSpc>
+                <a:spcPct val="100000"/>
+              </a:lnSpc>
+              <a:spcBef>
+                <a:spcPts val="0"/>
+              </a:spcBef>
+              <a:spcAft>
+                <a:spcPts val="1200"/>
+              </a:spcAft>
+              <a:buClrTx/>
+              <a:buSzTx/>
+              <a:buFontTx/>
+              <a:buNone/>
+              <a:tabLst/>
+              <a:defRPr/>
+            </a:pPr>
+            <a:endParaRPr lang="en-US" sz="2400" dirty="0">
+              <a:solidFill>
+                <a:prstClr val="black"/>
+              </a:solidFill>
+              <a:latin typeface="+mn-lt"/>
+            </a:endParaRPr>
+          </a:p>
+          <a:p>
+            <a:pPr marL="0" marR="0" lvl="0" indent="0" defTabSz="457200" rtl="0" eaLnBrk="1" fontAlgn="auto" latinLnBrk="0" hangingPunct="1">
+              <a:lnSpc>
+                <a:spcPct val="100000"/>
+              </a:lnSpc>
+              <a:spcBef>
+                <a:spcPts val="0"/>
+              </a:spcBef>
+              <a:spcAft>
+                <a:spcPts val="1200"/>
+              </a:spcAft>
+              <a:buClrTx/>
+              <a:buSzTx/>
+              <a:buFontTx/>
+              <a:buNone/>
+              <a:tabLst/>
+              <a:defRPr/>
+            </a:pPr>
+            <a:endParaRPr lang="en-US" sz="2400" dirty="0">
+              <a:solidFill>
+                <a:prstClr val="black"/>
+              </a:solidFill>
+              <a:latin typeface="+mn-lt"/>
+            </a:endParaRPr>
+          </a:p>
+          <a:p>
+            <a:pPr marL="0" marR="0" lvl="0" indent="0" defTabSz="457200" rtl="0" eaLnBrk="1" fontAlgn="auto" latinLnBrk="0" hangingPunct="1">
+              <a:lnSpc>
+                <a:spcPct val="100000"/>
+              </a:lnSpc>
+              <a:spcBef>
+                <a:spcPts val="0"/>
+              </a:spcBef>
+              <a:spcAft>
+                <a:spcPts val="1200"/>
+              </a:spcAft>
+              <a:buClrTx/>
+              <a:buSzTx/>
+              <a:buFontTx/>
+              <a:buNone/>
+              <a:tabLst/>
+              <a:defRPr/>
+            </a:pPr>
+            <a:endParaRPr lang="en-US" sz="2400" dirty="0">
+              <a:solidFill>
+                <a:prstClr val="black"/>
+              </a:solidFill>
+              <a:latin typeface="+mn-lt"/>
+            </a:endParaRPr>
+          </a:p>
+          <a:p>
+            <a:pPr marL="0" marR="0" lvl="0" indent="0" defTabSz="457200" rtl="0" eaLnBrk="1" fontAlgn="auto" latinLnBrk="0" hangingPunct="1">
+              <a:lnSpc>
+                <a:spcPct val="100000"/>
+              </a:lnSpc>
+              <a:spcBef>
+                <a:spcPts val="0"/>
+              </a:spcBef>
+              <a:spcAft>
+                <a:spcPts val="1200"/>
+              </a:spcAft>
+              <a:buClrTx/>
+              <a:buSzTx/>
+              <a:buFontTx/>
+              <a:buNone/>
+              <a:tabLst/>
+              <a:defRPr/>
+            </a:pPr>
+            <a:endParaRPr lang="en-US" sz="2400" dirty="0">
+              <a:solidFill>
+                <a:prstClr val="black"/>
+              </a:solidFill>
+              <a:latin typeface="+mn-lt"/>
+            </a:endParaRPr>
+          </a:p>
+          <a:p>
+            <a:pPr marL="0" marR="0" lvl="0" indent="0" defTabSz="457200" rtl="0" eaLnBrk="1" fontAlgn="auto" latinLnBrk="0" hangingPunct="1">
+              <a:lnSpc>
+                <a:spcPct val="100000"/>
+              </a:lnSpc>
+              <a:spcBef>
+                <a:spcPts val="0"/>
+              </a:spcBef>
+              <a:spcAft>
+                <a:spcPts val="1200"/>
+              </a:spcAft>
+              <a:buClrTx/>
+              <a:buSzTx/>
+              <a:buFontTx/>
+              <a:buNone/>
+              <a:tabLst/>
+              <a:defRPr/>
+            </a:pPr>
+            <a:endParaRPr lang="en-US" sz="2400" dirty="0">
+              <a:solidFill>
+                <a:prstClr val="black"/>
+              </a:solidFill>
+              <a:latin typeface="+mn-lt"/>
+            </a:endParaRPr>
+          </a:p>
+          <a:p>
+            <a:pPr marL="0" marR="0" lvl="0" indent="0" defTabSz="457200" rtl="0" eaLnBrk="1" fontAlgn="auto" latinLnBrk="0" hangingPunct="1">
+              <a:lnSpc>
+                <a:spcPct val="100000"/>
+              </a:lnSpc>
+              <a:spcBef>
+                <a:spcPts val="0"/>
+              </a:spcBef>
+              <a:spcAft>
+                <a:spcPts val="1200"/>
+              </a:spcAft>
+              <a:buClrTx/>
+              <a:buSzTx/>
+              <a:buFontTx/>
+              <a:buNone/>
+              <a:tabLst/>
+              <a:defRPr/>
+            </a:pPr>
+            <a:endParaRPr lang="en-US" sz="2400" dirty="0">
+              <a:solidFill>
+                <a:prstClr val="black"/>
+              </a:solidFill>
+              <a:latin typeface="+mn-lt"/>
+            </a:endParaRPr>
+          </a:p>
+          <a:p>
+            <a:pPr marL="0" marR="0" lvl="0" indent="0" defTabSz="457200" rtl="0" eaLnBrk="1" fontAlgn="auto" latinLnBrk="0" hangingPunct="1">
+              <a:lnSpc>
+                <a:spcPct val="100000"/>
+              </a:lnSpc>
+              <a:spcBef>
+                <a:spcPts val="0"/>
+              </a:spcBef>
+              <a:spcAft>
+                <a:spcPts val="1200"/>
+              </a:spcAft>
+              <a:buClrTx/>
+              <a:buSzTx/>
+              <a:buFontTx/>
+              <a:buNone/>
+              <a:tabLst/>
+              <a:defRPr/>
+            </a:pPr>
+            <a:endParaRPr lang="en-US" sz="2400" dirty="0">
+              <a:solidFill>
+                <a:prstClr val="black"/>
+              </a:solidFill>
+              <a:latin typeface="+mn-lt"/>
+            </a:endParaRPr>
+          </a:p>
+          <a:p>
+            <a:pPr lvl="0" eaLnBrk="1" hangingPunct="1">
+              <a:spcAft>
+                <a:spcPts val="1200"/>
+              </a:spcAft>
+              <a:defRPr/>
+            </a:pPr>
+            <a:r>
+              <a:rPr lang="en-US" sz="2400" dirty="0">
+                <a:solidFill>
+                  <a:prstClr val="black"/>
+                </a:solidFill>
+                <a:latin typeface="+mn-lt"/>
+              </a:rPr>
+              <a:t>Permutation test validates that Ridge model successfully captures mapping relationship from X-&gt;Y with </a:t>
+            </a:r>
+            <a:r>
+              <a:rPr lang="en-US" sz="2400" i="1" dirty="0">
+                <a:solidFill>
+                  <a:prstClr val="black"/>
+                </a:solidFill>
+                <a:latin typeface="+mn-lt"/>
+              </a:rPr>
+              <a:t>p&lt;0.00005.</a:t>
+            </a:r>
+            <a:r>
+              <a:rPr lang="en-US" sz="2400" dirty="0">
+                <a:solidFill>
+                  <a:prstClr val="black"/>
+                </a:solidFill>
+                <a:latin typeface="+mn-lt"/>
+              </a:rPr>
+              <a:t> </a:t>
+            </a:r>
+          </a:p>
+          <a:p>
+            <a:pPr lvl="0" eaLnBrk="1" hangingPunct="1">
+              <a:spcAft>
+                <a:spcPts val="1200"/>
+              </a:spcAft>
+              <a:defRPr/>
+            </a:pPr>
+            <a:r>
+              <a:rPr lang="en-US" sz="2400" dirty="0">
+                <a:solidFill>
+                  <a:prstClr val="black"/>
+                </a:solidFill>
+                <a:latin typeface="+mn-lt"/>
+              </a:rPr>
+              <a:t>After eliminating features one by one reversely, the best model and input is found to be Ridge with 3 OES ratios + discharge parameter.</a:t>
+            </a:r>
+          </a:p>
+          <a:p>
+            <a:pPr lvl="0" eaLnBrk="1" hangingPunct="1">
+              <a:spcAft>
+                <a:spcPts val="1200"/>
+              </a:spcAft>
+              <a:defRPr/>
+            </a:pPr>
+            <a:endParaRPr lang="en-US" sz="2400" dirty="0">
+              <a:solidFill>
+                <a:prstClr val="black"/>
+              </a:solidFill>
+              <a:latin typeface="+mn-lt"/>
+            </a:endParaRPr>
+          </a:p>
+          <a:p>
+            <a:pPr lvl="0" eaLnBrk="1" hangingPunct="1">
+              <a:spcAft>
+                <a:spcPts val="1200"/>
+              </a:spcAft>
+              <a:defRPr/>
+            </a:pPr>
+            <a:endParaRPr lang="en-US" sz="2400" dirty="0">
+              <a:solidFill>
+                <a:prstClr val="black"/>
+              </a:solidFill>
+              <a:latin typeface="+mn-lt"/>
+            </a:endParaRPr>
+          </a:p>
+          <a:p>
+            <a:pPr lvl="0" eaLnBrk="1" hangingPunct="1">
+              <a:spcAft>
+                <a:spcPts val="1200"/>
+              </a:spcAft>
+              <a:defRPr/>
+            </a:pPr>
+            <a:endParaRPr lang="en-US" sz="2400" dirty="0">
+              <a:solidFill>
+                <a:prstClr val="black"/>
+              </a:solidFill>
+              <a:latin typeface="+mn-lt"/>
+            </a:endParaRPr>
+          </a:p>
+          <a:p>
+            <a:pPr lvl="0" eaLnBrk="1" hangingPunct="1">
+              <a:spcAft>
+                <a:spcPts val="1200"/>
+              </a:spcAft>
+              <a:defRPr/>
+            </a:pPr>
+            <a:endParaRPr lang="en-US" sz="2400" dirty="0">
+              <a:solidFill>
+                <a:prstClr val="black"/>
+              </a:solidFill>
+              <a:latin typeface="+mn-lt"/>
+            </a:endParaRPr>
+          </a:p>
+          <a:p>
+            <a:pPr lvl="0" eaLnBrk="1" hangingPunct="1">
+              <a:spcAft>
+                <a:spcPts val="1200"/>
+              </a:spcAft>
+              <a:defRPr/>
+            </a:pPr>
+            <a:endParaRPr lang="en-US" sz="2400" dirty="0">
+              <a:solidFill>
+                <a:prstClr val="black"/>
+              </a:solidFill>
+              <a:latin typeface="+mn-lt"/>
+            </a:endParaRPr>
+          </a:p>
         </p:txBody>
       </p:sp>
+      <p:pic>
+        <p:nvPicPr>
+          <p:cNvPr id="9" name="Picture 8">
+            <a:extLst>
+              <a:ext uri="{FF2B5EF4-FFF2-40B4-BE49-F238E27FC236}">
+                <a16:creationId xmlns:a16="http://schemas.microsoft.com/office/drawing/2014/main" id="{DB10EE05-73B9-9477-F053-464A932A9DC3}"/>
+              </a:ext>
+            </a:extLst>
+          </p:cNvPr>
+          <p:cNvPicPr>
+            <a:picLocks noChangeAspect="1"/>
+          </p:cNvPicPr>
+          <p:nvPr/>
+        </p:nvPicPr>
+        <p:blipFill>
+          <a:blip r:embed="rId12"/>
+          <a:stretch>
+            <a:fillRect/>
+          </a:stretch>
+        </p:blipFill>
+        <p:spPr>
+          <a:xfrm>
+            <a:off x="15079208" y="7583827"/>
+            <a:ext cx="5377834" cy="4277689"/>
+          </a:xfrm>
+          <a:prstGeom prst="rect">
+            <a:avLst/>
+          </a:prstGeom>
+        </p:spPr>
+      </p:pic>
+      <p:pic>
+        <p:nvPicPr>
+          <p:cNvPr id="7" name="Picture 6">
+            <a:extLst>
+              <a:ext uri="{FF2B5EF4-FFF2-40B4-BE49-F238E27FC236}">
+                <a16:creationId xmlns:a16="http://schemas.microsoft.com/office/drawing/2014/main" id="{F20AF61B-B1F5-5EA9-D336-F730C1D07EA5}"/>
+              </a:ext>
+            </a:extLst>
+          </p:cNvPr>
+          <p:cNvPicPr>
+            <a:picLocks noChangeAspect="1"/>
+          </p:cNvPicPr>
+          <p:nvPr/>
+        </p:nvPicPr>
+        <p:blipFill>
+          <a:blip r:embed="rId13"/>
+          <a:stretch>
+            <a:fillRect/>
+          </a:stretch>
+        </p:blipFill>
+        <p:spPr>
+          <a:xfrm>
+            <a:off x="14428926" y="3128406"/>
+            <a:ext cx="6651006" cy="2217002"/>
+          </a:xfrm>
+          <a:prstGeom prst="rect">
+            <a:avLst/>
+          </a:prstGeom>
+        </p:spPr>
+      </p:pic>
+      <p:pic>
+        <p:nvPicPr>
+          <p:cNvPr id="10" name="Picture 9">
+            <a:extLst>
+              <a:ext uri="{FF2B5EF4-FFF2-40B4-BE49-F238E27FC236}">
+                <a16:creationId xmlns:a16="http://schemas.microsoft.com/office/drawing/2014/main" id="{1D139D78-8551-F3C2-D178-D0B301B4C7F4}"/>
+              </a:ext>
+            </a:extLst>
+          </p:cNvPr>
+          <p:cNvPicPr>
+            <a:picLocks noChangeAspect="1"/>
+          </p:cNvPicPr>
+          <p:nvPr/>
+        </p:nvPicPr>
+        <p:blipFill>
+          <a:blip r:embed="rId14"/>
+          <a:stretch>
+            <a:fillRect/>
+          </a:stretch>
+        </p:blipFill>
+        <p:spPr>
+          <a:xfrm>
+            <a:off x="14441619" y="14660370"/>
+            <a:ext cx="6651006" cy="2674604"/>
+          </a:xfrm>
+          <a:prstGeom prst="rect">
+            <a:avLst/>
+          </a:prstGeom>
+        </p:spPr>
+      </p:pic>
     </p:spTree>
     <p:extLst>
       <p:ext uri="{BB962C8B-B14F-4D97-AF65-F5344CB8AC3E}">

</xml_diff>

<commit_message>
Add conclusion section summarizing findings and improvements in feature engineering
</commit_message>
<xml_diff>
--- a/bench inspection poster/Presentation2.pptx
+++ b/bench inspection poster/Presentation2.pptx
@@ -3462,12 +3462,7 @@
           <a:bodyPr rtlCol="0" anchor="ctr"/>
           <a:lstStyle/>
           <a:p>
-            <a:pPr algn="ctr"/>
-            <a:r>
-              <a:rPr lang="en-US" altLang="zh-CN" sz="4096" dirty="0"/>
-              <a:t>`</a:t>
-            </a:r>
-            <a:endParaRPr lang="en-CN" sz="4096" dirty="0"/>
+            <a:endParaRPr lang="en-US" sz="1200" dirty="0"/>
           </a:p>
         </p:txBody>
       </p:sp>
@@ -3726,10 +3721,10 @@
         </p:nvGrpSpPr>
         <p:grpSpPr>
           <a:xfrm>
-            <a:off x="7348061" y="17790950"/>
-            <a:ext cx="6724016" cy="11420150"/>
+            <a:off x="7348061" y="18526054"/>
+            <a:ext cx="6724016" cy="10527597"/>
             <a:chOff x="440418" y="5694830"/>
-            <a:chExt cx="9183262" cy="11420150"/>
+            <a:chExt cx="9183262" cy="10527597"/>
           </a:xfrm>
         </p:grpSpPr>
         <p:sp>
@@ -3749,7 +3744,7 @@
           <p:spPr bwMode="auto">
             <a:xfrm>
               <a:off x="440418" y="6668631"/>
-              <a:ext cx="9183262" cy="10446349"/>
+              <a:ext cx="9183262" cy="9553796"/>
             </a:xfrm>
             <a:prstGeom prst="rect">
               <a:avLst/>
@@ -3947,6 +3942,22 @@
                 <a:tabLst/>
                 <a:defRPr/>
               </a:pPr>
+              <a:br>
+                <a:rPr kumimoji="0" lang="en-US" sz="2400" b="0" i="0" u="none" strike="noStrike" kern="1200" cap="none" spc="0" normalizeH="0" baseline="0" noProof="0" dirty="0">
+                  <a:ln>
+                    <a:noFill/>
+                  </a:ln>
+                  <a:solidFill>
+                    <a:prstClr val="black"/>
+                  </a:solidFill>
+                  <a:effectLst/>
+                  <a:uLnTx/>
+                  <a:uFillTx/>
+                  <a:latin typeface="+mn-lt"/>
+                  <a:ea typeface="+mn-ea"/>
+                  <a:cs typeface="+mn-cs"/>
+                </a:rPr>
+              </a:br>
               <a:endParaRPr kumimoji="0" lang="en-US" sz="2400" b="0" i="0" u="none" strike="noStrike" kern="1200" cap="none" spc="0" normalizeH="0" baseline="0" noProof="0" dirty="0">
                 <a:ln>
                   <a:noFill/>
@@ -4139,42 +4150,6 @@
                 </a:rPr>
                 <a:t> breakthrough is in phase 3. Feature engineering dramatically improved Config C for MLP model from 0.33 to 0.80 and Ridge model from -0.17 to 0.80.</a:t>
               </a:r>
-              <a:br>
-                <a:rPr lang="en-US" sz="2400" dirty="0">
-                  <a:solidFill>
-                    <a:prstClr val="black"/>
-                  </a:solidFill>
-                  <a:latin typeface="+mn-lt"/>
-                </a:rPr>
-              </a:br>
-              <a:br>
-                <a:rPr lang="en-US" sz="2400" dirty="0">
-                  <a:solidFill>
-                    <a:prstClr val="black"/>
-                  </a:solidFill>
-                  <a:latin typeface="+mn-lt"/>
-                </a:rPr>
-              </a:br>
-              <a:endParaRPr lang="en-US" sz="2400" dirty="0">
-                <a:solidFill>
-                  <a:prstClr val="black"/>
-                </a:solidFill>
-                <a:latin typeface="+mn-lt"/>
-              </a:endParaRPr>
-            </a:p>
-            <a:p>
-              <a:pPr lvl="0" eaLnBrk="1" hangingPunct="1">
-                <a:spcAft>
-                  <a:spcPts val="1200"/>
-                </a:spcAft>
-                <a:defRPr/>
-              </a:pPr>
-              <a:endParaRPr lang="en-US" sz="2400" dirty="0">
-                <a:solidFill>
-                  <a:prstClr val="black"/>
-                </a:solidFill>
-                <a:latin typeface="+mn-lt"/>
-              </a:endParaRPr>
             </a:p>
           </p:txBody>
         </p:sp>
@@ -4657,10 +4632,10 @@
         </p:nvGrpSpPr>
         <p:grpSpPr>
           <a:xfrm>
-            <a:off x="14392421" y="17826413"/>
-            <a:ext cx="6748634" cy="1817521"/>
+            <a:off x="14392421" y="20503684"/>
+            <a:ext cx="6748634" cy="8280829"/>
             <a:chOff x="440418" y="5694830"/>
-            <a:chExt cx="9183262" cy="1817521"/>
+            <a:chExt cx="9183262" cy="8280829"/>
           </a:xfrm>
         </p:grpSpPr>
         <p:sp>
@@ -4680,7 +4655,7 @@
           <p:spPr bwMode="auto">
             <a:xfrm>
               <a:off x="440418" y="6668631"/>
-              <a:ext cx="9183262" cy="843720"/>
+              <a:ext cx="9183262" cy="7307028"/>
             </a:xfrm>
             <a:prstGeom prst="rect">
               <a:avLst/>
@@ -4800,8 +4775,90 @@
               </a:lvl9pPr>
             </a:lstStyle>
             <a:p>
-              <a:pPr eaLnBrk="1" hangingPunct="1"/>
-              <a:endParaRPr lang="en-US" sz="3200" dirty="0">
+              <a:pPr eaLnBrk="1" hangingPunct="1">
+                <a:spcAft>
+                  <a:spcPts val="1200"/>
+                </a:spcAft>
+                <a:defRPr/>
+              </a:pPr>
+              <a:r>
+                <a:rPr lang="en-US" sz="2400" dirty="0">
+                  <a:solidFill>
+                    <a:prstClr val="black"/>
+                  </a:solidFill>
+                  <a:latin typeface="+mn-lt"/>
+                </a:rPr>
+                <a:t>This study demonstrates that domain-knowledge-driven feature engineering is the decisive factor in enabling accurate machine learning prediction of H₂O₂ yield from nanosecond pulsed CO₂ bubble plasma.</a:t>
+              </a:r>
+            </a:p>
+            <a:p>
+              <a:pPr eaLnBrk="1" hangingPunct="1">
+                <a:spcAft>
+                  <a:spcPts val="1200"/>
+                </a:spcAft>
+                <a:defRPr/>
+              </a:pPr>
+              <a:r>
+                <a:rPr lang="en-US" sz="2400" dirty="0">
+                  <a:solidFill>
+                    <a:prstClr val="black"/>
+                  </a:solidFill>
+                  <a:latin typeface="+mn-lt"/>
+                </a:rPr>
+                <a:t>Replacing PCA with physically meaningful OES features dramatically improved model performance (Ridge Config C R² from −0.17 to 0.80). </a:t>
+              </a:r>
+            </a:p>
+            <a:p>
+              <a:pPr eaLnBrk="1" hangingPunct="1">
+                <a:spcAft>
+                  <a:spcPts val="1200"/>
+                </a:spcAft>
+                <a:defRPr/>
+              </a:pPr>
+              <a:r>
+                <a:rPr lang="en-US" sz="2400" dirty="0">
+                  <a:solidFill>
+                    <a:prstClr val="black"/>
+                  </a:solidFill>
+                  <a:latin typeface="+mn-lt"/>
+                </a:rPr>
+                <a:t>Interpretability analysis identified CO₂ flow rate and its OES band integral as the most influential predictors. Permutation testing confirmed genuine predictive power (p &lt; 0.00005), and a parsimonious Ridge model with just 3 OES ratios and discharge parameters matched complex neural networks</a:t>
+              </a:r>
+              <a:r>
+                <a:rPr lang="en-US" altLang="zh-CN" sz="2400" dirty="0">
+                  <a:solidFill>
+                    <a:prstClr val="black"/>
+                  </a:solidFill>
+                  <a:latin typeface="+mn-lt"/>
+                </a:rPr>
+                <a:t>,</a:t>
+              </a:r>
+              <a:r>
+                <a:rPr lang="zh-CN" altLang="en-US" sz="2400" dirty="0">
+                  <a:solidFill>
+                    <a:prstClr val="black"/>
+                  </a:solidFill>
+                  <a:latin typeface="+mn-lt"/>
+                </a:rPr>
+                <a:t> </a:t>
+              </a:r>
+              <a:r>
+                <a:rPr lang="en-US" sz="2400" dirty="0">
+                  <a:solidFill>
+                    <a:prstClr val="black"/>
+                  </a:solidFill>
+                  <a:latin typeface="+mn-lt"/>
+                </a:rPr>
+                <a:t> demonstrating that interpretable linear models suffice when features are well-engineered</a:t>
+              </a:r>
+              <a:r>
+                <a:rPr lang="en-US" sz="2400" dirty="0"/>
+                <a:t>.</a:t>
+              </a:r>
+              <a:endParaRPr lang="en-US" sz="2400" dirty="0">
+                <a:solidFill>
+                  <a:prstClr val="black"/>
+                </a:solidFill>
                 <a:latin typeface="+mn-lt"/>
               </a:endParaRPr>
             </a:p>
@@ -5236,12 +5293,10 @@
               </a:endParaRPr>
             </a:p>
             <a:p>
-              <a:pPr marL="342900" indent="-342900" eaLnBrk="1" hangingPunct="1">
+              <a:pPr eaLnBrk="1" hangingPunct="1">
                 <a:spcAft>
                   <a:spcPts val="600"/>
                 </a:spcAft>
-                <a:buFont typeface="Arial" panose="020B0604020202020204" pitchFamily="34" charset="0"/>
-                <a:buChar char="•"/>
               </a:pPr>
               <a:endParaRPr lang="en-US" sz="2400" dirty="0">
                 <a:latin typeface="+mn-lt"/>
@@ -5385,7 +5440,7 @@
         </p:blipFill>
         <p:spPr>
           <a:xfrm>
-            <a:off x="1270808" y="24851344"/>
+            <a:off x="1270808" y="24811003"/>
             <a:ext cx="4609730" cy="1204520"/>
           </a:xfrm>
           <a:prstGeom prst="rect">
@@ -5410,7 +5465,7 @@
         <p:spPr bwMode="auto">
           <a:xfrm>
             <a:off x="7348061" y="3091330"/>
-            <a:ext cx="6724016" cy="14539777"/>
+            <a:ext cx="6724016" cy="15278441"/>
           </a:xfrm>
           <a:prstGeom prst="rect">
             <a:avLst/>
@@ -5780,6 +5835,14 @@
               </a:rPr>
               <a:t>.</a:t>
             </a:r>
+            <a:br>
+              <a:rPr lang="en-US" sz="2400" dirty="0">
+                <a:latin typeface="+mn-lt"/>
+              </a:rPr>
+            </a:br>
+            <a:endParaRPr lang="en-US" sz="2400" dirty="0">
+              <a:latin typeface="+mn-lt"/>
+            </a:endParaRPr>
           </a:p>
           <a:p>
             <a:endParaRPr lang="en-US" sz="2400" b="1" dirty="0">
@@ -5901,6 +5964,11 @@
           </a:p>
           <a:p>
             <a:pPr eaLnBrk="1" hangingPunct="1"/>
+            <a:br>
+              <a:rPr lang="en-US" sz="2400" dirty="0">
+                <a:latin typeface="+mn-lt"/>
+              </a:rPr>
+            </a:br>
             <a:endParaRPr lang="en-US" sz="2400" dirty="0">
               <a:latin typeface="+mn-lt"/>
             </a:endParaRPr>
@@ -5977,7 +6045,7 @@
         </p:blipFill>
         <p:spPr>
           <a:xfrm>
-            <a:off x="7779220" y="12234049"/>
+            <a:off x="7779220" y="12624012"/>
             <a:ext cx="5827312" cy="1789890"/>
           </a:xfrm>
           <a:prstGeom prst="rect">
@@ -6098,7 +6166,7 @@
         </p:blipFill>
         <p:spPr>
           <a:xfrm>
-            <a:off x="8443475" y="20464444"/>
+            <a:off x="8443475" y="21109900"/>
             <a:ext cx="4498802" cy="2249402"/>
           </a:xfrm>
           <a:prstGeom prst="rect">
@@ -6123,7 +6191,7 @@
         <p:spPr bwMode="auto">
           <a:xfrm>
             <a:off x="14392421" y="3093708"/>
-            <a:ext cx="6724016" cy="14508999"/>
+            <a:ext cx="6724016" cy="17248211"/>
           </a:xfrm>
           <a:prstGeom prst="rect">
             <a:avLst/>
@@ -6376,7 +6444,7 @@
               <a:tabLst/>
               <a:defRPr/>
             </a:pPr>
-            <a:r>
+            <a:br>
               <a:rPr kumimoji="0" lang="en-US" sz="2400" b="0" i="0" u="none" strike="noStrike" kern="1200" cap="none" spc="0" normalizeH="0" baseline="0" noProof="0" dirty="0">
                 <a:ln>
                   <a:noFill/>
@@ -6391,6 +6459,22 @@
                 <a:ea typeface="+mn-ea"/>
                 <a:cs typeface="+mn-cs"/>
               </a:rPr>
+            </a:br>
+            <a:r>
+              <a:rPr kumimoji="0" lang="en-US" sz="2400" b="0" i="0" u="none" strike="noStrike" kern="1200" cap="none" spc="0" normalizeH="0" baseline="0" noProof="0" dirty="0">
+                <a:ln>
+                  <a:noFill/>
+                </a:ln>
+                <a:solidFill>
+                  <a:prstClr val="black"/>
+                </a:solidFill>
+                <a:effectLst/>
+                <a:uLnTx/>
+                <a:uFillTx/>
+                <a:latin typeface="+mn-lt"/>
+                <a:ea typeface="+mn-ea"/>
+                <a:cs typeface="+mn-cs"/>
+              </a:rPr>
               <a:t>Phase 4 discovers that CO</a:t>
             </a:r>
             <a:r>
@@ -6521,6 +6605,39 @@
               </a:rPr>
               <a:t>Ridge config C and MLP config C. </a:t>
             </a:r>
+          </a:p>
+          <a:p>
+            <a:pPr marL="0" marR="0" lvl="0" indent="0" defTabSz="457200" rtl="0" eaLnBrk="1" fontAlgn="auto" latinLnBrk="0" hangingPunct="1">
+              <a:lnSpc>
+                <a:spcPct val="100000"/>
+              </a:lnSpc>
+              <a:spcBef>
+                <a:spcPts val="0"/>
+              </a:spcBef>
+              <a:spcAft>
+                <a:spcPts val="1200"/>
+              </a:spcAft>
+              <a:buClrTx/>
+              <a:buSzTx/>
+              <a:buFontTx/>
+              <a:buNone/>
+              <a:tabLst/>
+              <a:defRPr/>
+            </a:pPr>
+            <a:endParaRPr kumimoji="0" lang="en-US" sz="2400" b="0" i="0" u="none" strike="noStrike" kern="1200" cap="none" spc="0" normalizeH="0" noProof="0" dirty="0">
+              <a:ln>
+                <a:noFill/>
+              </a:ln>
+              <a:solidFill>
+                <a:prstClr val="black"/>
+              </a:solidFill>
+              <a:effectLst/>
+              <a:uLnTx/>
+              <a:uFillTx/>
+              <a:latin typeface="+mn-lt"/>
+              <a:ea typeface="+mn-ea"/>
+              <a:cs typeface="+mn-cs"/>
+            </a:endParaRPr>
           </a:p>
           <a:p>
             <a:pPr marL="0" marR="0" lvl="0" indent="0" defTabSz="457200" rtl="0" eaLnBrk="1" fontAlgn="auto" latinLnBrk="0" hangingPunct="1">
@@ -6748,6 +6865,81 @@
             </a:endParaRPr>
           </a:p>
           <a:p>
+            <a:pPr marL="0" marR="0" lvl="0" indent="0" defTabSz="457200" rtl="0" eaLnBrk="1" fontAlgn="auto" latinLnBrk="0" hangingPunct="1">
+              <a:lnSpc>
+                <a:spcPct val="100000"/>
+              </a:lnSpc>
+              <a:spcBef>
+                <a:spcPts val="0"/>
+              </a:spcBef>
+              <a:spcAft>
+                <a:spcPts val="1200"/>
+              </a:spcAft>
+              <a:buClrTx/>
+              <a:buSzTx/>
+              <a:buFontTx/>
+              <a:buNone/>
+              <a:tabLst/>
+              <a:defRPr/>
+            </a:pPr>
+            <a:endParaRPr lang="en-US" sz="2400" dirty="0">
+              <a:solidFill>
+                <a:prstClr val="black"/>
+              </a:solidFill>
+              <a:latin typeface="+mn-lt"/>
+            </a:endParaRPr>
+          </a:p>
+          <a:p>
+            <a:pPr marL="0" marR="0" lvl="0" indent="0" defTabSz="457200" rtl="0" eaLnBrk="1" fontAlgn="auto" latinLnBrk="0" hangingPunct="1">
+              <a:lnSpc>
+                <a:spcPct val="100000"/>
+              </a:lnSpc>
+              <a:spcBef>
+                <a:spcPts val="0"/>
+              </a:spcBef>
+              <a:spcAft>
+                <a:spcPts val="1200"/>
+              </a:spcAft>
+              <a:buClrTx/>
+              <a:buSzTx/>
+              <a:buFontTx/>
+              <a:buNone/>
+              <a:tabLst/>
+              <a:defRPr/>
+            </a:pPr>
+            <a:endParaRPr lang="en-US" sz="2400" dirty="0">
+              <a:solidFill>
+                <a:prstClr val="black"/>
+              </a:solidFill>
+              <a:latin typeface="+mn-lt"/>
+            </a:endParaRPr>
+          </a:p>
+          <a:p>
+            <a:pPr marL="0" marR="0" lvl="0" indent="0" defTabSz="457200" rtl="0" eaLnBrk="1" fontAlgn="auto" latinLnBrk="0" hangingPunct="1">
+              <a:lnSpc>
+                <a:spcPct val="100000"/>
+              </a:lnSpc>
+              <a:spcBef>
+                <a:spcPts val="0"/>
+              </a:spcBef>
+              <a:spcAft>
+                <a:spcPts val="1200"/>
+              </a:spcAft>
+              <a:buClrTx/>
+              <a:buSzTx/>
+              <a:buFontTx/>
+              <a:buNone/>
+              <a:tabLst/>
+              <a:defRPr/>
+            </a:pPr>
+            <a:endParaRPr lang="en-US" sz="2400" dirty="0">
+              <a:solidFill>
+                <a:prstClr val="black"/>
+              </a:solidFill>
+              <a:latin typeface="+mn-lt"/>
+            </a:endParaRPr>
+          </a:p>
+          <a:p>
             <a:pPr lvl="0" eaLnBrk="1" hangingPunct="1">
               <a:spcAft>
                 <a:spcPts val="1200"/>
@@ -6798,6 +6990,28 @@
               </a:rPr>
               <a:t>After eliminating features one by one reversely, the best model and input is found to be Ridge with 3 OES ratios + discharge parameter.</a:t>
             </a:r>
+            <a:br>
+              <a:rPr lang="en-US" sz="2400" dirty="0">
+                <a:solidFill>
+                  <a:prstClr val="black"/>
+                </a:solidFill>
+                <a:latin typeface="+mn-lt"/>
+              </a:rPr>
+            </a:br>
+            <a:br>
+              <a:rPr lang="en-US" sz="2400" dirty="0">
+                <a:solidFill>
+                  <a:prstClr val="black"/>
+                </a:solidFill>
+                <a:latin typeface="+mn-lt"/>
+              </a:rPr>
+            </a:br>
+            <a:endParaRPr lang="en-US" sz="2400" dirty="0">
+              <a:solidFill>
+                <a:prstClr val="black"/>
+              </a:solidFill>
+              <a:latin typeface="+mn-lt"/>
+            </a:endParaRPr>
           </a:p>
           <a:p>
             <a:pPr lvl="0" eaLnBrk="1" hangingPunct="1">
@@ -6820,48 +7034,30 @@
               </a:spcAft>
               <a:defRPr/>
             </a:pPr>
-            <a:endParaRPr lang="en-US" sz="2400" dirty="0">
-              <a:solidFill>
-                <a:prstClr val="black"/>
-              </a:solidFill>
-              <a:latin typeface="+mn-lt"/>
-            </a:endParaRPr>
-          </a:p>
-          <a:p>
-            <a:pPr lvl="0" eaLnBrk="1" hangingPunct="1">
-              <a:spcAft>
-                <a:spcPts val="1200"/>
-              </a:spcAft>
-              <a:defRPr/>
-            </a:pPr>
-            <a:endParaRPr lang="en-US" sz="2400" dirty="0">
-              <a:solidFill>
-                <a:prstClr val="black"/>
-              </a:solidFill>
-              <a:latin typeface="+mn-lt"/>
-            </a:endParaRPr>
-          </a:p>
-          <a:p>
-            <a:pPr lvl="0" eaLnBrk="1" hangingPunct="1">
-              <a:spcAft>
-                <a:spcPts val="1200"/>
-              </a:spcAft>
-              <a:defRPr/>
-            </a:pPr>
-            <a:endParaRPr lang="en-US" sz="2400" dirty="0">
-              <a:solidFill>
-                <a:prstClr val="black"/>
-              </a:solidFill>
-              <a:latin typeface="+mn-lt"/>
-            </a:endParaRPr>
-          </a:p>
-          <a:p>
-            <a:pPr lvl="0" eaLnBrk="1" hangingPunct="1">
-              <a:spcAft>
-                <a:spcPts val="1200"/>
-              </a:spcAft>
-              <a:defRPr/>
-            </a:pPr>
+            <a:br>
+              <a:rPr lang="en-US" sz="2400" dirty="0">
+                <a:solidFill>
+                  <a:prstClr val="black"/>
+                </a:solidFill>
+                <a:latin typeface="+mn-lt"/>
+              </a:rPr>
+            </a:br>
+            <a:br>
+              <a:rPr lang="en-US" sz="2400" dirty="0">
+                <a:solidFill>
+                  <a:prstClr val="black"/>
+                </a:solidFill>
+                <a:latin typeface="+mn-lt"/>
+              </a:rPr>
+            </a:br>
+            <a:br>
+              <a:rPr lang="en-US" sz="2400" dirty="0">
+                <a:solidFill>
+                  <a:prstClr val="black"/>
+                </a:solidFill>
+                <a:latin typeface="+mn-lt"/>
+              </a:rPr>
+            </a:br>
             <a:endParaRPr lang="en-US" sz="2400" dirty="0">
               <a:solidFill>
                 <a:prstClr val="black"/>
@@ -6893,7 +7089,7 @@
         </p:blipFill>
         <p:spPr>
           <a:xfrm>
-            <a:off x="15079208" y="7583827"/>
+            <a:off x="15079208" y="9977625"/>
             <a:ext cx="5377834" cy="4277689"/>
           </a:xfrm>
           <a:prstGeom prst="rect">
@@ -6953,7 +7149,7 @@
         </p:blipFill>
         <p:spPr>
           <a:xfrm>
-            <a:off x="14441619" y="14660370"/>
+            <a:off x="14441619" y="17138685"/>
             <a:ext cx="6651006" cy="2674604"/>
           </a:xfrm>
           <a:prstGeom prst="rect">
@@ -6961,6 +7157,774 @@
           </a:prstGeom>
         </p:spPr>
       </p:pic>
+      <p:pic>
+        <p:nvPicPr>
+          <p:cNvPr id="14" name="Picture 13">
+            <a:extLst>
+              <a:ext uri="{FF2B5EF4-FFF2-40B4-BE49-F238E27FC236}">
+                <a16:creationId xmlns:a16="http://schemas.microsoft.com/office/drawing/2014/main" id="{29D304C2-12F1-7F9C-EF8D-5BFEDECF916A}"/>
+              </a:ext>
+            </a:extLst>
+          </p:cNvPr>
+          <p:cNvPicPr>
+            <a:picLocks noChangeAspect="1"/>
+          </p:cNvPicPr>
+          <p:nvPr/>
+        </p:nvPicPr>
+        <p:blipFill>
+          <a:blip r:embed="rId15"/>
+          <a:stretch>
+            <a:fillRect/>
+          </a:stretch>
+        </p:blipFill>
+        <p:spPr>
+          <a:xfrm>
+            <a:off x="14503474" y="7911202"/>
+            <a:ext cx="6501909" cy="1992520"/>
+          </a:xfrm>
+          <a:prstGeom prst="rect">
+            <a:avLst/>
+          </a:prstGeom>
+        </p:spPr>
+      </p:pic>
+      <p:sp>
+        <p:nvSpPr>
+          <p:cNvPr id="15" name="TextBox 14">
+            <a:extLst>
+              <a:ext uri="{FF2B5EF4-FFF2-40B4-BE49-F238E27FC236}">
+                <a16:creationId xmlns:a16="http://schemas.microsoft.com/office/drawing/2014/main" id="{6C82D9C5-65D3-9AC4-6203-799480B740C8}"/>
+              </a:ext>
+            </a:extLst>
+          </p:cNvPr>
+          <p:cNvSpPr txBox="1"/>
+          <p:nvPr/>
+        </p:nvSpPr>
+        <p:spPr>
+          <a:xfrm>
+            <a:off x="809819" y="9317279"/>
+            <a:ext cx="5531707" cy="338554"/>
+          </a:xfrm>
+          <a:prstGeom prst="rect">
+            <a:avLst/>
+          </a:prstGeom>
+          <a:noFill/>
+        </p:spPr>
+        <p:txBody>
+          <a:bodyPr wrap="none" rtlCol="0">
+            <a:spAutoFit/>
+          </a:bodyPr>
+          <a:lstStyle/>
+          <a:p>
+            <a:pPr algn="ctr"/>
+            <a:r>
+              <a:rPr lang="en-CN" sz="1600" dirty="0"/>
+              <a:t>Figure 1: Nanosecond Pulsed CO</a:t>
+            </a:r>
+            <a:r>
+              <a:rPr lang="en-CN" sz="1600" baseline="-25000" dirty="0"/>
+              <a:t>2 </a:t>
+            </a:r>
+            <a:r>
+              <a:rPr lang="en-CN" sz="1600" dirty="0"/>
+              <a:t>Bubble Discharge Setting</a:t>
+            </a:r>
+            <a:r>
+              <a:rPr lang="en-CN" sz="1600" baseline="30000" dirty="0"/>
+              <a:t>[1]</a:t>
+            </a:r>
+            <a:endParaRPr lang="en-CN" sz="1600" dirty="0"/>
+          </a:p>
+        </p:txBody>
+      </p:sp>
+      <p:sp>
+        <p:nvSpPr>
+          <p:cNvPr id="16" name="TextBox 15">
+            <a:extLst>
+              <a:ext uri="{FF2B5EF4-FFF2-40B4-BE49-F238E27FC236}">
+                <a16:creationId xmlns:a16="http://schemas.microsoft.com/office/drawing/2014/main" id="{429A5C58-3C04-DE1C-909E-BFFB4C0FA171}"/>
+              </a:ext>
+            </a:extLst>
+          </p:cNvPr>
+          <p:cNvSpPr txBox="1"/>
+          <p:nvPr/>
+        </p:nvSpPr>
+        <p:spPr>
+          <a:xfrm>
+            <a:off x="985963" y="17463911"/>
+            <a:ext cx="5058694" cy="338554"/>
+          </a:xfrm>
+          <a:prstGeom prst="rect">
+            <a:avLst/>
+          </a:prstGeom>
+          <a:noFill/>
+        </p:spPr>
+        <p:txBody>
+          <a:bodyPr wrap="none" rtlCol="0">
+            <a:spAutoFit/>
+          </a:bodyPr>
+          <a:lstStyle/>
+          <a:p>
+            <a:pPr algn="ctr"/>
+            <a:r>
+              <a:rPr lang="en-CN" sz="1600" dirty="0"/>
+              <a:t>Figure 2: </a:t>
+            </a:r>
+            <a:r>
+              <a:rPr lang="en-US" altLang="zh-CN" sz="1600" dirty="0"/>
+              <a:t>20</a:t>
+            </a:r>
+            <a:r>
+              <a:rPr lang="zh-CN" altLang="en-US" sz="1600" dirty="0"/>
+              <a:t> </a:t>
+            </a:r>
+            <a:r>
+              <a:rPr lang="en-US" altLang="zh-CN" sz="1600" dirty="0"/>
+              <a:t>Optical Emission Spectrum of 701 Samples</a:t>
+            </a:r>
+            <a:endParaRPr lang="en-CN" sz="1600" dirty="0"/>
+          </a:p>
+        </p:txBody>
+      </p:sp>
+      <p:sp>
+        <p:nvSpPr>
+          <p:cNvPr id="17" name="TextBox 16">
+            <a:extLst>
+              <a:ext uri="{FF2B5EF4-FFF2-40B4-BE49-F238E27FC236}">
+                <a16:creationId xmlns:a16="http://schemas.microsoft.com/office/drawing/2014/main" id="{A8F31F1A-E19B-902A-3F5F-9EABE38ACD75}"/>
+              </a:ext>
+            </a:extLst>
+          </p:cNvPr>
+          <p:cNvSpPr txBox="1"/>
+          <p:nvPr/>
+        </p:nvSpPr>
+        <p:spPr>
+          <a:xfrm>
+            <a:off x="1348680" y="25870364"/>
+            <a:ext cx="4511043" cy="338554"/>
+          </a:xfrm>
+          <a:prstGeom prst="rect">
+            <a:avLst/>
+          </a:prstGeom>
+          <a:noFill/>
+        </p:spPr>
+        <p:txBody>
+          <a:bodyPr wrap="none" rtlCol="0">
+            <a:spAutoFit/>
+          </a:bodyPr>
+          <a:lstStyle/>
+          <a:p>
+            <a:pPr algn="ctr"/>
+            <a:r>
+              <a:rPr lang="en-CN" sz="1600" dirty="0"/>
+              <a:t>Table 1: Configuration of Data Input Construction</a:t>
+            </a:r>
+          </a:p>
+        </p:txBody>
+      </p:sp>
+      <p:sp>
+        <p:nvSpPr>
+          <p:cNvPr id="18" name="TextBox 17">
+            <a:extLst>
+              <a:ext uri="{FF2B5EF4-FFF2-40B4-BE49-F238E27FC236}">
+                <a16:creationId xmlns:a16="http://schemas.microsoft.com/office/drawing/2014/main" id="{AE00C9D4-6149-4D7F-1896-B22C8CEBE77C}"/>
+              </a:ext>
+            </a:extLst>
+          </p:cNvPr>
+          <p:cNvSpPr txBox="1"/>
+          <p:nvPr/>
+        </p:nvSpPr>
+        <p:spPr>
+          <a:xfrm>
+            <a:off x="8755696" y="10447971"/>
+            <a:ext cx="3908762" cy="338554"/>
+          </a:xfrm>
+          <a:prstGeom prst="rect">
+            <a:avLst/>
+          </a:prstGeom>
+          <a:noFill/>
+        </p:spPr>
+        <p:txBody>
+          <a:bodyPr wrap="none" rtlCol="0">
+            <a:spAutoFit/>
+          </a:bodyPr>
+          <a:lstStyle/>
+          <a:p>
+            <a:pPr algn="ctr"/>
+            <a:r>
+              <a:rPr lang="en-CN" sz="1600" dirty="0"/>
+              <a:t>Table 2: Manually Selected OES Features</a:t>
+            </a:r>
+          </a:p>
+        </p:txBody>
+      </p:sp>
+      <p:sp>
+        <p:nvSpPr>
+          <p:cNvPr id="19" name="TextBox 18">
+            <a:extLst>
+              <a:ext uri="{FF2B5EF4-FFF2-40B4-BE49-F238E27FC236}">
+                <a16:creationId xmlns:a16="http://schemas.microsoft.com/office/drawing/2014/main" id="{AA1AFB4C-055F-DCA5-C69E-B157E6DDE4C3}"/>
+              </a:ext>
+            </a:extLst>
+          </p:cNvPr>
+          <p:cNvSpPr txBox="1"/>
+          <p:nvPr/>
+        </p:nvSpPr>
+        <p:spPr>
+          <a:xfrm>
+            <a:off x="8353952" y="14323108"/>
+            <a:ext cx="4712252" cy="338554"/>
+          </a:xfrm>
+          <a:prstGeom prst="rect">
+            <a:avLst/>
+          </a:prstGeom>
+          <a:noFill/>
+        </p:spPr>
+        <p:txBody>
+          <a:bodyPr wrap="none" rtlCol="0">
+            <a:spAutoFit/>
+          </a:bodyPr>
+          <a:lstStyle/>
+          <a:p>
+            <a:pPr algn="ctr"/>
+            <a:r>
+              <a:rPr lang="en-CN" sz="1600" dirty="0"/>
+              <a:t>Table 3: Methods for Evaluating Feature Importance</a:t>
+            </a:r>
+          </a:p>
+        </p:txBody>
+      </p:sp>
+      <p:sp>
+        <p:nvSpPr>
+          <p:cNvPr id="20" name="TextBox 19">
+            <a:extLst>
+              <a:ext uri="{FF2B5EF4-FFF2-40B4-BE49-F238E27FC236}">
+                <a16:creationId xmlns:a16="http://schemas.microsoft.com/office/drawing/2014/main" id="{DF2FCE69-A3B1-5EC0-1E19-8148B3C73CFF}"/>
+              </a:ext>
+            </a:extLst>
+          </p:cNvPr>
+          <p:cNvSpPr txBox="1"/>
+          <p:nvPr/>
+        </p:nvSpPr>
+        <p:spPr>
+          <a:xfrm>
+            <a:off x="8146777" y="23359302"/>
+            <a:ext cx="5126596" cy="338554"/>
+          </a:xfrm>
+          <a:prstGeom prst="rect">
+            <a:avLst/>
+          </a:prstGeom>
+          <a:noFill/>
+        </p:spPr>
+        <p:txBody>
+          <a:bodyPr wrap="none" rtlCol="0">
+            <a:spAutoFit/>
+          </a:bodyPr>
+          <a:lstStyle/>
+          <a:p>
+            <a:pPr algn="ctr"/>
+            <a:r>
+              <a:rPr lang="en-CN" sz="1600" dirty="0"/>
+              <a:t>Figure 3: Principle Components Analysis Variance Curve</a:t>
+            </a:r>
+          </a:p>
+        </p:txBody>
+      </p:sp>
+      <p:sp>
+        <p:nvSpPr>
+          <p:cNvPr id="21" name="TextBox 20">
+            <a:extLst>
+              <a:ext uri="{FF2B5EF4-FFF2-40B4-BE49-F238E27FC236}">
+                <a16:creationId xmlns:a16="http://schemas.microsoft.com/office/drawing/2014/main" id="{4AFAE915-8466-3B7C-9898-5969D0D28102}"/>
+              </a:ext>
+            </a:extLst>
+          </p:cNvPr>
+          <p:cNvSpPr txBox="1"/>
+          <p:nvPr/>
+        </p:nvSpPr>
+        <p:spPr>
+          <a:xfrm>
+            <a:off x="15843751" y="5331416"/>
+            <a:ext cx="3821367" cy="338554"/>
+          </a:xfrm>
+          <a:prstGeom prst="rect">
+            <a:avLst/>
+          </a:prstGeom>
+          <a:noFill/>
+        </p:spPr>
+        <p:txBody>
+          <a:bodyPr wrap="none" rtlCol="0">
+            <a:spAutoFit/>
+          </a:bodyPr>
+          <a:lstStyle/>
+          <a:p>
+            <a:pPr algn="ctr"/>
+            <a:r>
+              <a:rPr lang="en-CN" sz="1600" dirty="0"/>
+              <a:t>Figure 3: R</a:t>
+            </a:r>
+            <a:r>
+              <a:rPr lang="en-CN" sz="1600" baseline="30000" dirty="0"/>
+              <a:t>2</a:t>
+            </a:r>
+            <a:r>
+              <a:rPr lang="en-CN" sz="1600" dirty="0"/>
+              <a:t> Performance for Each Phase</a:t>
+            </a:r>
+          </a:p>
+        </p:txBody>
+      </p:sp>
+      <p:sp>
+        <p:nvSpPr>
+          <p:cNvPr id="22" name="TextBox 21">
+            <a:extLst>
+              <a:ext uri="{FF2B5EF4-FFF2-40B4-BE49-F238E27FC236}">
+                <a16:creationId xmlns:a16="http://schemas.microsoft.com/office/drawing/2014/main" id="{4E82511C-E8C0-CEB6-0D4E-4C31CABB9C41}"/>
+              </a:ext>
+            </a:extLst>
+          </p:cNvPr>
+          <p:cNvSpPr txBox="1"/>
+          <p:nvPr/>
+        </p:nvSpPr>
+        <p:spPr>
+          <a:xfrm>
+            <a:off x="15817430" y="9655833"/>
+            <a:ext cx="3874009" cy="338554"/>
+          </a:xfrm>
+          <a:prstGeom prst="rect">
+            <a:avLst/>
+          </a:prstGeom>
+          <a:noFill/>
+        </p:spPr>
+        <p:txBody>
+          <a:bodyPr wrap="none" rtlCol="0">
+            <a:spAutoFit/>
+          </a:bodyPr>
+          <a:lstStyle/>
+          <a:p>
+            <a:pPr algn="ctr"/>
+            <a:r>
+              <a:rPr lang="en-CN" sz="1600" dirty="0"/>
+              <a:t>Figure 4: Heatmap for Feature Importance</a:t>
+            </a:r>
+          </a:p>
+        </p:txBody>
+      </p:sp>
+      <p:sp>
+        <p:nvSpPr>
+          <p:cNvPr id="23" name="TextBox 22">
+            <a:extLst>
+              <a:ext uri="{FF2B5EF4-FFF2-40B4-BE49-F238E27FC236}">
+                <a16:creationId xmlns:a16="http://schemas.microsoft.com/office/drawing/2014/main" id="{9012CD83-CC5C-A908-4B0D-1DBB4FE52AFF}"/>
+              </a:ext>
+            </a:extLst>
+          </p:cNvPr>
+          <p:cNvSpPr txBox="1"/>
+          <p:nvPr/>
+        </p:nvSpPr>
+        <p:spPr>
+          <a:xfrm>
+            <a:off x="14806512" y="14225021"/>
+            <a:ext cx="5920468" cy="338554"/>
+          </a:xfrm>
+          <a:prstGeom prst="rect">
+            <a:avLst/>
+          </a:prstGeom>
+          <a:noFill/>
+        </p:spPr>
+        <p:txBody>
+          <a:bodyPr wrap="none" rtlCol="0">
+            <a:spAutoFit/>
+          </a:bodyPr>
+          <a:lstStyle/>
+          <a:p>
+            <a:pPr algn="ctr"/>
+            <a:r>
+              <a:rPr lang="en-CN" sz="1600" dirty="0"/>
+              <a:t>Figure 5: Bootstrap Confidence Interval Evaluation (Ridge vs MLP)</a:t>
+            </a:r>
+          </a:p>
+        </p:txBody>
+      </p:sp>
+      <p:sp>
+        <p:nvSpPr>
+          <p:cNvPr id="24" name="TextBox 23">
+            <a:extLst>
+              <a:ext uri="{FF2B5EF4-FFF2-40B4-BE49-F238E27FC236}">
+                <a16:creationId xmlns:a16="http://schemas.microsoft.com/office/drawing/2014/main" id="{D968035D-787C-A294-8ADF-54066E8D9367}"/>
+              </a:ext>
+            </a:extLst>
+          </p:cNvPr>
+          <p:cNvSpPr txBox="1"/>
+          <p:nvPr/>
+        </p:nvSpPr>
+        <p:spPr>
+          <a:xfrm>
+            <a:off x="15060025" y="19705277"/>
+            <a:ext cx="5388848" cy="338554"/>
+          </a:xfrm>
+          <a:prstGeom prst="rect">
+            <a:avLst/>
+          </a:prstGeom>
+          <a:noFill/>
+        </p:spPr>
+        <p:txBody>
+          <a:bodyPr wrap="none" rtlCol="0">
+            <a:spAutoFit/>
+          </a:bodyPr>
+          <a:lstStyle/>
+          <a:p>
+            <a:pPr algn="ctr"/>
+            <a:r>
+              <a:rPr lang="en-CN" sz="1600" dirty="0"/>
+              <a:t>Table 4: Best Performed Models and Configs across Phases</a:t>
+            </a:r>
+          </a:p>
+        </p:txBody>
+      </p:sp>
+      <p:sp>
+        <p:nvSpPr>
+          <p:cNvPr id="28" name="TextBox 27">
+            <a:extLst>
+              <a:ext uri="{FF2B5EF4-FFF2-40B4-BE49-F238E27FC236}">
+                <a16:creationId xmlns:a16="http://schemas.microsoft.com/office/drawing/2014/main" id="{9A45FC15-DCE8-AAF5-BAD8-3FB05D1F7553}"/>
+              </a:ext>
+            </a:extLst>
+          </p:cNvPr>
+          <p:cNvSpPr txBox="1"/>
+          <p:nvPr/>
+        </p:nvSpPr>
+        <p:spPr>
+          <a:xfrm>
+            <a:off x="291625" y="29466205"/>
+            <a:ext cx="18261859" cy="923330"/>
+          </a:xfrm>
+          <a:prstGeom prst="rect">
+            <a:avLst/>
+          </a:prstGeom>
+          <a:noFill/>
+        </p:spPr>
+        <p:txBody>
+          <a:bodyPr wrap="none" rtlCol="0">
+            <a:spAutoFit/>
+          </a:bodyPr>
+          <a:lstStyle/>
+          <a:p>
+            <a:pPr marL="0" marR="0" lvl="0" indent="0" algn="l" defTabSz="457200" rtl="0" eaLnBrk="1" fontAlgn="auto" latinLnBrk="0" hangingPunct="1">
+              <a:lnSpc>
+                <a:spcPct val="100000"/>
+              </a:lnSpc>
+              <a:spcBef>
+                <a:spcPts val="0"/>
+              </a:spcBef>
+              <a:spcAft>
+                <a:spcPts val="0"/>
+              </a:spcAft>
+              <a:buClrTx/>
+              <a:buSzTx/>
+              <a:buFontTx/>
+              <a:buNone/>
+              <a:tabLst/>
+              <a:defRPr/>
+            </a:pPr>
+            <a:r>
+              <a:rPr kumimoji="0" lang="en-US" sz="1200" b="0" i="0" u="none" strike="noStrike" kern="1200" cap="none" spc="0" normalizeH="0" baseline="0" noProof="0" dirty="0">
+                <a:ln>
+                  <a:noFill/>
+                </a:ln>
+                <a:solidFill>
+                  <a:prstClr val="white"/>
+                </a:solidFill>
+                <a:effectLst/>
+                <a:uLnTx/>
+                <a:uFillTx/>
+                <a:latin typeface="Aptos" panose="02110004020202020204"/>
+                <a:ea typeface="+mn-ea"/>
+                <a:cs typeface="+mn-cs"/>
+              </a:rPr>
+              <a:t>[1]	Y. Gao, R. Zhou, L. Hong, B. Chen, J. Sun, R. Zhou, and Z. Liu, "Efficient synthesis of CO and H₂O₂ via nanosecond pulsed CO₂ bubble discharge," </a:t>
+            </a:r>
+            <a:r>
+              <a:rPr kumimoji="0" lang="en-US" sz="1200" b="0" i="1" u="none" strike="noStrike" kern="1200" cap="none" spc="0" normalizeH="0" baseline="0" noProof="0" dirty="0">
+                <a:ln>
+                  <a:noFill/>
+                </a:ln>
+                <a:solidFill>
+                  <a:prstClr val="white"/>
+                </a:solidFill>
+                <a:effectLst/>
+                <a:uLnTx/>
+                <a:uFillTx/>
+                <a:latin typeface="Aptos" panose="02110004020202020204"/>
+                <a:ea typeface="+mn-ea"/>
+                <a:cs typeface="+mn-cs"/>
+              </a:rPr>
+              <a:t>J. Phys. D: Appl. Phys.</a:t>
+            </a:r>
+            <a:r>
+              <a:rPr kumimoji="0" lang="en-US" sz="1200" b="0" i="0" u="none" strike="noStrike" kern="1200" cap="none" spc="0" normalizeH="0" baseline="0" noProof="0" dirty="0">
+                <a:ln>
+                  <a:noFill/>
+                </a:ln>
+                <a:solidFill>
+                  <a:prstClr val="white"/>
+                </a:solidFill>
+                <a:effectLst/>
+                <a:uLnTx/>
+                <a:uFillTx/>
+                <a:latin typeface="Aptos" panose="02110004020202020204"/>
+                <a:ea typeface="+mn-ea"/>
+                <a:cs typeface="+mn-cs"/>
+              </a:rPr>
+              <a:t>, vol. 57, no. 37, Sep. 2024, </a:t>
+            </a:r>
+            <a:r>
+              <a:rPr kumimoji="0" lang="en-US" sz="1200" b="0" i="0" u="none" strike="noStrike" kern="1200" cap="none" spc="0" normalizeH="0" baseline="0" noProof="0" dirty="0" err="1">
+                <a:ln>
+                  <a:noFill/>
+                </a:ln>
+                <a:solidFill>
+                  <a:prstClr val="white"/>
+                </a:solidFill>
+                <a:effectLst/>
+                <a:uLnTx/>
+                <a:uFillTx/>
+                <a:latin typeface="Aptos" panose="02110004020202020204"/>
+                <a:ea typeface="+mn-ea"/>
+                <a:cs typeface="+mn-cs"/>
+              </a:rPr>
+              <a:t>doi</a:t>
+            </a:r>
+            <a:r>
+              <a:rPr kumimoji="0" lang="en-US" sz="1200" b="0" i="0" u="none" strike="noStrike" kern="1200" cap="none" spc="0" normalizeH="0" baseline="0" noProof="0" dirty="0">
+                <a:ln>
+                  <a:noFill/>
+                </a:ln>
+                <a:solidFill>
+                  <a:prstClr val="white"/>
+                </a:solidFill>
+                <a:effectLst/>
+                <a:uLnTx/>
+                <a:uFillTx/>
+                <a:latin typeface="Aptos" panose="02110004020202020204"/>
+                <a:ea typeface="+mn-ea"/>
+                <a:cs typeface="+mn-cs"/>
+              </a:rPr>
+              <a:t>: 10.1088/1361-6463/ad5569.</a:t>
+            </a:r>
+          </a:p>
+          <a:p>
+            <a:pPr marL="0" marR="0" lvl="0" indent="0" algn="l" defTabSz="457200" rtl="0" eaLnBrk="1" fontAlgn="auto" latinLnBrk="0" hangingPunct="1">
+              <a:lnSpc>
+                <a:spcPct val="100000"/>
+              </a:lnSpc>
+              <a:spcBef>
+                <a:spcPts val="0"/>
+              </a:spcBef>
+              <a:spcAft>
+                <a:spcPts val="0"/>
+              </a:spcAft>
+              <a:buClrTx/>
+              <a:buSzTx/>
+              <a:buFontTx/>
+              <a:buNone/>
+              <a:tabLst/>
+              <a:defRPr/>
+            </a:pPr>
+            <a:r>
+              <a:rPr kumimoji="0" lang="en-US" sz="1200" b="0" i="0" u="none" strike="noStrike" kern="1200" cap="none" spc="0" normalizeH="0" baseline="0" noProof="0" dirty="0">
+                <a:ln>
+                  <a:noFill/>
+                </a:ln>
+                <a:solidFill>
+                  <a:prstClr val="white"/>
+                </a:solidFill>
+                <a:effectLst/>
+                <a:uLnTx/>
+                <a:uFillTx/>
+                <a:latin typeface="Aptos" panose="02110004020202020204"/>
+                <a:ea typeface="+mn-ea"/>
+                <a:cs typeface="+mn-cs"/>
+              </a:rPr>
+              <a:t>[2]	P. Paris, M. </a:t>
+            </a:r>
+            <a:r>
+              <a:rPr kumimoji="0" lang="en-US" sz="1200" b="0" i="0" u="none" strike="noStrike" kern="1200" cap="none" spc="0" normalizeH="0" baseline="0" noProof="0" dirty="0" err="1">
+                <a:ln>
+                  <a:noFill/>
+                </a:ln>
+                <a:solidFill>
+                  <a:prstClr val="white"/>
+                </a:solidFill>
+                <a:effectLst/>
+                <a:uLnTx/>
+                <a:uFillTx/>
+                <a:latin typeface="Aptos" panose="02110004020202020204"/>
+                <a:ea typeface="+mn-ea"/>
+                <a:cs typeface="+mn-cs"/>
+              </a:rPr>
+              <a:t>Aints</a:t>
+            </a:r>
+            <a:r>
+              <a:rPr kumimoji="0" lang="en-US" sz="1200" b="0" i="0" u="none" strike="noStrike" kern="1200" cap="none" spc="0" normalizeH="0" baseline="0" noProof="0" dirty="0">
+                <a:ln>
+                  <a:noFill/>
+                </a:ln>
+                <a:solidFill>
+                  <a:prstClr val="white"/>
+                </a:solidFill>
+                <a:effectLst/>
+                <a:uLnTx/>
+                <a:uFillTx/>
+                <a:latin typeface="Aptos" panose="02110004020202020204"/>
+                <a:ea typeface="+mn-ea"/>
+                <a:cs typeface="+mn-cs"/>
+              </a:rPr>
+              <a:t>, F. Valk, T. Plank, A. </a:t>
+            </a:r>
+            <a:r>
+              <a:rPr kumimoji="0" lang="en-US" sz="1200" b="0" i="0" u="none" strike="noStrike" kern="1200" cap="none" spc="0" normalizeH="0" baseline="0" noProof="0" dirty="0" err="1">
+                <a:ln>
+                  <a:noFill/>
+                </a:ln>
+                <a:solidFill>
+                  <a:prstClr val="white"/>
+                </a:solidFill>
+                <a:effectLst/>
+                <a:uLnTx/>
+                <a:uFillTx/>
+                <a:latin typeface="Aptos" panose="02110004020202020204"/>
+                <a:ea typeface="+mn-ea"/>
+                <a:cs typeface="+mn-cs"/>
+              </a:rPr>
+              <a:t>Haljaste</a:t>
+            </a:r>
+            <a:r>
+              <a:rPr kumimoji="0" lang="en-US" sz="1200" b="0" i="0" u="none" strike="noStrike" kern="1200" cap="none" spc="0" normalizeH="0" baseline="0" noProof="0" dirty="0">
+                <a:ln>
+                  <a:noFill/>
+                </a:ln>
+                <a:solidFill>
+                  <a:prstClr val="white"/>
+                </a:solidFill>
+                <a:effectLst/>
+                <a:uLnTx/>
+                <a:uFillTx/>
+                <a:latin typeface="Aptos" panose="02110004020202020204"/>
+                <a:ea typeface="+mn-ea"/>
+                <a:cs typeface="+mn-cs"/>
+              </a:rPr>
+              <a:t>, K. V. Kozlov, and H.-E. Wagner, "Intensity ratio of spectral bands of nitrogen as a measure of electric field strength in plasmas," J. Phys. D: Appl. Phys., vol. 38, no. 21, pp. 3894–3899, 2005, </a:t>
+            </a:r>
+            <a:r>
+              <a:rPr kumimoji="0" lang="en-US" sz="1200" b="0" i="0" u="none" strike="noStrike" kern="1200" cap="none" spc="0" normalizeH="0" baseline="0" noProof="0" dirty="0" err="1">
+                <a:ln>
+                  <a:noFill/>
+                </a:ln>
+                <a:solidFill>
+                  <a:prstClr val="white"/>
+                </a:solidFill>
+                <a:effectLst/>
+                <a:uLnTx/>
+                <a:uFillTx/>
+                <a:latin typeface="Aptos" panose="02110004020202020204"/>
+                <a:ea typeface="+mn-ea"/>
+                <a:cs typeface="+mn-cs"/>
+              </a:rPr>
+              <a:t>doi</a:t>
+            </a:r>
+            <a:r>
+              <a:rPr kumimoji="0" lang="en-US" sz="1200" b="0" i="0" u="none" strike="noStrike" kern="1200" cap="none" spc="0" normalizeH="0" baseline="0" noProof="0" dirty="0">
+                <a:ln>
+                  <a:noFill/>
+                </a:ln>
+                <a:solidFill>
+                  <a:prstClr val="white"/>
+                </a:solidFill>
+                <a:effectLst/>
+                <a:uLnTx/>
+                <a:uFillTx/>
+                <a:latin typeface="Aptos" panose="02110004020202020204"/>
+                <a:ea typeface="+mn-ea"/>
+                <a:cs typeface="+mn-cs"/>
+              </a:rPr>
+              <a:t>: 10.1088/0022-3727/38/21/010.</a:t>
+            </a:r>
+          </a:p>
+          <a:p>
+            <a:pPr marL="0" marR="0" lvl="0" indent="0" algn="l" defTabSz="457200" rtl="0" eaLnBrk="1" fontAlgn="auto" latinLnBrk="0" hangingPunct="1">
+              <a:lnSpc>
+                <a:spcPct val="100000"/>
+              </a:lnSpc>
+              <a:spcBef>
+                <a:spcPts val="0"/>
+              </a:spcBef>
+              <a:spcAft>
+                <a:spcPts val="0"/>
+              </a:spcAft>
+              <a:buClrTx/>
+              <a:buSzTx/>
+              <a:buFontTx/>
+              <a:buNone/>
+              <a:tabLst/>
+              <a:defRPr/>
+            </a:pPr>
+            <a:r>
+              <a:rPr kumimoji="0" lang="en-US" sz="1200" b="0" i="0" u="none" strike="noStrike" kern="1200" cap="none" spc="0" normalizeH="0" baseline="0" noProof="0" dirty="0">
+                <a:ln>
+                  <a:noFill/>
+                </a:ln>
+                <a:solidFill>
+                  <a:prstClr val="white"/>
+                </a:solidFill>
+                <a:effectLst/>
+                <a:uLnTx/>
+                <a:uFillTx/>
+                <a:latin typeface="Aptos" panose="02110004020202020204"/>
+                <a:ea typeface="+mn-ea"/>
+                <a:cs typeface="+mn-cs"/>
+              </a:rPr>
+              <a:t>[3]	H. R. Griem, Principles of Plasma Spectroscopy. Cambridge, U.K.: Cambridge University Press, 1997, </a:t>
+            </a:r>
+            <a:r>
+              <a:rPr kumimoji="0" lang="en-US" sz="1200" b="0" i="0" u="none" strike="noStrike" kern="1200" cap="none" spc="0" normalizeH="0" baseline="0" noProof="0" dirty="0" err="1">
+                <a:ln>
+                  <a:noFill/>
+                </a:ln>
+                <a:solidFill>
+                  <a:prstClr val="white"/>
+                </a:solidFill>
+                <a:effectLst/>
+                <a:uLnTx/>
+                <a:uFillTx/>
+                <a:latin typeface="Aptos" panose="02110004020202020204"/>
+                <a:ea typeface="+mn-ea"/>
+                <a:cs typeface="+mn-cs"/>
+              </a:rPr>
+              <a:t>ch.</a:t>
+            </a:r>
+            <a:r>
+              <a:rPr kumimoji="0" lang="en-US" sz="1200" b="0" i="0" u="none" strike="noStrike" kern="1200" cap="none" spc="0" normalizeH="0" baseline="0" noProof="0" dirty="0">
+                <a:ln>
+                  <a:noFill/>
+                </a:ln>
+                <a:solidFill>
+                  <a:prstClr val="white"/>
+                </a:solidFill>
+                <a:effectLst/>
+                <a:uLnTx/>
+                <a:uFillTx/>
+                <a:latin typeface="Aptos" panose="02110004020202020204"/>
+                <a:ea typeface="+mn-ea"/>
+                <a:cs typeface="+mn-cs"/>
+              </a:rPr>
+              <a:t> 7.</a:t>
+            </a:r>
+          </a:p>
+          <a:p>
+            <a:endParaRPr lang="en-CN" dirty="0"/>
+          </a:p>
+        </p:txBody>
+      </p:sp>
     </p:spTree>
     <p:extLst>
       <p:ext uri="{BB962C8B-B14F-4D97-AF65-F5344CB8AC3E}">

</xml_diff>

<commit_message>
Update presentation files and add new poster document
</commit_message>
<xml_diff>
--- a/bench inspection poster/Presentation2.pptx
+++ b/bench inspection poster/Presentation2.pptx
@@ -4174,9 +4174,7 @@
               <a:avLst/>
             </a:prstGeom>
             <a:solidFill>
-              <a:schemeClr val="accent1">
-                <a:lumMod val="75000"/>
-              </a:schemeClr>
+              <a:srgbClr val="355F93"/>
             </a:solidFill>
           </p:spPr>
           <p:style>
@@ -4203,10 +4201,7 @@
               <a:r>
                 <a:rPr lang="en-US" sz="5400" b="1" dirty="0">
                   <a:solidFill>
-                    <a:schemeClr val="accent3">
-                      <a:lumMod val="20000"/>
-                      <a:lumOff val="80000"/>
-                    </a:schemeClr>
+                    <a:schemeClr val="bg1"/>
                   </a:solidFill>
                 </a:rPr>
                 <a:t>Results</a:t>
@@ -4577,9 +4572,7 @@
               <a:avLst/>
             </a:prstGeom>
             <a:solidFill>
-              <a:schemeClr val="accent1">
-                <a:lumMod val="75000"/>
-              </a:schemeClr>
+              <a:srgbClr val="355F93"/>
             </a:solidFill>
           </p:spPr>
           <p:style>
@@ -4602,14 +4595,15 @@
             <a:bodyPr lIns="86970" tIns="43485" rIns="86970" bIns="43485" rtlCol="0" anchor="ctr"/>
             <a:lstStyle/>
             <a:p>
-              <a:pPr algn="ctr"/>
+              <a:pPr algn="ctr">
+                <a:tabLst>
+                  <a:tab pos="5146675" algn="l"/>
+                </a:tabLst>
+              </a:pPr>
               <a:r>
                 <a:rPr lang="en-US" sz="5400" b="1" dirty="0">
                   <a:solidFill>
-                    <a:schemeClr val="accent3">
-                      <a:lumMod val="20000"/>
-                      <a:lumOff val="80000"/>
-                    </a:schemeClr>
+                    <a:schemeClr val="bg1"/>
                   </a:solidFill>
                 </a:rPr>
                 <a:t>Introduction</a:t>
@@ -4885,9 +4879,7 @@
               <a:avLst/>
             </a:prstGeom>
             <a:solidFill>
-              <a:schemeClr val="accent1">
-                <a:lumMod val="75000"/>
-              </a:schemeClr>
+              <a:srgbClr val="355F93"/>
             </a:solidFill>
           </p:spPr>
           <p:style>
@@ -4914,10 +4906,7 @@
               <a:r>
                 <a:rPr lang="en-US" sz="5400" b="1" dirty="0">
                   <a:solidFill>
-                    <a:schemeClr val="accent3">
-                      <a:lumMod val="20000"/>
-                      <a:lumOff val="80000"/>
-                    </a:schemeClr>
+                    <a:schemeClr val="bg1"/>
                   </a:solidFill>
                 </a:rPr>
                 <a:t>Conclusion</a:t>
@@ -5377,9 +5366,7 @@
               <a:avLst/>
             </a:prstGeom>
             <a:solidFill>
-              <a:schemeClr val="accent1">
-                <a:lumMod val="75000"/>
-              </a:schemeClr>
+              <a:srgbClr val="355F93"/>
             </a:solidFill>
           </p:spPr>
           <p:style>
@@ -5406,10 +5393,7 @@
               <a:r>
                 <a:rPr lang="en-US" sz="5400" b="1" dirty="0">
                   <a:solidFill>
-                    <a:schemeClr val="accent3">
-                      <a:lumMod val="20000"/>
-                      <a:lumOff val="80000"/>
-                    </a:schemeClr>
+                    <a:schemeClr val="bg1"/>
                   </a:solidFill>
                 </a:rPr>
                 <a:t>Methodology</a:t>

</xml_diff>